<commit_message>
📊 PPTX enrichis: 20 modules avec 7-13 slides chacun, exemples SwissSound, speaker notes détaillées
</commit_message>
<xml_diff>
--- a/pptx/Module15_Vues_procédures_fonctions.pptx
+++ b/pptx/Module15_Vues_procédures_fonctions.pptx
@@ -596,7 +596,7 @@
           <a:p>
             <a:r>
               <a:rPr lang="en-US" dirty="0"/>
-              <a:t/>
+              <a:t>Les vues sont un outil de sécurité puissant : donner accès à la vue sans accès à la table source.</a:t>
             </a:r>
             <a:endParaRPr lang="en-US" dirty="0"/>
           </a:p>
@@ -684,7 +684,7 @@
           <a:p>
             <a:r>
               <a:rPr lang="en-US" dirty="0"/>
-              <a:t/>
+              <a:t>Le DELIMITER est nécessaire car la procédure contient des ; internes.</a:t>
             </a:r>
             <a:endParaRPr lang="en-US" dirty="0"/>
           </a:p>
@@ -772,7 +772,7 @@
           <a:p>
             <a:r>
               <a:rPr lang="en-US" dirty="0"/>
-              <a:t/>
+              <a:t>Fonctions = réutilisables dans des SELECT. Triggers = automatisation sans intervention.</a:t>
             </a:r>
             <a:endParaRPr lang="en-US" dirty="0"/>
           </a:p>
@@ -860,7 +860,7 @@
           <a:p>
             <a:r>
               <a:rPr lang="en-US" dirty="0"/>
-              <a:t/>
+              <a:t>Module technique important pour M2 (système complet avec sécurité et maintenance).</a:t>
             </a:r>
             <a:endParaRPr lang="en-US" dirty="0"/>
           </a:p>
@@ -1445,7 +1445,7 @@
         </p:blipFill>
         <p:spPr>
           <a:xfrm>
-            <a:off x="3931920" y="457200"/>
+            <a:off x="3931920" y="365760"/>
             <a:ext cx="1280160" cy="1280160"/>
           </a:xfrm>
           <a:prstGeom prst="rect">
@@ -1461,7 +1461,7 @@
         </p:nvSpPr>
         <p:spPr>
           <a:xfrm>
-            <a:off x="457200" y="1828800"/>
+            <a:off x="457200" y="1737360"/>
             <a:ext cx="8229600" cy="457200"/>
           </a:xfrm>
           <a:prstGeom prst="rect">
@@ -1500,8 +1500,8 @@
         </p:nvSpPr>
         <p:spPr>
           <a:xfrm>
-            <a:off x="457200" y="2286000"/>
-            <a:ext cx="8229600" cy="822960"/>
+            <a:off x="274320" y="2194560"/>
+            <a:ext cx="8595360" cy="822960"/>
           </a:xfrm>
           <a:prstGeom prst="rect">
             <a:avLst/>
@@ -1517,7 +1517,7 @@
               <a:buNone/>
             </a:pPr>
             <a:r>
-              <a:rPr lang="en-US" sz="3400" b="1" dirty="0">
+              <a:rPr lang="en-US" sz="3200" b="1" dirty="0">
                 <a:solidFill>
                   <a:srgbClr val="FFFFFF"/>
                 </a:solidFill>
@@ -1525,9 +1525,9 @@
                 <a:ea typeface="Trebuchet MS" pitchFamily="34" charset="-122"/>
                 <a:cs typeface="Trebuchet MS" pitchFamily="34" charset="-120"/>
               </a:rPr>
-              <a:t>Vues, procédures, fonctions</a:t>
-            </a:r>
-            <a:endParaRPr lang="en-US" sz="3400" dirty="0"/>
+              <a:t>Vues procédures fonctions</a:t>
+            </a:r>
+            <a:endParaRPr lang="en-US" sz="3200" dirty="0"/>
           </a:p>
         </p:txBody>
       </p:sp>
@@ -1539,7 +1539,7 @@
         </p:nvSpPr>
         <p:spPr>
           <a:xfrm>
-            <a:off x="457200" y="3108960"/>
+            <a:off x="457200" y="3017520"/>
             <a:ext cx="8229600" cy="457200"/>
           </a:xfrm>
           <a:prstGeom prst="rect">
@@ -1556,7 +1556,7 @@
               <a:buNone/>
             </a:pPr>
             <a:r>
-              <a:rPr lang="en-US" sz="1600" dirty="0">
+              <a:rPr lang="en-US" sz="1500" dirty="0">
                 <a:solidFill>
                   <a:srgbClr val="CCCCCC"/>
                 </a:solidFill>
@@ -1564,9 +1564,9 @@
                 <a:ea typeface="Calibri" pitchFamily="34" charset="-122"/>
                 <a:cs typeface="Calibri" pitchFamily="34" charset="-120"/>
               </a:rPr>
-              <a:t>CREATE VIEW, PROCEDURE, FUNCTION, triggers</a:t>
-            </a:r>
-            <a:endParaRPr lang="en-US" sz="1600" dirty="0"/>
+              <a:t>CREATE VIEW · PROCEDURE · FUNCTION · Triggers</a:t>
+            </a:r>
+            <a:endParaRPr lang="en-US" sz="1500" dirty="0"/>
           </a:p>
         </p:txBody>
       </p:sp>
@@ -1597,54 +1597,15 @@
             <a:r>
               <a:rPr lang="en-US" sz="1100" dirty="0">
                 <a:solidFill>
-                  <a:srgbClr val="AAAACC"/>
+                  <a:srgbClr val="AA99CC"/>
                 </a:solidFill>
                 <a:latin typeface="Calibri" pitchFamily="34" charset="0"/>
                 <a:ea typeface="Calibri" pitchFamily="34" charset="-122"/>
                 <a:cs typeface="Calibri" pitchFamily="34" charset="-120"/>
               </a:rPr>
-              <a:t>Unit 4 — Database Design &amp; Development | SwissSound Studios</a:t>
+              <a:t>SwissSound Studios | BTEC: P3 M2 | LO2</a:t>
             </a:r>
             <a:endParaRPr lang="en-US" sz="1100" dirty="0"/>
-          </a:p>
-        </p:txBody>
-      </p:sp>
-      <p:sp>
-        <p:nvSpPr>
-          <p:cNvPr id="8" name="Text 5"/>
-          <p:cNvSpPr/>
-          <p:nvPr/>
-        </p:nvSpPr>
-        <p:spPr>
-          <a:xfrm>
-            <a:off x="457200" y="4434840"/>
-            <a:ext cx="8229600" cy="274320"/>
-          </a:xfrm>
-          <a:prstGeom prst="rect">
-            <a:avLst/>
-          </a:prstGeom>
-          <a:noFill/>
-          <a:ln/>
-        </p:spPr>
-        <p:txBody>
-          <a:bodyPr wrap="square" lIns="0" tIns="0" rIns="0" bIns="0" rtlCol="0" anchor="ctr"/>
-          <a:lstStyle/>
-          <a:p>
-            <a:pPr algn="ctr" indent="0" marL="0">
-              <a:buNone/>
-            </a:pPr>
-            <a:r>
-              <a:rPr lang="en-US" sz="1000" dirty="0">
-                <a:solidFill>
-                  <a:srgbClr val="8888AA"/>
-                </a:solidFill>
-                <a:latin typeface="Calibri" pitchFamily="34" charset="0"/>
-                <a:ea typeface="Calibri" pitchFamily="34" charset="-122"/>
-                <a:cs typeface="Calibri" pitchFamily="34" charset="-120"/>
-              </a:rPr>
-              <a:t>BTEC : P3 M2 | LO2</a:t>
-            </a:r>
-            <a:endParaRPr lang="en-US" sz="1000" dirty="0"/>
           </a:p>
         </p:txBody>
       </p:sp>
@@ -1689,7 +1650,7 @@
         <p:spPr>
           <a:xfrm>
             <a:off x="0" y="0"/>
-            <a:ext cx="9144000" cy="73152"/>
+            <a:ext cx="9144000" cy="54864"/>
           </a:xfrm>
           <a:prstGeom prst="rect">
             <a:avLst/>
@@ -1708,8 +1669,8 @@
         </p:nvSpPr>
         <p:spPr>
           <a:xfrm>
-            <a:off x="457200" y="228600"/>
-            <a:ext cx="8229600" cy="640080"/>
+            <a:off x="457200" y="182880"/>
+            <a:ext cx="8229600" cy="594360"/>
           </a:xfrm>
           <a:prstGeom prst="rect">
             <a:avLst/>
@@ -1725,7 +1686,7 @@
               <a:buNone/>
             </a:pPr>
             <a:r>
-              <a:rPr lang="en-US" sz="2600" b="1" dirty="0">
+              <a:rPr lang="en-US" sz="2400" b="1" dirty="0">
                 <a:solidFill>
                   <a:srgbClr val="0D47A1"/>
                 </a:solidFill>
@@ -1733,9 +1694,9 @@
                 <a:ea typeface="Trebuchet MS" pitchFamily="34" charset="-122"/>
                 <a:cs typeface="Trebuchet MS" pitchFamily="34" charset="-120"/>
               </a:rPr>
-              <a:t>Vues (VIEW)</a:t>
-            </a:r>
-            <a:endParaRPr lang="en-US" sz="2600" dirty="0"/>
+              <a:t>Vues : tables virtuelles</a:t>
+            </a:r>
+            <a:endParaRPr lang="en-US" sz="2400" dirty="0"/>
           </a:p>
         </p:txBody>
       </p:sp>
@@ -1747,8 +1708,8 @@
         </p:nvSpPr>
         <p:spPr>
           <a:xfrm>
-            <a:off x="457200" y="1051560"/>
-            <a:ext cx="8229600" cy="640080"/>
+            <a:off x="457200" y="914400"/>
+            <a:ext cx="8229600" cy="521208"/>
           </a:xfrm>
           <a:prstGeom prst="rect">
             <a:avLst/>
@@ -1774,8 +1735,8 @@
         </p:nvSpPr>
         <p:spPr>
           <a:xfrm>
-            <a:off x="457200" y="1051560"/>
-            <a:ext cx="54864" cy="640080"/>
+            <a:off x="457200" y="914400"/>
+            <a:ext cx="45720" cy="521208"/>
           </a:xfrm>
           <a:prstGeom prst="rect">
             <a:avLst/>
@@ -1794,8 +1755,8 @@
         </p:nvSpPr>
         <p:spPr>
           <a:xfrm>
-            <a:off x="731520" y="1051560"/>
-            <a:ext cx="7772400" cy="640080"/>
+            <a:off x="685800" y="914400"/>
+            <a:ext cx="7818120" cy="521208"/>
           </a:xfrm>
           <a:prstGeom prst="rect">
             <a:avLst/>
@@ -1811,7 +1772,7 @@
               <a:buNone/>
             </a:pPr>
             <a:r>
-              <a:rPr lang="en-US" sz="1100" dirty="0">
+              <a:rPr lang="en-US" sz="1000" dirty="0">
                 <a:solidFill>
                   <a:srgbClr val="0D47A1"/>
                 </a:solidFill>
@@ -1819,9 +1780,9 @@
                 <a:ea typeface="JetBrains Mono" pitchFamily="34" charset="-122"/>
                 <a:cs typeface="JetBrains Mono" pitchFamily="34" charset="-120"/>
               </a:rPr>
-              <a:t>CREATE VIEW v_artistes_actifs AS SELECT ... WHERE actif = TRUE;</a:t>
-            </a:r>
-            <a:endParaRPr lang="en-US" sz="1100" dirty="0"/>
+              <a:t>CREATE VIEW v_artistes_actifs AS SELECT * FROM artiste WHERE actif = TRUE;</a:t>
+            </a:r>
+            <a:endParaRPr lang="en-US" sz="1000" dirty="0"/>
           </a:p>
         </p:txBody>
       </p:sp>
@@ -1833,8 +1794,8 @@
         </p:nvSpPr>
         <p:spPr>
           <a:xfrm>
-            <a:off x="457200" y="1783080"/>
-            <a:ext cx="8229600" cy="640080"/>
+            <a:off x="457200" y="1463040"/>
+            <a:ext cx="8229600" cy="521208"/>
           </a:xfrm>
           <a:prstGeom prst="rect">
             <a:avLst/>
@@ -1860,8 +1821,8 @@
         </p:nvSpPr>
         <p:spPr>
           <a:xfrm>
-            <a:off x="457200" y="1783080"/>
-            <a:ext cx="54864" cy="640080"/>
+            <a:off x="457200" y="1463040"/>
+            <a:ext cx="45720" cy="521208"/>
           </a:xfrm>
           <a:prstGeom prst="rect">
             <a:avLst/>
@@ -1880,8 +1841,8 @@
         </p:nvSpPr>
         <p:spPr>
           <a:xfrm>
-            <a:off x="731520" y="1783080"/>
-            <a:ext cx="7772400" cy="640080"/>
+            <a:off x="685800" y="1463040"/>
+            <a:ext cx="7818120" cy="521208"/>
           </a:xfrm>
           <a:prstGeom prst="rect">
             <a:avLst/>
@@ -1897,7 +1858,7 @@
               <a:buNone/>
             </a:pPr>
             <a:r>
-              <a:rPr lang="en-US" sz="1300" dirty="0">
+              <a:rPr lang="en-US" sz="1200" dirty="0">
                 <a:solidFill>
                   <a:srgbClr val="1A1A2E"/>
                 </a:solidFill>
@@ -1905,9 +1866,9 @@
                 <a:ea typeface="Calibri" pitchFamily="34" charset="-122"/>
                 <a:cs typeface="Calibri" pitchFamily="34" charset="-120"/>
               </a:rPr>
-              <a:t>Requête enregistrée qui se comporte comme une table virtuelle</a:t>
-            </a:r>
-            <a:endParaRPr lang="en-US" sz="1300" dirty="0"/>
+              <a:t>Utilisation : SELECT * FROM v_artistes_actifs; (comme une table)</a:t>
+            </a:r>
+            <a:endParaRPr lang="en-US" sz="1200" dirty="0"/>
           </a:p>
         </p:txBody>
       </p:sp>
@@ -1919,8 +1880,8 @@
         </p:nvSpPr>
         <p:spPr>
           <a:xfrm>
-            <a:off x="457200" y="2514600"/>
-            <a:ext cx="8229600" cy="640080"/>
+            <a:off x="457200" y="2011680"/>
+            <a:ext cx="8229600" cy="521208"/>
           </a:xfrm>
           <a:prstGeom prst="rect">
             <a:avLst/>
@@ -1946,8 +1907,8 @@
         </p:nvSpPr>
         <p:spPr>
           <a:xfrm>
-            <a:off x="457200" y="2514600"/>
-            <a:ext cx="54864" cy="640080"/>
+            <a:off x="457200" y="2011680"/>
+            <a:ext cx="45720" cy="521208"/>
           </a:xfrm>
           <a:prstGeom prst="rect">
             <a:avLst/>
@@ -1966,8 +1927,8 @@
         </p:nvSpPr>
         <p:spPr>
           <a:xfrm>
-            <a:off x="731520" y="2514600"/>
-            <a:ext cx="7772400" cy="640080"/>
+            <a:off x="685800" y="2011680"/>
+            <a:ext cx="7818120" cy="521208"/>
           </a:xfrm>
           <a:prstGeom prst="rect">
             <a:avLst/>
@@ -1983,7 +1944,351 @@
               <a:buNone/>
             </a:pPr>
             <a:r>
-              <a:rPr lang="en-US" sz="1100" dirty="0">
+              <a:rPr lang="en-US" sz="1200" dirty="0">
+                <a:solidFill>
+                  <a:srgbClr val="1A1A2E"/>
+                </a:solidFill>
+                <a:latin typeface="Calibri" pitchFamily="34" charset="0"/>
+                <a:ea typeface="Calibri" pitchFamily="34" charset="-122"/>
+                <a:cs typeface="Calibri" pitchFamily="34" charset="-120"/>
+              </a:rPr>
+              <a:t>Avantages : simplification (requête complexe → nom simple)</a:t>
+            </a:r>
+            <a:endParaRPr lang="en-US" sz="1200" dirty="0"/>
+          </a:p>
+        </p:txBody>
+      </p:sp>
+      <p:sp>
+        <p:nvSpPr>
+          <p:cNvPr id="13" name="Shape 11"/>
+          <p:cNvSpPr/>
+          <p:nvPr/>
+        </p:nvSpPr>
+        <p:spPr>
+          <a:xfrm>
+            <a:off x="457200" y="2560320"/>
+            <a:ext cx="8229600" cy="521208"/>
+          </a:xfrm>
+          <a:prstGeom prst="rect">
+            <a:avLst/>
+          </a:prstGeom>
+          <a:solidFill>
+            <a:srgbClr val="E3F2FD"/>
+          </a:solidFill>
+          <a:ln/>
+          <a:effectLst>
+            <a:outerShdw sx="100000" sy="100000" kx="0" ky="0" algn="bl" rotWithShape="0" blurRad="50800" dist="25400" dir="8100000">
+              <a:srgbClr val="000000">
+                <a:alpha val="12000"/>
+              </a:srgbClr>
+            </a:outerShdw>
+          </a:effectLst>
+        </p:spPr>
+      </p:sp>
+      <p:sp>
+        <p:nvSpPr>
+          <p:cNvPr id="14" name="Shape 12"/>
+          <p:cNvSpPr/>
+          <p:nvPr/>
+        </p:nvSpPr>
+        <p:spPr>
+          <a:xfrm>
+            <a:off x="457200" y="2560320"/>
+            <a:ext cx="45720" cy="521208"/>
+          </a:xfrm>
+          <a:prstGeom prst="rect">
+            <a:avLst/>
+          </a:prstGeom>
+          <a:solidFill>
+            <a:srgbClr val="1565C0"/>
+          </a:solidFill>
+          <a:ln/>
+        </p:spPr>
+      </p:sp>
+      <p:sp>
+        <p:nvSpPr>
+          <p:cNvPr id="15" name="Text 13"/>
+          <p:cNvSpPr/>
+          <p:nvPr/>
+        </p:nvSpPr>
+        <p:spPr>
+          <a:xfrm>
+            <a:off x="685800" y="2560320"/>
+            <a:ext cx="7818120" cy="521208"/>
+          </a:xfrm>
+          <a:prstGeom prst="rect">
+            <a:avLst/>
+          </a:prstGeom>
+          <a:noFill/>
+          <a:ln/>
+        </p:spPr>
+        <p:txBody>
+          <a:bodyPr wrap="square" lIns="0" tIns="0" rIns="0" bIns="0" rtlCol="0" anchor="ctr"/>
+          <a:lstStyle/>
+          <a:p>
+            <a:pPr indent="0" marL="0">
+              <a:buNone/>
+            </a:pPr>
+            <a:r>
+              <a:rPr lang="en-US" sz="1200" dirty="0">
+                <a:solidFill>
+                  <a:srgbClr val="1A1A2E"/>
+                </a:solidFill>
+                <a:latin typeface="Calibri" pitchFamily="34" charset="0"/>
+                <a:ea typeface="Calibri" pitchFamily="34" charset="-122"/>
+                <a:cs typeface="Calibri" pitchFamily="34" charset="-120"/>
+              </a:rPr>
+              <a:t>Sécurité : masquer des colonnes sensibles aux utilisateurs</a:t>
+            </a:r>
+            <a:endParaRPr lang="en-US" sz="1200" dirty="0"/>
+          </a:p>
+        </p:txBody>
+      </p:sp>
+      <p:sp>
+        <p:nvSpPr>
+          <p:cNvPr id="16" name="Shape 14"/>
+          <p:cNvSpPr/>
+          <p:nvPr/>
+        </p:nvSpPr>
+        <p:spPr>
+          <a:xfrm>
+            <a:off x="457200" y="3108960"/>
+            <a:ext cx="8229600" cy="521208"/>
+          </a:xfrm>
+          <a:prstGeom prst="rect">
+            <a:avLst/>
+          </a:prstGeom>
+          <a:solidFill>
+            <a:srgbClr val="FFFFFF"/>
+          </a:solidFill>
+          <a:ln/>
+          <a:effectLst>
+            <a:outerShdw sx="100000" sy="100000" kx="0" ky="0" algn="bl" rotWithShape="0" blurRad="50800" dist="25400" dir="8100000">
+              <a:srgbClr val="000000">
+                <a:alpha val="12000"/>
+              </a:srgbClr>
+            </a:outerShdw>
+          </a:effectLst>
+        </p:spPr>
+      </p:sp>
+      <p:sp>
+        <p:nvSpPr>
+          <p:cNvPr id="17" name="Shape 15"/>
+          <p:cNvSpPr/>
+          <p:nvPr/>
+        </p:nvSpPr>
+        <p:spPr>
+          <a:xfrm>
+            <a:off x="457200" y="3108960"/>
+            <a:ext cx="45720" cy="521208"/>
+          </a:xfrm>
+          <a:prstGeom prst="rect">
+            <a:avLst/>
+          </a:prstGeom>
+          <a:solidFill>
+            <a:srgbClr val="1565C0"/>
+          </a:solidFill>
+          <a:ln/>
+        </p:spPr>
+      </p:sp>
+      <p:sp>
+        <p:nvSpPr>
+          <p:cNvPr id="18" name="Text 16"/>
+          <p:cNvSpPr/>
+          <p:nvPr/>
+        </p:nvSpPr>
+        <p:spPr>
+          <a:xfrm>
+            <a:off x="685800" y="3108960"/>
+            <a:ext cx="7818120" cy="521208"/>
+          </a:xfrm>
+          <a:prstGeom prst="rect">
+            <a:avLst/>
+          </a:prstGeom>
+          <a:noFill/>
+          <a:ln/>
+        </p:spPr>
+        <p:txBody>
+          <a:bodyPr wrap="square" lIns="0" tIns="0" rIns="0" bIns="0" rtlCol="0" anchor="ctr"/>
+          <a:lstStyle/>
+          <a:p>
+            <a:pPr indent="0" marL="0">
+              <a:buNone/>
+            </a:pPr>
+            <a:r>
+              <a:rPr lang="en-US" sz="1200" dirty="0">
+                <a:solidFill>
+                  <a:srgbClr val="1A1A2E"/>
+                </a:solidFill>
+                <a:latin typeface="Calibri" pitchFamily="34" charset="0"/>
+                <a:ea typeface="Calibri" pitchFamily="34" charset="-122"/>
+                <a:cs typeface="Calibri" pitchFamily="34" charset="-120"/>
+              </a:rPr>
+              <a:t>Abstraction : changer la requête sans modifier le code client</a:t>
+            </a:r>
+            <a:endParaRPr lang="en-US" sz="1200" dirty="0"/>
+          </a:p>
+        </p:txBody>
+      </p:sp>
+      <p:sp>
+        <p:nvSpPr>
+          <p:cNvPr id="19" name="Shape 17"/>
+          <p:cNvSpPr/>
+          <p:nvPr/>
+        </p:nvSpPr>
+        <p:spPr>
+          <a:xfrm>
+            <a:off x="457200" y="3657600"/>
+            <a:ext cx="8229600" cy="521208"/>
+          </a:xfrm>
+          <a:prstGeom prst="rect">
+            <a:avLst/>
+          </a:prstGeom>
+          <a:solidFill>
+            <a:srgbClr val="E3F2FD"/>
+          </a:solidFill>
+          <a:ln/>
+          <a:effectLst>
+            <a:outerShdw sx="100000" sy="100000" kx="0" ky="0" algn="bl" rotWithShape="0" blurRad="50800" dist="25400" dir="8100000">
+              <a:srgbClr val="000000">
+                <a:alpha val="12000"/>
+              </a:srgbClr>
+            </a:outerShdw>
+          </a:effectLst>
+        </p:spPr>
+      </p:sp>
+      <p:sp>
+        <p:nvSpPr>
+          <p:cNvPr id="20" name="Shape 18"/>
+          <p:cNvSpPr/>
+          <p:nvPr/>
+        </p:nvSpPr>
+        <p:spPr>
+          <a:xfrm>
+            <a:off x="457200" y="3657600"/>
+            <a:ext cx="45720" cy="521208"/>
+          </a:xfrm>
+          <a:prstGeom prst="rect">
+            <a:avLst/>
+          </a:prstGeom>
+          <a:solidFill>
+            <a:srgbClr val="1565C0"/>
+          </a:solidFill>
+          <a:ln/>
+        </p:spPr>
+      </p:sp>
+      <p:sp>
+        <p:nvSpPr>
+          <p:cNvPr id="21" name="Text 19"/>
+          <p:cNvSpPr/>
+          <p:nvPr/>
+        </p:nvSpPr>
+        <p:spPr>
+          <a:xfrm>
+            <a:off x="685800" y="3657600"/>
+            <a:ext cx="7818120" cy="521208"/>
+          </a:xfrm>
+          <a:prstGeom prst="rect">
+            <a:avLst/>
+          </a:prstGeom>
+          <a:noFill/>
+          <a:ln/>
+        </p:spPr>
+        <p:txBody>
+          <a:bodyPr wrap="square" lIns="0" tIns="0" rIns="0" bIns="0" rtlCol="0" anchor="ctr"/>
+          <a:lstStyle/>
+          <a:p>
+            <a:pPr indent="0" marL="0">
+              <a:buNone/>
+            </a:pPr>
+            <a:r>
+              <a:rPr lang="en-US" sz="1200" dirty="0">
+                <a:solidFill>
+                  <a:srgbClr val="1A1A2E"/>
+                </a:solidFill>
+                <a:latin typeface="Calibri" pitchFamily="34" charset="0"/>
+                <a:ea typeface="Calibri" pitchFamily="34" charset="-122"/>
+                <a:cs typeface="Calibri" pitchFamily="34" charset="-120"/>
+              </a:rPr>
+              <a:t>Pas de stockage physique → recalculée à chaque appel</a:t>
+            </a:r>
+            <a:endParaRPr lang="en-US" sz="1200" dirty="0"/>
+          </a:p>
+        </p:txBody>
+      </p:sp>
+      <p:sp>
+        <p:nvSpPr>
+          <p:cNvPr id="22" name="Shape 20"/>
+          <p:cNvSpPr/>
+          <p:nvPr/>
+        </p:nvSpPr>
+        <p:spPr>
+          <a:xfrm>
+            <a:off x="457200" y="4206240"/>
+            <a:ext cx="8229600" cy="521208"/>
+          </a:xfrm>
+          <a:prstGeom prst="rect">
+            <a:avLst/>
+          </a:prstGeom>
+          <a:solidFill>
+            <a:srgbClr val="FFFFFF"/>
+          </a:solidFill>
+          <a:ln/>
+          <a:effectLst>
+            <a:outerShdw sx="100000" sy="100000" kx="0" ky="0" algn="bl" rotWithShape="0" blurRad="50800" dist="25400" dir="8100000">
+              <a:srgbClr val="000000">
+                <a:alpha val="12000"/>
+              </a:srgbClr>
+            </a:outerShdw>
+          </a:effectLst>
+        </p:spPr>
+      </p:sp>
+      <p:sp>
+        <p:nvSpPr>
+          <p:cNvPr id="23" name="Shape 21"/>
+          <p:cNvSpPr/>
+          <p:nvPr/>
+        </p:nvSpPr>
+        <p:spPr>
+          <a:xfrm>
+            <a:off x="457200" y="4206240"/>
+            <a:ext cx="45720" cy="521208"/>
+          </a:xfrm>
+          <a:prstGeom prst="rect">
+            <a:avLst/>
+          </a:prstGeom>
+          <a:solidFill>
+            <a:srgbClr val="1565C0"/>
+          </a:solidFill>
+          <a:ln/>
+        </p:spPr>
+      </p:sp>
+      <p:sp>
+        <p:nvSpPr>
+          <p:cNvPr id="24" name="Text 22"/>
+          <p:cNvSpPr/>
+          <p:nvPr/>
+        </p:nvSpPr>
+        <p:spPr>
+          <a:xfrm>
+            <a:off x="685800" y="4206240"/>
+            <a:ext cx="7818120" cy="521208"/>
+          </a:xfrm>
+          <a:prstGeom prst="rect">
+            <a:avLst/>
+          </a:prstGeom>
+          <a:noFill/>
+          <a:ln/>
+        </p:spPr>
+        <p:txBody>
+          <a:bodyPr wrap="square" lIns="0" tIns="0" rIns="0" bIns="0" rtlCol="0" anchor="ctr"/>
+          <a:lstStyle/>
+          <a:p>
+            <a:pPr indent="0" marL="0">
+              <a:buNone/>
+            </a:pPr>
+            <a:r>
+              <a:rPr lang="en-US" sz="1000" dirty="0">
                 <a:solidFill>
                   <a:srgbClr val="0D47A1"/>
                 </a:solidFill>
@@ -1991,220 +2296,9 @@
                 <a:ea typeface="JetBrains Mono" pitchFamily="34" charset="-122"/>
                 <a:cs typeface="JetBrains Mono" pitchFamily="34" charset="-120"/>
               </a:rPr>
-              <a:t>SELECT * FROM v_artistes_actifs; (utilisation simple)</a:t>
-            </a:r>
-            <a:endParaRPr lang="en-US" sz="1100" dirty="0"/>
-          </a:p>
-        </p:txBody>
-      </p:sp>
-      <p:sp>
-        <p:nvSpPr>
-          <p:cNvPr id="13" name="Shape 11"/>
-          <p:cNvSpPr/>
-          <p:nvPr/>
-        </p:nvSpPr>
-        <p:spPr>
-          <a:xfrm>
-            <a:off x="457200" y="3246120"/>
-            <a:ext cx="8229600" cy="640080"/>
-          </a:xfrm>
-          <a:prstGeom prst="rect">
-            <a:avLst/>
-          </a:prstGeom>
-          <a:solidFill>
-            <a:srgbClr val="E3F2FD"/>
-          </a:solidFill>
-          <a:ln/>
-          <a:effectLst>
-            <a:outerShdw sx="100000" sy="100000" kx="0" ky="0" algn="bl" rotWithShape="0" blurRad="50800" dist="25400" dir="8100000">
-              <a:srgbClr val="000000">
-                <a:alpha val="12000"/>
-              </a:srgbClr>
-            </a:outerShdw>
-          </a:effectLst>
-        </p:spPr>
-      </p:sp>
-      <p:sp>
-        <p:nvSpPr>
-          <p:cNvPr id="14" name="Shape 12"/>
-          <p:cNvSpPr/>
-          <p:nvPr/>
-        </p:nvSpPr>
-        <p:spPr>
-          <a:xfrm>
-            <a:off x="457200" y="3246120"/>
-            <a:ext cx="54864" cy="640080"/>
-          </a:xfrm>
-          <a:prstGeom prst="rect">
-            <a:avLst/>
-          </a:prstGeom>
-          <a:solidFill>
-            <a:srgbClr val="1565C0"/>
-          </a:solidFill>
-          <a:ln/>
-        </p:spPr>
-      </p:sp>
-      <p:sp>
-        <p:nvSpPr>
-          <p:cNvPr id="15" name="Text 13"/>
-          <p:cNvSpPr/>
-          <p:nvPr/>
-        </p:nvSpPr>
-        <p:spPr>
-          <a:xfrm>
-            <a:off x="731520" y="3246120"/>
-            <a:ext cx="7772400" cy="640080"/>
-          </a:xfrm>
-          <a:prstGeom prst="rect">
-            <a:avLst/>
-          </a:prstGeom>
-          <a:noFill/>
-          <a:ln/>
-        </p:spPr>
-        <p:txBody>
-          <a:bodyPr wrap="square" lIns="0" tIns="0" rIns="0" bIns="0" rtlCol="0" anchor="ctr"/>
-          <a:lstStyle/>
-          <a:p>
-            <a:pPr indent="0" marL="0">
-              <a:buNone/>
-            </a:pPr>
-            <a:r>
-              <a:rPr lang="en-US" sz="1300" dirty="0">
-                <a:solidFill>
-                  <a:srgbClr val="1A1A2E"/>
-                </a:solidFill>
-                <a:latin typeface="Calibri" pitchFamily="34" charset="0"/>
-                <a:ea typeface="Calibri" pitchFamily="34" charset="-122"/>
-                <a:cs typeface="Calibri" pitchFamily="34" charset="-120"/>
-              </a:rPr>
-              <a:t>Avantages : simplification, sécurité (masquer colonnes), abstraction</a:t>
-            </a:r>
-            <a:endParaRPr lang="en-US" sz="1300" dirty="0"/>
-          </a:p>
-        </p:txBody>
-      </p:sp>
-      <p:sp>
-        <p:nvSpPr>
-          <p:cNvPr id="16" name="Shape 14"/>
-          <p:cNvSpPr/>
-          <p:nvPr/>
-        </p:nvSpPr>
-        <p:spPr>
-          <a:xfrm>
-            <a:off x="457200" y="3977640"/>
-            <a:ext cx="8229600" cy="640080"/>
-          </a:xfrm>
-          <a:prstGeom prst="rect">
-            <a:avLst/>
-          </a:prstGeom>
-          <a:solidFill>
-            <a:srgbClr val="FFFFFF"/>
-          </a:solidFill>
-          <a:ln/>
-          <a:effectLst>
-            <a:outerShdw sx="100000" sy="100000" kx="0" ky="0" algn="bl" rotWithShape="0" blurRad="50800" dist="25400" dir="8100000">
-              <a:srgbClr val="000000">
-                <a:alpha val="12000"/>
-              </a:srgbClr>
-            </a:outerShdw>
-          </a:effectLst>
-        </p:spPr>
-      </p:sp>
-      <p:sp>
-        <p:nvSpPr>
-          <p:cNvPr id="17" name="Shape 15"/>
-          <p:cNvSpPr/>
-          <p:nvPr/>
-        </p:nvSpPr>
-        <p:spPr>
-          <a:xfrm>
-            <a:off x="457200" y="3977640"/>
-            <a:ext cx="54864" cy="640080"/>
-          </a:xfrm>
-          <a:prstGeom prst="rect">
-            <a:avLst/>
-          </a:prstGeom>
-          <a:solidFill>
-            <a:srgbClr val="1565C0"/>
-          </a:solidFill>
-          <a:ln/>
-        </p:spPr>
-      </p:sp>
-      <p:sp>
-        <p:nvSpPr>
-          <p:cNvPr id="18" name="Text 16"/>
-          <p:cNvSpPr/>
-          <p:nvPr/>
-        </p:nvSpPr>
-        <p:spPr>
-          <a:xfrm>
-            <a:off x="731520" y="3977640"/>
-            <a:ext cx="7772400" cy="640080"/>
-          </a:xfrm>
-          <a:prstGeom prst="rect">
-            <a:avLst/>
-          </a:prstGeom>
-          <a:noFill/>
-          <a:ln/>
-        </p:spPr>
-        <p:txBody>
-          <a:bodyPr wrap="square" lIns="0" tIns="0" rIns="0" bIns="0" rtlCol="0" anchor="ctr"/>
-          <a:lstStyle/>
-          <a:p>
-            <a:pPr indent="0" marL="0">
-              <a:buNone/>
-            </a:pPr>
-            <a:r>
-              <a:rPr lang="en-US" sz="1100" dirty="0">
-                <a:solidFill>
-                  <a:srgbClr val="0D47A1"/>
-                </a:solidFill>
-                <a:latin typeface="JetBrains Mono" pitchFamily="34" charset="0"/>
-                <a:ea typeface="JetBrains Mono" pitchFamily="34" charset="-122"/>
-                <a:cs typeface="JetBrains Mono" pitchFamily="34" charset="-120"/>
-              </a:rPr>
-              <a:t>Pas de stockage physique → recalculée à chaque appel</a:t>
-            </a:r>
-            <a:endParaRPr lang="en-US" sz="1100" dirty="0"/>
-          </a:p>
-        </p:txBody>
-      </p:sp>
-      <p:sp>
-        <p:nvSpPr>
-          <p:cNvPr id="19" name="Text 17"/>
-          <p:cNvSpPr/>
-          <p:nvPr/>
-        </p:nvSpPr>
-        <p:spPr>
-          <a:xfrm>
-            <a:off x="8229600" y="4754880"/>
-            <a:ext cx="731520" cy="274320"/>
-          </a:xfrm>
-          <a:prstGeom prst="rect">
-            <a:avLst/>
-          </a:prstGeom>
-          <a:noFill/>
-          <a:ln/>
-        </p:spPr>
-        <p:txBody>
-          <a:bodyPr wrap="square" lIns="0" tIns="0" rIns="0" bIns="0" rtlCol="0" anchor="ctr"/>
-          <a:lstStyle/>
-          <a:p>
-            <a:pPr algn="r" indent="0" marL="0">
-              <a:buNone/>
-            </a:pPr>
-            <a:r>
-              <a:rPr lang="en-US" sz="900" dirty="0">
-                <a:solidFill>
-                  <a:srgbClr val="AAAAAA"/>
-                </a:solidFill>
-                <a:latin typeface="Calibri" pitchFamily="34" charset="0"/>
-                <a:ea typeface="Calibri" pitchFamily="34" charset="-122"/>
-                <a:cs typeface="Calibri" pitchFamily="34" charset="-120"/>
-              </a:rPr>
-              <a:t>2/6</a:t>
-            </a:r>
-            <a:endParaRPr lang="en-US" sz="900" dirty="0"/>
+              <a:t>DROP VIEW IF EXISTS v_artistes_actifs;</a:t>
+            </a:r>
+            <a:endParaRPr lang="en-US" sz="1000" dirty="0"/>
           </a:p>
         </p:txBody>
       </p:sp>
@@ -2249,7 +2343,7 @@
         <p:spPr>
           <a:xfrm>
             <a:off x="0" y="0"/>
-            <a:ext cx="9144000" cy="73152"/>
+            <a:ext cx="9144000" cy="54864"/>
           </a:xfrm>
           <a:prstGeom prst="rect">
             <a:avLst/>
@@ -2268,8 +2362,8 @@
         </p:nvSpPr>
         <p:spPr>
           <a:xfrm>
-            <a:off x="457200" y="228600"/>
-            <a:ext cx="8229600" cy="640080"/>
+            <a:off x="457200" y="182880"/>
+            <a:ext cx="8229600" cy="594360"/>
           </a:xfrm>
           <a:prstGeom prst="rect">
             <a:avLst/>
@@ -2285,7 +2379,7 @@
               <a:buNone/>
             </a:pPr>
             <a:r>
-              <a:rPr lang="en-US" sz="2600" b="1" dirty="0">
+              <a:rPr lang="en-US" sz="2400" b="1" dirty="0">
                 <a:solidFill>
                   <a:srgbClr val="0D47A1"/>
                 </a:solidFill>
@@ -2295,7 +2389,7 @@
               </a:rPr>
               <a:t>Procédures stockées</a:t>
             </a:r>
-            <a:endParaRPr lang="en-US" sz="2600" dirty="0"/>
+            <a:endParaRPr lang="en-US" sz="2400" dirty="0"/>
           </a:p>
         </p:txBody>
       </p:sp>
@@ -2307,8 +2401,8 @@
         </p:nvSpPr>
         <p:spPr>
           <a:xfrm>
-            <a:off x="457200" y="1051560"/>
-            <a:ext cx="8229600" cy="434340"/>
+            <a:off x="457200" y="914400"/>
+            <a:ext cx="8229600" cy="275023"/>
           </a:xfrm>
           <a:prstGeom prst="rect">
             <a:avLst/>
@@ -2334,8 +2428,8 @@
         </p:nvSpPr>
         <p:spPr>
           <a:xfrm>
-            <a:off x="457200" y="1051560"/>
-            <a:ext cx="54864" cy="434340"/>
+            <a:off x="457200" y="914400"/>
+            <a:ext cx="45720" cy="275023"/>
           </a:xfrm>
           <a:prstGeom prst="rect">
             <a:avLst/>
@@ -2354,8 +2448,8 @@
         </p:nvSpPr>
         <p:spPr>
           <a:xfrm>
-            <a:off x="731520" y="1051560"/>
-            <a:ext cx="7772400" cy="434340"/>
+            <a:off x="685800" y="914400"/>
+            <a:ext cx="7818120" cy="275023"/>
           </a:xfrm>
           <a:prstGeom prst="rect">
             <a:avLst/>
@@ -2371,7 +2465,7 @@
               <a:buNone/>
             </a:pPr>
             <a:r>
-              <a:rPr lang="en-US" sz="1100" dirty="0">
+              <a:rPr lang="en-US" sz="1000" dirty="0">
                 <a:solidFill>
                   <a:srgbClr val="0D47A1"/>
                 </a:solidFill>
@@ -2381,7 +2475,7 @@
               </a:rPr>
               <a:t>DELIMITER //</a:t>
             </a:r>
-            <a:endParaRPr lang="en-US" sz="1100" dirty="0"/>
+            <a:endParaRPr lang="en-US" sz="1000" dirty="0"/>
           </a:p>
         </p:txBody>
       </p:sp>
@@ -2393,8 +2487,8 @@
         </p:nvSpPr>
         <p:spPr>
           <a:xfrm>
-            <a:off x="457200" y="1508760"/>
-            <a:ext cx="8229600" cy="434340"/>
+            <a:off x="457200" y="1216855"/>
+            <a:ext cx="8229600" cy="275023"/>
           </a:xfrm>
           <a:prstGeom prst="rect">
             <a:avLst/>
@@ -2420,8 +2514,8 @@
         </p:nvSpPr>
         <p:spPr>
           <a:xfrm>
-            <a:off x="457200" y="1508760"/>
-            <a:ext cx="54864" cy="434340"/>
+            <a:off x="457200" y="1216855"/>
+            <a:ext cx="45720" cy="275023"/>
           </a:xfrm>
           <a:prstGeom prst="rect">
             <a:avLst/>
@@ -2440,8 +2534,8 @@
         </p:nvSpPr>
         <p:spPr>
           <a:xfrm>
-            <a:off x="731520" y="1508760"/>
-            <a:ext cx="7772400" cy="434340"/>
+            <a:off x="685800" y="1216855"/>
+            <a:ext cx="7818120" cy="275023"/>
           </a:xfrm>
           <a:prstGeom prst="rect">
             <a:avLst/>
@@ -2457,7 +2551,7 @@
               <a:buNone/>
             </a:pPr>
             <a:r>
-              <a:rPr lang="en-US" sz="1100" dirty="0">
+              <a:rPr lang="en-US" sz="1000" dirty="0">
                 <a:solidFill>
                   <a:srgbClr val="0D47A1"/>
                 </a:solidFill>
@@ -2465,9 +2559,9 @@
                 <a:ea typeface="JetBrains Mono" pitchFamily="34" charset="-122"/>
                 <a:cs typeface="JetBrains Mono" pitchFamily="34" charset="-120"/>
               </a:rPr>
-              <a:t>CREATE PROCEDURE sp_ajouter_session(IN p_date DATE, ...)</a:t>
-            </a:r>
-            <a:endParaRPr lang="en-US" sz="1100" dirty="0"/>
+              <a:t>CREATE PROCEDURE sp_ajouter_session(IN p_date DATE, IN p_salle INT)</a:t>
+            </a:r>
+            <a:endParaRPr lang="en-US" sz="1000" dirty="0"/>
           </a:p>
         </p:txBody>
       </p:sp>
@@ -2479,8 +2573,8 @@
         </p:nvSpPr>
         <p:spPr>
           <a:xfrm>
-            <a:off x="457200" y="1965960"/>
-            <a:ext cx="8229600" cy="434340"/>
+            <a:off x="457200" y="1519311"/>
+            <a:ext cx="8229600" cy="275023"/>
           </a:xfrm>
           <a:prstGeom prst="rect">
             <a:avLst/>
@@ -2506,8 +2600,8 @@
         </p:nvSpPr>
         <p:spPr>
           <a:xfrm>
-            <a:off x="457200" y="1965960"/>
-            <a:ext cx="54864" cy="434340"/>
+            <a:off x="457200" y="1519311"/>
+            <a:ext cx="45720" cy="275023"/>
           </a:xfrm>
           <a:prstGeom prst="rect">
             <a:avLst/>
@@ -2526,8 +2620,8 @@
         </p:nvSpPr>
         <p:spPr>
           <a:xfrm>
-            <a:off x="731520" y="1965960"/>
-            <a:ext cx="7772400" cy="434340"/>
+            <a:off x="685800" y="1519311"/>
+            <a:ext cx="7818120" cy="275023"/>
           </a:xfrm>
           <a:prstGeom prst="rect">
             <a:avLst/>
@@ -2543,7 +2637,7 @@
               <a:buNone/>
             </a:pPr>
             <a:r>
-              <a:rPr lang="en-US" sz="1100" dirty="0">
+              <a:rPr lang="en-US" sz="1000" dirty="0">
                 <a:solidFill>
                   <a:srgbClr val="0D47A1"/>
                 </a:solidFill>
@@ -2553,7 +2647,7 @@
               </a:rPr>
               <a:t>BEGIN</a:t>
             </a:r>
-            <a:endParaRPr lang="en-US" sz="1100" dirty="0"/>
+            <a:endParaRPr lang="en-US" sz="1000" dirty="0"/>
           </a:p>
         </p:txBody>
       </p:sp>
@@ -2565,8 +2659,8 @@
         </p:nvSpPr>
         <p:spPr>
           <a:xfrm>
-            <a:off x="457200" y="2423160"/>
-            <a:ext cx="8229600" cy="434340"/>
+            <a:off x="457200" y="1821766"/>
+            <a:ext cx="8229600" cy="275023"/>
           </a:xfrm>
           <a:prstGeom prst="rect">
             <a:avLst/>
@@ -2592,8 +2686,8 @@
         </p:nvSpPr>
         <p:spPr>
           <a:xfrm>
-            <a:off x="457200" y="2423160"/>
-            <a:ext cx="54864" cy="434340"/>
+            <a:off x="457200" y="1821766"/>
+            <a:ext cx="45720" cy="275023"/>
           </a:xfrm>
           <a:prstGeom prst="rect">
             <a:avLst/>
@@ -2612,8 +2706,8 @@
         </p:nvSpPr>
         <p:spPr>
           <a:xfrm>
-            <a:off x="731520" y="2423160"/>
-            <a:ext cx="7772400" cy="434340"/>
+            <a:off x="685800" y="1821766"/>
+            <a:ext cx="7818120" cy="275023"/>
           </a:xfrm>
           <a:prstGeom prst="rect">
             <a:avLst/>
@@ -2629,7 +2723,7 @@
               <a:buNone/>
             </a:pPr>
             <a:r>
-              <a:rPr lang="en-US" sz="1300" dirty="0">
+              <a:rPr lang="en-US" sz="1200" dirty="0">
                 <a:solidFill>
                   <a:srgbClr val="1A1A2E"/>
                 </a:solidFill>
@@ -2637,9 +2731,9 @@
                 <a:ea typeface="Calibri" pitchFamily="34" charset="-122"/>
                 <a:cs typeface="Calibri" pitchFamily="34" charset="-120"/>
               </a:rPr>
-              <a:t>  -- logique SQL ici</a:t>
-            </a:r>
-            <a:endParaRPr lang="en-US" sz="1300" dirty="0"/>
+              <a:t>  DECLARE v_conflit INT;</a:t>
+            </a:r>
+            <a:endParaRPr lang="en-US" sz="1200" dirty="0"/>
           </a:p>
         </p:txBody>
       </p:sp>
@@ -2651,8 +2745,8 @@
         </p:nvSpPr>
         <p:spPr>
           <a:xfrm>
-            <a:off x="457200" y="2880360"/>
-            <a:ext cx="8229600" cy="434340"/>
+            <a:off x="457200" y="2124222"/>
+            <a:ext cx="8229600" cy="275023"/>
           </a:xfrm>
           <a:prstGeom prst="rect">
             <a:avLst/>
@@ -2678,8 +2772,8 @@
         </p:nvSpPr>
         <p:spPr>
           <a:xfrm>
-            <a:off x="457200" y="2880360"/>
-            <a:ext cx="54864" cy="434340"/>
+            <a:off x="457200" y="2124222"/>
+            <a:ext cx="45720" cy="275023"/>
           </a:xfrm>
           <a:prstGeom prst="rect">
             <a:avLst/>
@@ -2698,8 +2792,8 @@
         </p:nvSpPr>
         <p:spPr>
           <a:xfrm>
-            <a:off x="731520" y="2880360"/>
-            <a:ext cx="7772400" cy="434340"/>
+            <a:off x="685800" y="2124222"/>
+            <a:ext cx="7818120" cy="275023"/>
           </a:xfrm>
           <a:prstGeom prst="rect">
             <a:avLst/>
@@ -2715,7 +2809,523 @@
               <a:buNone/>
             </a:pPr>
             <a:r>
-              <a:rPr lang="en-US" sz="1300" dirty="0">
+              <a:rPr lang="en-US" sz="1000" dirty="0">
+                <a:solidFill>
+                  <a:srgbClr val="0D47A1"/>
+                </a:solidFill>
+                <a:latin typeface="JetBrains Mono" pitchFamily="34" charset="0"/>
+                <a:ea typeface="JetBrains Mono" pitchFamily="34" charset="-122"/>
+                <a:cs typeface="JetBrains Mono" pitchFamily="34" charset="-120"/>
+              </a:rPr>
+              <a:t>  SELECT COUNT(*) INTO v_conflit FROM session WHERE ...;</a:t>
+            </a:r>
+            <a:endParaRPr lang="en-US" sz="1000" dirty="0"/>
+          </a:p>
+        </p:txBody>
+      </p:sp>
+      <p:sp>
+        <p:nvSpPr>
+          <p:cNvPr id="19" name="Shape 17"/>
+          <p:cNvSpPr/>
+          <p:nvPr/>
+        </p:nvSpPr>
+        <p:spPr>
+          <a:xfrm>
+            <a:off x="457200" y="2426677"/>
+            <a:ext cx="8229600" cy="275023"/>
+          </a:xfrm>
+          <a:prstGeom prst="rect">
+            <a:avLst/>
+          </a:prstGeom>
+          <a:solidFill>
+            <a:srgbClr val="E3F2FD"/>
+          </a:solidFill>
+          <a:ln/>
+          <a:effectLst>
+            <a:outerShdw sx="100000" sy="100000" kx="0" ky="0" algn="bl" rotWithShape="0" blurRad="50800" dist="25400" dir="8100000">
+              <a:srgbClr val="000000">
+                <a:alpha val="12000"/>
+              </a:srgbClr>
+            </a:outerShdw>
+          </a:effectLst>
+        </p:spPr>
+      </p:sp>
+      <p:sp>
+        <p:nvSpPr>
+          <p:cNvPr id="20" name="Shape 18"/>
+          <p:cNvSpPr/>
+          <p:nvPr/>
+        </p:nvSpPr>
+        <p:spPr>
+          <a:xfrm>
+            <a:off x="457200" y="2426677"/>
+            <a:ext cx="45720" cy="275023"/>
+          </a:xfrm>
+          <a:prstGeom prst="rect">
+            <a:avLst/>
+          </a:prstGeom>
+          <a:solidFill>
+            <a:srgbClr val="1565C0"/>
+          </a:solidFill>
+          <a:ln/>
+        </p:spPr>
+      </p:sp>
+      <p:sp>
+        <p:nvSpPr>
+          <p:cNvPr id="21" name="Text 19"/>
+          <p:cNvSpPr/>
+          <p:nvPr/>
+        </p:nvSpPr>
+        <p:spPr>
+          <a:xfrm>
+            <a:off x="685800" y="2426677"/>
+            <a:ext cx="7818120" cy="275023"/>
+          </a:xfrm>
+          <a:prstGeom prst="rect">
+            <a:avLst/>
+          </a:prstGeom>
+          <a:noFill/>
+          <a:ln/>
+        </p:spPr>
+        <p:txBody>
+          <a:bodyPr wrap="square" lIns="0" tIns="0" rIns="0" bIns="0" rtlCol="0" anchor="ctr"/>
+          <a:lstStyle/>
+          <a:p>
+            <a:pPr indent="0" marL="0">
+              <a:buNone/>
+            </a:pPr>
+            <a:r>
+              <a:rPr lang="en-US" sz="1200" dirty="0">
+                <a:solidFill>
+                  <a:srgbClr val="1A1A2E"/>
+                </a:solidFill>
+                <a:latin typeface="Calibri" pitchFamily="34" charset="0"/>
+                <a:ea typeface="Calibri" pitchFamily="34" charset="-122"/>
+                <a:cs typeface="Calibri" pitchFamily="34" charset="-120"/>
+              </a:rPr>
+              <a:t>  IF v_conflit &gt; 0 THEN</a:t>
+            </a:r>
+            <a:endParaRPr lang="en-US" sz="1200" dirty="0"/>
+          </a:p>
+        </p:txBody>
+      </p:sp>
+      <p:sp>
+        <p:nvSpPr>
+          <p:cNvPr id="22" name="Shape 20"/>
+          <p:cNvSpPr/>
+          <p:nvPr/>
+        </p:nvSpPr>
+        <p:spPr>
+          <a:xfrm>
+            <a:off x="457200" y="2729132"/>
+            <a:ext cx="8229600" cy="275023"/>
+          </a:xfrm>
+          <a:prstGeom prst="rect">
+            <a:avLst/>
+          </a:prstGeom>
+          <a:solidFill>
+            <a:srgbClr val="FFFFFF"/>
+          </a:solidFill>
+          <a:ln/>
+          <a:effectLst>
+            <a:outerShdw sx="100000" sy="100000" kx="0" ky="0" algn="bl" rotWithShape="0" blurRad="50800" dist="25400" dir="8100000">
+              <a:srgbClr val="000000">
+                <a:alpha val="12000"/>
+              </a:srgbClr>
+            </a:outerShdw>
+          </a:effectLst>
+        </p:spPr>
+      </p:sp>
+      <p:sp>
+        <p:nvSpPr>
+          <p:cNvPr id="23" name="Shape 21"/>
+          <p:cNvSpPr/>
+          <p:nvPr/>
+        </p:nvSpPr>
+        <p:spPr>
+          <a:xfrm>
+            <a:off x="457200" y="2729132"/>
+            <a:ext cx="45720" cy="275023"/>
+          </a:xfrm>
+          <a:prstGeom prst="rect">
+            <a:avLst/>
+          </a:prstGeom>
+          <a:solidFill>
+            <a:srgbClr val="1565C0"/>
+          </a:solidFill>
+          <a:ln/>
+        </p:spPr>
+      </p:sp>
+      <p:sp>
+        <p:nvSpPr>
+          <p:cNvPr id="24" name="Text 22"/>
+          <p:cNvSpPr/>
+          <p:nvPr/>
+        </p:nvSpPr>
+        <p:spPr>
+          <a:xfrm>
+            <a:off x="685800" y="2729132"/>
+            <a:ext cx="7818120" cy="275023"/>
+          </a:xfrm>
+          <a:prstGeom prst="rect">
+            <a:avLst/>
+          </a:prstGeom>
+          <a:noFill/>
+          <a:ln/>
+        </p:spPr>
+        <p:txBody>
+          <a:bodyPr wrap="square" lIns="0" tIns="0" rIns="0" bIns="0" rtlCol="0" anchor="ctr"/>
+          <a:lstStyle/>
+          <a:p>
+            <a:pPr indent="0" marL="0">
+              <a:buNone/>
+            </a:pPr>
+            <a:r>
+              <a:rPr lang="en-US" sz="1200" dirty="0">
+                <a:solidFill>
+                  <a:srgbClr val="1A1A2E"/>
+                </a:solidFill>
+                <a:latin typeface="Calibri" pitchFamily="34" charset="0"/>
+                <a:ea typeface="Calibri" pitchFamily="34" charset="-122"/>
+                <a:cs typeface="Calibri" pitchFamily="34" charset="-120"/>
+              </a:rPr>
+              <a:t>    SIGNAL SQLSTATE '45000' SET MESSAGE_TEXT = 'Salle occupée';</a:t>
+            </a:r>
+            <a:endParaRPr lang="en-US" sz="1200" dirty="0"/>
+          </a:p>
+        </p:txBody>
+      </p:sp>
+      <p:sp>
+        <p:nvSpPr>
+          <p:cNvPr id="25" name="Shape 23"/>
+          <p:cNvSpPr/>
+          <p:nvPr/>
+        </p:nvSpPr>
+        <p:spPr>
+          <a:xfrm>
+            <a:off x="457200" y="3031588"/>
+            <a:ext cx="8229600" cy="275023"/>
+          </a:xfrm>
+          <a:prstGeom prst="rect">
+            <a:avLst/>
+          </a:prstGeom>
+          <a:solidFill>
+            <a:srgbClr val="E3F2FD"/>
+          </a:solidFill>
+          <a:ln/>
+          <a:effectLst>
+            <a:outerShdw sx="100000" sy="100000" kx="0" ky="0" algn="bl" rotWithShape="0" blurRad="50800" dist="25400" dir="8100000">
+              <a:srgbClr val="000000">
+                <a:alpha val="12000"/>
+              </a:srgbClr>
+            </a:outerShdw>
+          </a:effectLst>
+        </p:spPr>
+      </p:sp>
+      <p:sp>
+        <p:nvSpPr>
+          <p:cNvPr id="26" name="Shape 24"/>
+          <p:cNvSpPr/>
+          <p:nvPr/>
+        </p:nvSpPr>
+        <p:spPr>
+          <a:xfrm>
+            <a:off x="457200" y="3031588"/>
+            <a:ext cx="45720" cy="275023"/>
+          </a:xfrm>
+          <a:prstGeom prst="rect">
+            <a:avLst/>
+          </a:prstGeom>
+          <a:solidFill>
+            <a:srgbClr val="1565C0"/>
+          </a:solidFill>
+          <a:ln/>
+        </p:spPr>
+      </p:sp>
+      <p:sp>
+        <p:nvSpPr>
+          <p:cNvPr id="27" name="Text 25"/>
+          <p:cNvSpPr/>
+          <p:nvPr/>
+        </p:nvSpPr>
+        <p:spPr>
+          <a:xfrm>
+            <a:off x="685800" y="3031588"/>
+            <a:ext cx="7818120" cy="275023"/>
+          </a:xfrm>
+          <a:prstGeom prst="rect">
+            <a:avLst/>
+          </a:prstGeom>
+          <a:noFill/>
+          <a:ln/>
+        </p:spPr>
+        <p:txBody>
+          <a:bodyPr wrap="square" lIns="0" tIns="0" rIns="0" bIns="0" rtlCol="0" anchor="ctr"/>
+          <a:lstStyle/>
+          <a:p>
+            <a:pPr indent="0" marL="0">
+              <a:buNone/>
+            </a:pPr>
+            <a:r>
+              <a:rPr lang="en-US" sz="1200" dirty="0">
+                <a:solidFill>
+                  <a:srgbClr val="1A1A2E"/>
+                </a:solidFill>
+                <a:latin typeface="Calibri" pitchFamily="34" charset="0"/>
+                <a:ea typeface="Calibri" pitchFamily="34" charset="-122"/>
+                <a:cs typeface="Calibri" pitchFamily="34" charset="-120"/>
+              </a:rPr>
+              <a:t>  ELSE</a:t>
+            </a:r>
+            <a:endParaRPr lang="en-US" sz="1200" dirty="0"/>
+          </a:p>
+        </p:txBody>
+      </p:sp>
+      <p:sp>
+        <p:nvSpPr>
+          <p:cNvPr id="28" name="Shape 26"/>
+          <p:cNvSpPr/>
+          <p:nvPr/>
+        </p:nvSpPr>
+        <p:spPr>
+          <a:xfrm>
+            <a:off x="457200" y="3334043"/>
+            <a:ext cx="8229600" cy="275023"/>
+          </a:xfrm>
+          <a:prstGeom prst="rect">
+            <a:avLst/>
+          </a:prstGeom>
+          <a:solidFill>
+            <a:srgbClr val="FFFFFF"/>
+          </a:solidFill>
+          <a:ln/>
+          <a:effectLst>
+            <a:outerShdw sx="100000" sy="100000" kx="0" ky="0" algn="bl" rotWithShape="0" blurRad="50800" dist="25400" dir="8100000">
+              <a:srgbClr val="000000">
+                <a:alpha val="12000"/>
+              </a:srgbClr>
+            </a:outerShdw>
+          </a:effectLst>
+        </p:spPr>
+      </p:sp>
+      <p:sp>
+        <p:nvSpPr>
+          <p:cNvPr id="29" name="Shape 27"/>
+          <p:cNvSpPr/>
+          <p:nvPr/>
+        </p:nvSpPr>
+        <p:spPr>
+          <a:xfrm>
+            <a:off x="457200" y="3334043"/>
+            <a:ext cx="45720" cy="275023"/>
+          </a:xfrm>
+          <a:prstGeom prst="rect">
+            <a:avLst/>
+          </a:prstGeom>
+          <a:solidFill>
+            <a:srgbClr val="1565C0"/>
+          </a:solidFill>
+          <a:ln/>
+        </p:spPr>
+      </p:sp>
+      <p:sp>
+        <p:nvSpPr>
+          <p:cNvPr id="30" name="Text 28"/>
+          <p:cNvSpPr/>
+          <p:nvPr/>
+        </p:nvSpPr>
+        <p:spPr>
+          <a:xfrm>
+            <a:off x="685800" y="3334043"/>
+            <a:ext cx="7818120" cy="275023"/>
+          </a:xfrm>
+          <a:prstGeom prst="rect">
+            <a:avLst/>
+          </a:prstGeom>
+          <a:noFill/>
+          <a:ln/>
+        </p:spPr>
+        <p:txBody>
+          <a:bodyPr wrap="square" lIns="0" tIns="0" rIns="0" bIns="0" rtlCol="0" anchor="ctr"/>
+          <a:lstStyle/>
+          <a:p>
+            <a:pPr indent="0" marL="0">
+              <a:buNone/>
+            </a:pPr>
+            <a:r>
+              <a:rPr lang="en-US" sz="1000" dirty="0">
+                <a:solidFill>
+                  <a:srgbClr val="0D47A1"/>
+                </a:solidFill>
+                <a:latin typeface="JetBrains Mono" pitchFamily="34" charset="0"/>
+                <a:ea typeface="JetBrains Mono" pitchFamily="34" charset="-122"/>
+                <a:cs typeface="JetBrains Mono" pitchFamily="34" charset="-120"/>
+              </a:rPr>
+              <a:t>    INSERT INTO session (...) VALUES (...);</a:t>
+            </a:r>
+            <a:endParaRPr lang="en-US" sz="1000" dirty="0"/>
+          </a:p>
+        </p:txBody>
+      </p:sp>
+      <p:sp>
+        <p:nvSpPr>
+          <p:cNvPr id="31" name="Shape 29"/>
+          <p:cNvSpPr/>
+          <p:nvPr/>
+        </p:nvSpPr>
+        <p:spPr>
+          <a:xfrm>
+            <a:off x="457200" y="3636498"/>
+            <a:ext cx="8229600" cy="275023"/>
+          </a:xfrm>
+          <a:prstGeom prst="rect">
+            <a:avLst/>
+          </a:prstGeom>
+          <a:solidFill>
+            <a:srgbClr val="E3F2FD"/>
+          </a:solidFill>
+          <a:ln/>
+          <a:effectLst>
+            <a:outerShdw sx="100000" sy="100000" kx="0" ky="0" algn="bl" rotWithShape="0" blurRad="50800" dist="25400" dir="8100000">
+              <a:srgbClr val="000000">
+                <a:alpha val="12000"/>
+              </a:srgbClr>
+            </a:outerShdw>
+          </a:effectLst>
+        </p:spPr>
+      </p:sp>
+      <p:sp>
+        <p:nvSpPr>
+          <p:cNvPr id="32" name="Shape 30"/>
+          <p:cNvSpPr/>
+          <p:nvPr/>
+        </p:nvSpPr>
+        <p:spPr>
+          <a:xfrm>
+            <a:off x="457200" y="3636498"/>
+            <a:ext cx="45720" cy="275023"/>
+          </a:xfrm>
+          <a:prstGeom prst="rect">
+            <a:avLst/>
+          </a:prstGeom>
+          <a:solidFill>
+            <a:srgbClr val="1565C0"/>
+          </a:solidFill>
+          <a:ln/>
+        </p:spPr>
+      </p:sp>
+      <p:sp>
+        <p:nvSpPr>
+          <p:cNvPr id="33" name="Text 31"/>
+          <p:cNvSpPr/>
+          <p:nvPr/>
+        </p:nvSpPr>
+        <p:spPr>
+          <a:xfrm>
+            <a:off x="685800" y="3636498"/>
+            <a:ext cx="7818120" cy="275023"/>
+          </a:xfrm>
+          <a:prstGeom prst="rect">
+            <a:avLst/>
+          </a:prstGeom>
+          <a:noFill/>
+          <a:ln/>
+        </p:spPr>
+        <p:txBody>
+          <a:bodyPr wrap="square" lIns="0" tIns="0" rIns="0" bIns="0" rtlCol="0" anchor="ctr"/>
+          <a:lstStyle/>
+          <a:p>
+            <a:pPr indent="0" marL="0">
+              <a:buNone/>
+            </a:pPr>
+            <a:r>
+              <a:rPr lang="en-US" sz="1200" dirty="0">
+                <a:solidFill>
+                  <a:srgbClr val="1A1A2E"/>
+                </a:solidFill>
+                <a:latin typeface="Calibri" pitchFamily="34" charset="0"/>
+                <a:ea typeface="Calibri" pitchFamily="34" charset="-122"/>
+                <a:cs typeface="Calibri" pitchFamily="34" charset="-120"/>
+              </a:rPr>
+              <a:t>  END IF;</a:t>
+            </a:r>
+            <a:endParaRPr lang="en-US" sz="1200" dirty="0"/>
+          </a:p>
+        </p:txBody>
+      </p:sp>
+      <p:sp>
+        <p:nvSpPr>
+          <p:cNvPr id="34" name="Shape 32"/>
+          <p:cNvSpPr/>
+          <p:nvPr/>
+        </p:nvSpPr>
+        <p:spPr>
+          <a:xfrm>
+            <a:off x="457200" y="3938954"/>
+            <a:ext cx="8229600" cy="275023"/>
+          </a:xfrm>
+          <a:prstGeom prst="rect">
+            <a:avLst/>
+          </a:prstGeom>
+          <a:solidFill>
+            <a:srgbClr val="FFFFFF"/>
+          </a:solidFill>
+          <a:ln/>
+          <a:effectLst>
+            <a:outerShdw sx="100000" sy="100000" kx="0" ky="0" algn="bl" rotWithShape="0" blurRad="50800" dist="25400" dir="8100000">
+              <a:srgbClr val="000000">
+                <a:alpha val="12000"/>
+              </a:srgbClr>
+            </a:outerShdw>
+          </a:effectLst>
+        </p:spPr>
+      </p:sp>
+      <p:sp>
+        <p:nvSpPr>
+          <p:cNvPr id="35" name="Shape 33"/>
+          <p:cNvSpPr/>
+          <p:nvPr/>
+        </p:nvSpPr>
+        <p:spPr>
+          <a:xfrm>
+            <a:off x="457200" y="3938954"/>
+            <a:ext cx="45720" cy="275023"/>
+          </a:xfrm>
+          <a:prstGeom prst="rect">
+            <a:avLst/>
+          </a:prstGeom>
+          <a:solidFill>
+            <a:srgbClr val="1565C0"/>
+          </a:solidFill>
+          <a:ln/>
+        </p:spPr>
+      </p:sp>
+      <p:sp>
+        <p:nvSpPr>
+          <p:cNvPr id="36" name="Text 34"/>
+          <p:cNvSpPr/>
+          <p:nvPr/>
+        </p:nvSpPr>
+        <p:spPr>
+          <a:xfrm>
+            <a:off x="685800" y="3938954"/>
+            <a:ext cx="7818120" cy="275023"/>
+          </a:xfrm>
+          <a:prstGeom prst="rect">
+            <a:avLst/>
+          </a:prstGeom>
+          <a:noFill/>
+          <a:ln/>
+        </p:spPr>
+        <p:txBody>
+          <a:bodyPr wrap="square" lIns="0" tIns="0" rIns="0" bIns="0" rtlCol="0" anchor="ctr"/>
+          <a:lstStyle/>
+          <a:p>
+            <a:pPr indent="0" marL="0">
+              <a:buNone/>
+            </a:pPr>
+            <a:r>
+              <a:rPr lang="en-US" sz="1200" dirty="0">
                 <a:solidFill>
                   <a:srgbClr val="1A1A2E"/>
                 </a:solidFill>
@@ -2725,20 +3335,20 @@
               </a:rPr>
               <a:t>END //</a:t>
             </a:r>
-            <a:endParaRPr lang="en-US" sz="1300" dirty="0"/>
-          </a:p>
-        </p:txBody>
-      </p:sp>
-      <p:sp>
-        <p:nvSpPr>
-          <p:cNvPr id="19" name="Shape 17"/>
-          <p:cNvSpPr/>
-          <p:nvPr/>
-        </p:nvSpPr>
-        <p:spPr>
-          <a:xfrm>
-            <a:off x="457200" y="3337560"/>
-            <a:ext cx="8229600" cy="434340"/>
+            <a:endParaRPr lang="en-US" sz="1200" dirty="0"/>
+          </a:p>
+        </p:txBody>
+      </p:sp>
+      <p:sp>
+        <p:nvSpPr>
+          <p:cNvPr id="37" name="Shape 35"/>
+          <p:cNvSpPr/>
+          <p:nvPr/>
+        </p:nvSpPr>
+        <p:spPr>
+          <a:xfrm>
+            <a:off x="457200" y="4241409"/>
+            <a:ext cx="8229600" cy="275023"/>
           </a:xfrm>
           <a:prstGeom prst="rect">
             <a:avLst/>
@@ -2758,14 +3368,14 @@
       </p:sp>
       <p:sp>
         <p:nvSpPr>
-          <p:cNvPr id="20" name="Shape 18"/>
-          <p:cNvSpPr/>
-          <p:nvPr/>
-        </p:nvSpPr>
-        <p:spPr>
-          <a:xfrm>
-            <a:off x="457200" y="3337560"/>
-            <a:ext cx="54864" cy="434340"/>
+          <p:cNvPr id="38" name="Shape 36"/>
+          <p:cNvSpPr/>
+          <p:nvPr/>
+        </p:nvSpPr>
+        <p:spPr>
+          <a:xfrm>
+            <a:off x="457200" y="4241409"/>
+            <a:ext cx="45720" cy="275023"/>
           </a:xfrm>
           <a:prstGeom prst="rect">
             <a:avLst/>
@@ -2778,14 +3388,14 @@
       </p:sp>
       <p:sp>
         <p:nvSpPr>
-          <p:cNvPr id="21" name="Text 19"/>
-          <p:cNvSpPr/>
-          <p:nvPr/>
-        </p:nvSpPr>
-        <p:spPr>
-          <a:xfrm>
-            <a:off x="731520" y="3337560"/>
-            <a:ext cx="7772400" cy="434340"/>
+          <p:cNvPr id="39" name="Text 37"/>
+          <p:cNvSpPr/>
+          <p:nvPr/>
+        </p:nvSpPr>
+        <p:spPr>
+          <a:xfrm>
+            <a:off x="685800" y="4241409"/>
+            <a:ext cx="7818120" cy="275023"/>
           </a:xfrm>
           <a:prstGeom prst="rect">
             <a:avLst/>
@@ -2801,7 +3411,7 @@
               <a:buNone/>
             </a:pPr>
             <a:r>
-              <a:rPr lang="en-US" sz="1100" dirty="0">
+              <a:rPr lang="en-US" sz="1000" dirty="0">
                 <a:solidFill>
                   <a:srgbClr val="0D47A1"/>
                 </a:solidFill>
@@ -2811,20 +3421,20 @@
               </a:rPr>
               <a:t>DELIMITER ;</a:t>
             </a:r>
-            <a:endParaRPr lang="en-US" sz="1100" dirty="0"/>
-          </a:p>
-        </p:txBody>
-      </p:sp>
-      <p:sp>
-        <p:nvSpPr>
-          <p:cNvPr id="22" name="Shape 20"/>
-          <p:cNvSpPr/>
-          <p:nvPr/>
-        </p:nvSpPr>
-        <p:spPr>
-          <a:xfrm>
-            <a:off x="457200" y="3794760"/>
-            <a:ext cx="8229600" cy="434340"/>
+            <a:endParaRPr lang="en-US" sz="1000" dirty="0"/>
+          </a:p>
+        </p:txBody>
+      </p:sp>
+      <p:sp>
+        <p:nvSpPr>
+          <p:cNvPr id="40" name="Shape 38"/>
+          <p:cNvSpPr/>
+          <p:nvPr/>
+        </p:nvSpPr>
+        <p:spPr>
+          <a:xfrm>
+            <a:off x="457200" y="4543865"/>
+            <a:ext cx="8229600" cy="275023"/>
           </a:xfrm>
           <a:prstGeom prst="rect">
             <a:avLst/>
@@ -2844,14 +3454,14 @@
       </p:sp>
       <p:sp>
         <p:nvSpPr>
-          <p:cNvPr id="23" name="Shape 21"/>
-          <p:cNvSpPr/>
-          <p:nvPr/>
-        </p:nvSpPr>
-        <p:spPr>
-          <a:xfrm>
-            <a:off x="457200" y="3794760"/>
-            <a:ext cx="54864" cy="434340"/>
+          <p:cNvPr id="41" name="Shape 39"/>
+          <p:cNvSpPr/>
+          <p:nvPr/>
+        </p:nvSpPr>
+        <p:spPr>
+          <a:xfrm>
+            <a:off x="457200" y="4543865"/>
+            <a:ext cx="45720" cy="275023"/>
           </a:xfrm>
           <a:prstGeom prst="rect">
             <a:avLst/>
@@ -2864,14 +3474,14 @@
       </p:sp>
       <p:sp>
         <p:nvSpPr>
-          <p:cNvPr id="24" name="Text 22"/>
-          <p:cNvSpPr/>
-          <p:nvPr/>
-        </p:nvSpPr>
-        <p:spPr>
-          <a:xfrm>
-            <a:off x="731520" y="3794760"/>
-            <a:ext cx="7772400" cy="434340"/>
+          <p:cNvPr id="42" name="Text 40"/>
+          <p:cNvSpPr/>
+          <p:nvPr/>
+        </p:nvSpPr>
+        <p:spPr>
+          <a:xfrm>
+            <a:off x="685800" y="4543865"/>
+            <a:ext cx="7818120" cy="275023"/>
           </a:xfrm>
           <a:prstGeom prst="rect">
             <a:avLst/>
@@ -2887,7 +3497,7 @@
               <a:buNone/>
             </a:pPr>
             <a:r>
-              <a:rPr lang="en-US" sz="1300" dirty="0">
+              <a:rPr lang="en-US" sz="1200" dirty="0">
                 <a:solidFill>
                   <a:srgbClr val="1A1A2E"/>
                 </a:solidFill>
@@ -2895,134 +3505,9 @@
                 <a:ea typeface="Calibri" pitchFamily="34" charset="-122"/>
                 <a:cs typeface="Calibri" pitchFamily="34" charset="-120"/>
               </a:rPr>
-              <a:t>Appel : CALL sp_ajouter_session('2025-04-15', ...);</a:t>
-            </a:r>
-            <a:endParaRPr lang="en-US" sz="1300" dirty="0"/>
-          </a:p>
-        </p:txBody>
-      </p:sp>
-      <p:sp>
-        <p:nvSpPr>
-          <p:cNvPr id="25" name="Shape 23"/>
-          <p:cNvSpPr/>
-          <p:nvPr/>
-        </p:nvSpPr>
-        <p:spPr>
-          <a:xfrm>
-            <a:off x="457200" y="4251960"/>
-            <a:ext cx="8229600" cy="434340"/>
-          </a:xfrm>
-          <a:prstGeom prst="rect">
-            <a:avLst/>
-          </a:prstGeom>
-          <a:solidFill>
-            <a:srgbClr val="E3F2FD"/>
-          </a:solidFill>
-          <a:ln/>
-          <a:effectLst>
-            <a:outerShdw sx="100000" sy="100000" kx="0" ky="0" algn="bl" rotWithShape="0" blurRad="50800" dist="25400" dir="8100000">
-              <a:srgbClr val="000000">
-                <a:alpha val="12000"/>
-              </a:srgbClr>
-            </a:outerShdw>
-          </a:effectLst>
-        </p:spPr>
-      </p:sp>
-      <p:sp>
-        <p:nvSpPr>
-          <p:cNvPr id="26" name="Shape 24"/>
-          <p:cNvSpPr/>
-          <p:nvPr/>
-        </p:nvSpPr>
-        <p:spPr>
-          <a:xfrm>
-            <a:off x="457200" y="4251960"/>
-            <a:ext cx="54864" cy="434340"/>
-          </a:xfrm>
-          <a:prstGeom prst="rect">
-            <a:avLst/>
-          </a:prstGeom>
-          <a:solidFill>
-            <a:srgbClr val="1565C0"/>
-          </a:solidFill>
-          <a:ln/>
-        </p:spPr>
-      </p:sp>
-      <p:sp>
-        <p:nvSpPr>
-          <p:cNvPr id="27" name="Text 25"/>
-          <p:cNvSpPr/>
-          <p:nvPr/>
-        </p:nvSpPr>
-        <p:spPr>
-          <a:xfrm>
-            <a:off x="731520" y="4251960"/>
-            <a:ext cx="7772400" cy="434340"/>
-          </a:xfrm>
-          <a:prstGeom prst="rect">
-            <a:avLst/>
-          </a:prstGeom>
-          <a:noFill/>
-          <a:ln/>
-        </p:spPr>
-        <p:txBody>
-          <a:bodyPr wrap="square" lIns="0" tIns="0" rIns="0" bIns="0" rtlCol="0" anchor="ctr"/>
-          <a:lstStyle/>
-          <a:p>
-            <a:pPr indent="0" marL="0">
-              <a:buNone/>
-            </a:pPr>
-            <a:r>
-              <a:rPr lang="en-US" sz="1300" dirty="0">
-                <a:solidFill>
-                  <a:srgbClr val="1A1A2E"/>
-                </a:solidFill>
-                <a:latin typeface="Calibri" pitchFamily="34" charset="0"/>
-                <a:ea typeface="Calibri" pitchFamily="34" charset="-122"/>
-                <a:cs typeface="Calibri" pitchFamily="34" charset="-120"/>
-              </a:rPr>
-              <a:t>Paramètres IN (entrée), OUT (sortie), INOUT (les deux)</a:t>
-            </a:r>
-            <a:endParaRPr lang="en-US" sz="1300" dirty="0"/>
-          </a:p>
-        </p:txBody>
-      </p:sp>
-      <p:sp>
-        <p:nvSpPr>
-          <p:cNvPr id="28" name="Text 26"/>
-          <p:cNvSpPr/>
-          <p:nvPr/>
-        </p:nvSpPr>
-        <p:spPr>
-          <a:xfrm>
-            <a:off x="8229600" y="4754880"/>
-            <a:ext cx="731520" cy="274320"/>
-          </a:xfrm>
-          <a:prstGeom prst="rect">
-            <a:avLst/>
-          </a:prstGeom>
-          <a:noFill/>
-          <a:ln/>
-        </p:spPr>
-        <p:txBody>
-          <a:bodyPr wrap="square" lIns="0" tIns="0" rIns="0" bIns="0" rtlCol="0" anchor="ctr"/>
-          <a:lstStyle/>
-          <a:p>
-            <a:pPr algn="r" indent="0" marL="0">
-              <a:buNone/>
-            </a:pPr>
-            <a:r>
-              <a:rPr lang="en-US" sz="900" dirty="0">
-                <a:solidFill>
-                  <a:srgbClr val="AAAAAA"/>
-                </a:solidFill>
-                <a:latin typeface="Calibri" pitchFamily="34" charset="0"/>
-                <a:ea typeface="Calibri" pitchFamily="34" charset="-122"/>
-                <a:cs typeface="Calibri" pitchFamily="34" charset="-120"/>
-              </a:rPr>
-              <a:t>3/6</a:t>
-            </a:r>
-            <a:endParaRPr lang="en-US" sz="900" dirty="0"/>
+              <a:t>Appel : CALL sp_ajouter_session('2025-05-01', 1);</a:t>
+            </a:r>
+            <a:endParaRPr lang="en-US" sz="1200" dirty="0"/>
           </a:p>
         </p:txBody>
       </p:sp>
@@ -3067,7 +3552,7 @@
         <p:spPr>
           <a:xfrm>
             <a:off x="0" y="0"/>
-            <a:ext cx="9144000" cy="73152"/>
+            <a:ext cx="9144000" cy="54864"/>
           </a:xfrm>
           <a:prstGeom prst="rect">
             <a:avLst/>
@@ -3086,8 +3571,8 @@
         </p:nvSpPr>
         <p:spPr>
           <a:xfrm>
-            <a:off x="457200" y="228600"/>
-            <a:ext cx="8229600" cy="640080"/>
+            <a:off x="457200" y="182880"/>
+            <a:ext cx="8229600" cy="594360"/>
           </a:xfrm>
           <a:prstGeom prst="rect">
             <a:avLst/>
@@ -3103,7 +3588,7 @@
               <a:buNone/>
             </a:pPr>
             <a:r>
-              <a:rPr lang="en-US" sz="2600" b="1" dirty="0">
+              <a:rPr lang="en-US" sz="2400" b="1" dirty="0">
                 <a:solidFill>
                   <a:srgbClr val="0D47A1"/>
                 </a:solidFill>
@@ -3111,9 +3596,9 @@
                 <a:ea typeface="Trebuchet MS" pitchFamily="34" charset="-122"/>
                 <a:cs typeface="Trebuchet MS" pitchFamily="34" charset="-120"/>
               </a:rPr>
-              <a:t>Fonctions personnalisées</a:t>
-            </a:r>
-            <a:endParaRPr lang="en-US" sz="2600" dirty="0"/>
+              <a:t>Fonctions et Triggers</a:t>
+            </a:r>
+            <a:endParaRPr lang="en-US" sz="2400" dirty="0"/>
           </a:p>
         </p:txBody>
       </p:sp>
@@ -3125,8 +3610,8 @@
         </p:nvSpPr>
         <p:spPr>
           <a:xfrm>
-            <a:off x="457200" y="1051560"/>
-            <a:ext cx="8229600" cy="640080"/>
+            <a:off x="457200" y="914400"/>
+            <a:ext cx="8229600" cy="521208"/>
           </a:xfrm>
           <a:prstGeom prst="rect">
             <a:avLst/>
@@ -3152,8 +3637,8 @@
         </p:nvSpPr>
         <p:spPr>
           <a:xfrm>
-            <a:off x="457200" y="1051560"/>
-            <a:ext cx="54864" cy="640080"/>
+            <a:off x="457200" y="914400"/>
+            <a:ext cx="45720" cy="521208"/>
           </a:xfrm>
           <a:prstGeom prst="rect">
             <a:avLst/>
@@ -3172,8 +3657,8 @@
         </p:nvSpPr>
         <p:spPr>
           <a:xfrm>
-            <a:off x="731520" y="1051560"/>
-            <a:ext cx="7772400" cy="640080"/>
+            <a:off x="685800" y="914400"/>
+            <a:ext cx="7818120" cy="521208"/>
           </a:xfrm>
           <a:prstGeom prst="rect">
             <a:avLst/>
@@ -3189,7 +3674,93 @@
               <a:buNone/>
             </a:pPr>
             <a:r>
-              <a:rPr lang="en-US" sz="1100" dirty="0">
+              <a:rPr lang="en-US" sz="1200" dirty="0">
+                <a:solidFill>
+                  <a:srgbClr val="1A1A2E"/>
+                </a:solidFill>
+                <a:latin typeface="Calibri" pitchFamily="34" charset="0"/>
+                <a:ea typeface="Calibri" pitchFamily="34" charset="-122"/>
+                <a:cs typeface="Calibri" pitchFamily="34" charset="-120"/>
+              </a:rPr>
+              <a:t>FONCTION : retourne une valeur, utilisable dans SELECT</a:t>
+            </a:r>
+            <a:endParaRPr lang="en-US" sz="1200" dirty="0"/>
+          </a:p>
+        </p:txBody>
+      </p:sp>
+      <p:sp>
+        <p:nvSpPr>
+          <p:cNvPr id="7" name="Shape 5"/>
+          <p:cNvSpPr/>
+          <p:nvPr/>
+        </p:nvSpPr>
+        <p:spPr>
+          <a:xfrm>
+            <a:off x="457200" y="1463040"/>
+            <a:ext cx="8229600" cy="521208"/>
+          </a:xfrm>
+          <a:prstGeom prst="rect">
+            <a:avLst/>
+          </a:prstGeom>
+          <a:solidFill>
+            <a:srgbClr val="E3F2FD"/>
+          </a:solidFill>
+          <a:ln/>
+          <a:effectLst>
+            <a:outerShdw sx="100000" sy="100000" kx="0" ky="0" algn="bl" rotWithShape="0" blurRad="50800" dist="25400" dir="8100000">
+              <a:srgbClr val="000000">
+                <a:alpha val="12000"/>
+              </a:srgbClr>
+            </a:outerShdw>
+          </a:effectLst>
+        </p:spPr>
+      </p:sp>
+      <p:sp>
+        <p:nvSpPr>
+          <p:cNvPr id="8" name="Shape 6"/>
+          <p:cNvSpPr/>
+          <p:nvPr/>
+        </p:nvSpPr>
+        <p:spPr>
+          <a:xfrm>
+            <a:off x="457200" y="1463040"/>
+            <a:ext cx="45720" cy="521208"/>
+          </a:xfrm>
+          <a:prstGeom prst="rect">
+            <a:avLst/>
+          </a:prstGeom>
+          <a:solidFill>
+            <a:srgbClr val="1565C0"/>
+          </a:solidFill>
+          <a:ln/>
+        </p:spPr>
+      </p:sp>
+      <p:sp>
+        <p:nvSpPr>
+          <p:cNvPr id="9" name="Text 7"/>
+          <p:cNvSpPr/>
+          <p:nvPr/>
+        </p:nvSpPr>
+        <p:spPr>
+          <a:xfrm>
+            <a:off x="685800" y="1463040"/>
+            <a:ext cx="7818120" cy="521208"/>
+          </a:xfrm>
+          <a:prstGeom prst="rect">
+            <a:avLst/>
+          </a:prstGeom>
+          <a:noFill/>
+          <a:ln/>
+        </p:spPr>
+        <p:txBody>
+          <a:bodyPr wrap="square" lIns="0" tIns="0" rIns="0" bIns="0" rtlCol="0" anchor="ctr"/>
+          <a:lstStyle/>
+          <a:p>
+            <a:pPr indent="0" marL="0">
+              <a:buNone/>
+            </a:pPr>
+            <a:r>
+              <a:rPr lang="en-US" sz="1000" dirty="0">
                 <a:solidFill>
                   <a:srgbClr val="0D47A1"/>
                 </a:solidFill>
@@ -3197,28 +3768,28 @@
                 <a:ea typeface="JetBrains Mono" pitchFamily="34" charset="-122"/>
                 <a:cs typeface="JetBrains Mono" pitchFamily="34" charset="-120"/>
               </a:rPr>
-              <a:t>CREATE FUNCTION fn_ca_artiste(p_id INT) RETURNS DECIMAL(10,2)</a:t>
-            </a:r>
-            <a:endParaRPr lang="en-US" sz="1100" dirty="0"/>
-          </a:p>
-        </p:txBody>
-      </p:sp>
-      <p:sp>
-        <p:nvSpPr>
-          <p:cNvPr id="7" name="Shape 5"/>
-          <p:cNvSpPr/>
-          <p:nvPr/>
-        </p:nvSpPr>
-        <p:spPr>
-          <a:xfrm>
-            <a:off x="457200" y="1783080"/>
-            <a:ext cx="8229600" cy="640080"/>
-          </a:xfrm>
-          <a:prstGeom prst="rect">
-            <a:avLst/>
-          </a:prstGeom>
-          <a:solidFill>
-            <a:srgbClr val="E3F2FD"/>
+              <a:t>CREATE FUNCTION fn_ca_artiste(p_id INT) RETURNS DECIMAL(10,2) ...</a:t>
+            </a:r>
+            <a:endParaRPr lang="en-US" sz="1000" dirty="0"/>
+          </a:p>
+        </p:txBody>
+      </p:sp>
+      <p:sp>
+        <p:nvSpPr>
+          <p:cNvPr id="10" name="Shape 8"/>
+          <p:cNvSpPr/>
+          <p:nvPr/>
+        </p:nvSpPr>
+        <p:spPr>
+          <a:xfrm>
+            <a:off x="457200" y="2011680"/>
+            <a:ext cx="8229600" cy="521208"/>
+          </a:xfrm>
+          <a:prstGeom prst="rect">
+            <a:avLst/>
+          </a:prstGeom>
+          <a:solidFill>
+            <a:srgbClr val="FFFFFF"/>
           </a:solidFill>
           <a:ln/>
           <a:effectLst>
@@ -3232,14 +3803,14 @@
       </p:sp>
       <p:sp>
         <p:nvSpPr>
-          <p:cNvPr id="8" name="Shape 6"/>
-          <p:cNvSpPr/>
-          <p:nvPr/>
-        </p:nvSpPr>
-        <p:spPr>
-          <a:xfrm>
-            <a:off x="457200" y="1783080"/>
-            <a:ext cx="54864" cy="640080"/>
+          <p:cNvPr id="11" name="Shape 9"/>
+          <p:cNvSpPr/>
+          <p:nvPr/>
+        </p:nvSpPr>
+        <p:spPr>
+          <a:xfrm>
+            <a:off x="457200" y="2011680"/>
+            <a:ext cx="45720" cy="521208"/>
           </a:xfrm>
           <a:prstGeom prst="rect">
             <a:avLst/>
@@ -3252,14 +3823,14 @@
       </p:sp>
       <p:sp>
         <p:nvSpPr>
-          <p:cNvPr id="9" name="Text 7"/>
-          <p:cNvSpPr/>
-          <p:nvPr/>
-        </p:nvSpPr>
-        <p:spPr>
-          <a:xfrm>
-            <a:off x="731520" y="1783080"/>
-            <a:ext cx="7772400" cy="640080"/>
+          <p:cNvPr id="12" name="Text 10"/>
+          <p:cNvSpPr/>
+          <p:nvPr/>
+        </p:nvSpPr>
+        <p:spPr>
+          <a:xfrm>
+            <a:off x="685800" y="2011680"/>
+            <a:ext cx="7818120" cy="521208"/>
           </a:xfrm>
           <a:prstGeom prst="rect">
             <a:avLst/>
@@ -3275,7 +3846,93 @@
               <a:buNone/>
             </a:pPr>
             <a:r>
-              <a:rPr lang="en-US" sz="1300" dirty="0">
+              <a:rPr lang="en-US" sz="1000" dirty="0">
+                <a:solidFill>
+                  <a:srgbClr val="0D47A1"/>
+                </a:solidFill>
+                <a:latin typeface="JetBrains Mono" pitchFamily="34" charset="0"/>
+                <a:ea typeface="JetBrains Mono" pitchFamily="34" charset="-122"/>
+                <a:cs typeface="JetBrains Mono" pitchFamily="34" charset="-120"/>
+              </a:rPr>
+              <a:t>SELECT nom, fn_ca_artiste(id_artiste) AS ca FROM artiste;</a:t>
+            </a:r>
+            <a:endParaRPr lang="en-US" sz="1000" dirty="0"/>
+          </a:p>
+        </p:txBody>
+      </p:sp>
+      <p:sp>
+        <p:nvSpPr>
+          <p:cNvPr id="13" name="Shape 11"/>
+          <p:cNvSpPr/>
+          <p:nvPr/>
+        </p:nvSpPr>
+        <p:spPr>
+          <a:xfrm>
+            <a:off x="457200" y="2560320"/>
+            <a:ext cx="8229600" cy="521208"/>
+          </a:xfrm>
+          <a:prstGeom prst="rect">
+            <a:avLst/>
+          </a:prstGeom>
+          <a:solidFill>
+            <a:srgbClr val="E3F2FD"/>
+          </a:solidFill>
+          <a:ln/>
+          <a:effectLst>
+            <a:outerShdw sx="100000" sy="100000" kx="0" ky="0" algn="bl" rotWithShape="0" blurRad="50800" dist="25400" dir="8100000">
+              <a:srgbClr val="000000">
+                <a:alpha val="12000"/>
+              </a:srgbClr>
+            </a:outerShdw>
+          </a:effectLst>
+        </p:spPr>
+      </p:sp>
+      <p:sp>
+        <p:nvSpPr>
+          <p:cNvPr id="14" name="Shape 12"/>
+          <p:cNvSpPr/>
+          <p:nvPr/>
+        </p:nvSpPr>
+        <p:spPr>
+          <a:xfrm>
+            <a:off x="457200" y="2560320"/>
+            <a:ext cx="45720" cy="521208"/>
+          </a:xfrm>
+          <a:prstGeom prst="rect">
+            <a:avLst/>
+          </a:prstGeom>
+          <a:solidFill>
+            <a:srgbClr val="1565C0"/>
+          </a:solidFill>
+          <a:ln/>
+        </p:spPr>
+      </p:sp>
+      <p:sp>
+        <p:nvSpPr>
+          <p:cNvPr id="15" name="Text 13"/>
+          <p:cNvSpPr/>
+          <p:nvPr/>
+        </p:nvSpPr>
+        <p:spPr>
+          <a:xfrm>
+            <a:off x="685800" y="2560320"/>
+            <a:ext cx="7818120" cy="521208"/>
+          </a:xfrm>
+          <a:prstGeom prst="rect">
+            <a:avLst/>
+          </a:prstGeom>
+          <a:noFill/>
+          <a:ln/>
+        </p:spPr>
+        <p:txBody>
+          <a:bodyPr wrap="square" lIns="0" tIns="0" rIns="0" bIns="0" rtlCol="0" anchor="ctr"/>
+          <a:lstStyle/>
+          <a:p>
+            <a:pPr indent="0" marL="0">
+              <a:buNone/>
+            </a:pPr>
+            <a:r>
+              <a:rPr lang="en-US" sz="1200" dirty="0">
                 <a:solidFill>
                   <a:srgbClr val="1A1A2E"/>
                 </a:solidFill>
@@ -3283,22 +3940,22 @@
                 <a:ea typeface="Calibri" pitchFamily="34" charset="-122"/>
                 <a:cs typeface="Calibri" pitchFamily="34" charset="-120"/>
               </a:rPr>
-              <a:t>DETERMINISTIC READS SQL DATA</a:t>
-            </a:r>
-            <a:endParaRPr lang="en-US" sz="1300" dirty="0"/>
-          </a:p>
-        </p:txBody>
-      </p:sp>
-      <p:sp>
-        <p:nvSpPr>
-          <p:cNvPr id="10" name="Shape 8"/>
-          <p:cNvSpPr/>
-          <p:nvPr/>
-        </p:nvSpPr>
-        <p:spPr>
-          <a:xfrm>
-            <a:off x="457200" y="2514600"/>
-            <a:ext cx="8229600" cy="640080"/>
+              <a:t>TRIGGER : se déclenche AUTOMATIQUEMENT</a:t>
+            </a:r>
+            <a:endParaRPr lang="en-US" sz="1200" dirty="0"/>
+          </a:p>
+        </p:txBody>
+      </p:sp>
+      <p:sp>
+        <p:nvSpPr>
+          <p:cNvPr id="16" name="Shape 14"/>
+          <p:cNvSpPr/>
+          <p:nvPr/>
+        </p:nvSpPr>
+        <p:spPr>
+          <a:xfrm>
+            <a:off x="457200" y="3108960"/>
+            <a:ext cx="8229600" cy="521208"/>
           </a:xfrm>
           <a:prstGeom prst="rect">
             <a:avLst/>
@@ -3318,14 +3975,14 @@
       </p:sp>
       <p:sp>
         <p:nvSpPr>
-          <p:cNvPr id="11" name="Shape 9"/>
-          <p:cNvSpPr/>
-          <p:nvPr/>
-        </p:nvSpPr>
-        <p:spPr>
-          <a:xfrm>
-            <a:off x="457200" y="2514600"/>
-            <a:ext cx="54864" cy="640080"/>
+          <p:cNvPr id="17" name="Shape 15"/>
+          <p:cNvSpPr/>
+          <p:nvPr/>
+        </p:nvSpPr>
+        <p:spPr>
+          <a:xfrm>
+            <a:off x="457200" y="3108960"/>
+            <a:ext cx="45720" cy="521208"/>
           </a:xfrm>
           <a:prstGeom prst="rect">
             <a:avLst/>
@@ -3338,14 +3995,14 @@
       </p:sp>
       <p:sp>
         <p:nvSpPr>
-          <p:cNvPr id="12" name="Text 10"/>
-          <p:cNvSpPr/>
-          <p:nvPr/>
-        </p:nvSpPr>
-        <p:spPr>
-          <a:xfrm>
-            <a:off x="731520" y="2514600"/>
-            <a:ext cx="7772400" cy="640080"/>
+          <p:cNvPr id="18" name="Text 16"/>
+          <p:cNvSpPr/>
+          <p:nvPr/>
+        </p:nvSpPr>
+        <p:spPr>
+          <a:xfrm>
+            <a:off x="685800" y="3108960"/>
+            <a:ext cx="7818120" cy="521208"/>
           </a:xfrm>
           <a:prstGeom prst="rect">
             <a:avLst/>
@@ -3361,7 +4018,7 @@
               <a:buNone/>
             </a:pPr>
             <a:r>
-              <a:rPr lang="en-US" sz="1100" dirty="0">
+              <a:rPr lang="en-US" sz="1000" dirty="0">
                 <a:solidFill>
                   <a:srgbClr val="0D47A1"/>
                 </a:solidFill>
@@ -3369,22 +4026,22 @@
                 <a:ea typeface="JetBrains Mono" pitchFamily="34" charset="-122"/>
                 <a:cs typeface="JetBrains Mono" pitchFamily="34" charset="-120"/>
               </a:rPr>
-              <a:t>BEGIN ... RETURN valeur; END</a:t>
-            </a:r>
-            <a:endParaRPr lang="en-US" sz="1100" dirty="0"/>
-          </a:p>
-        </p:txBody>
-      </p:sp>
-      <p:sp>
-        <p:nvSpPr>
-          <p:cNvPr id="13" name="Shape 11"/>
-          <p:cNvSpPr/>
-          <p:nvPr/>
-        </p:nvSpPr>
-        <p:spPr>
-          <a:xfrm>
-            <a:off x="457200" y="3246120"/>
-            <a:ext cx="8229600" cy="640080"/>
+              <a:t>CREATE TRIGGER trg_after_update_facture AFTER UPDATE ON facture ...</a:t>
+            </a:r>
+            <a:endParaRPr lang="en-US" sz="1000" dirty="0"/>
+          </a:p>
+        </p:txBody>
+      </p:sp>
+      <p:sp>
+        <p:nvSpPr>
+          <p:cNvPr id="19" name="Shape 17"/>
+          <p:cNvSpPr/>
+          <p:nvPr/>
+        </p:nvSpPr>
+        <p:spPr>
+          <a:xfrm>
+            <a:off x="457200" y="3657600"/>
+            <a:ext cx="8229600" cy="521208"/>
           </a:xfrm>
           <a:prstGeom prst="rect">
             <a:avLst/>
@@ -3404,14 +4061,14 @@
       </p:sp>
       <p:sp>
         <p:nvSpPr>
-          <p:cNvPr id="14" name="Shape 12"/>
-          <p:cNvSpPr/>
-          <p:nvPr/>
-        </p:nvSpPr>
-        <p:spPr>
-          <a:xfrm>
-            <a:off x="457200" y="3246120"/>
-            <a:ext cx="54864" cy="640080"/>
+          <p:cNvPr id="20" name="Shape 18"/>
+          <p:cNvSpPr/>
+          <p:nvPr/>
+        </p:nvSpPr>
+        <p:spPr>
+          <a:xfrm>
+            <a:off x="457200" y="3657600"/>
+            <a:ext cx="45720" cy="521208"/>
           </a:xfrm>
           <a:prstGeom prst="rect">
             <a:avLst/>
@@ -3424,14 +4081,14 @@
       </p:sp>
       <p:sp>
         <p:nvSpPr>
-          <p:cNvPr id="15" name="Text 13"/>
-          <p:cNvSpPr/>
-          <p:nvPr/>
-        </p:nvSpPr>
-        <p:spPr>
-          <a:xfrm>
-            <a:off x="731520" y="3246120"/>
-            <a:ext cx="7772400" cy="640080"/>
+          <p:cNvPr id="21" name="Text 19"/>
+          <p:cNvSpPr/>
+          <p:nvPr/>
+        </p:nvSpPr>
+        <p:spPr>
+          <a:xfrm>
+            <a:off x="685800" y="3657600"/>
+            <a:ext cx="7818120" cy="521208"/>
           </a:xfrm>
           <a:prstGeom prst="rect">
             <a:avLst/>
@@ -3447,30 +4104,30 @@
               <a:buNone/>
             </a:pPr>
             <a:r>
-              <a:rPr lang="en-US" sz="1100" dirty="0">
+              <a:rPr lang="en-US" sz="1200" dirty="0">
                 <a:solidFill>
-                  <a:srgbClr val="0D47A1"/>
+                  <a:srgbClr val="1A1A2E"/>
                 </a:solidFill>
-                <a:latin typeface="JetBrains Mono" pitchFamily="34" charset="0"/>
-                <a:ea typeface="JetBrains Mono" pitchFamily="34" charset="-122"/>
-                <a:cs typeface="JetBrains Mono" pitchFamily="34" charset="-120"/>
+                <a:latin typeface="Calibri" pitchFamily="34" charset="0"/>
+                <a:ea typeface="Calibri" pitchFamily="34" charset="-122"/>
+                <a:cs typeface="Calibri" pitchFamily="34" charset="-120"/>
               </a:rPr>
-              <a:t>Utilisation dans SELECT : SELECT nom, fn_ca_artiste(id) FROM artiste;</a:t>
-            </a:r>
-            <a:endParaRPr lang="en-US" sz="1100" dirty="0"/>
-          </a:p>
-        </p:txBody>
-      </p:sp>
-      <p:sp>
-        <p:nvSpPr>
-          <p:cNvPr id="16" name="Shape 14"/>
-          <p:cNvSpPr/>
-          <p:nvPr/>
-        </p:nvSpPr>
-        <p:spPr>
-          <a:xfrm>
-            <a:off x="457200" y="3977640"/>
-            <a:ext cx="8229600" cy="640080"/>
+              <a:t>Pas de CALL : le trigger s'exécute tout seul après INSERT/UPDATE/DELETE</a:t>
+            </a:r>
+            <a:endParaRPr lang="en-US" sz="1200" dirty="0"/>
+          </a:p>
+        </p:txBody>
+      </p:sp>
+      <p:sp>
+        <p:nvSpPr>
+          <p:cNvPr id="22" name="Shape 20"/>
+          <p:cNvSpPr/>
+          <p:nvPr/>
+        </p:nvSpPr>
+        <p:spPr>
+          <a:xfrm>
+            <a:off x="457200" y="4206240"/>
+            <a:ext cx="8229600" cy="521208"/>
           </a:xfrm>
           <a:prstGeom prst="rect">
             <a:avLst/>
@@ -3490,14 +4147,14 @@
       </p:sp>
       <p:sp>
         <p:nvSpPr>
-          <p:cNvPr id="17" name="Shape 15"/>
-          <p:cNvSpPr/>
-          <p:nvPr/>
-        </p:nvSpPr>
-        <p:spPr>
-          <a:xfrm>
-            <a:off x="457200" y="3977640"/>
-            <a:ext cx="54864" cy="640080"/>
+          <p:cNvPr id="23" name="Shape 21"/>
+          <p:cNvSpPr/>
+          <p:nvPr/>
+        </p:nvSpPr>
+        <p:spPr>
+          <a:xfrm>
+            <a:off x="457200" y="4206240"/>
+            <a:ext cx="45720" cy="521208"/>
           </a:xfrm>
           <a:prstGeom prst="rect">
             <a:avLst/>
@@ -3510,14 +4167,14 @@
       </p:sp>
       <p:sp>
         <p:nvSpPr>
-          <p:cNvPr id="18" name="Text 16"/>
-          <p:cNvSpPr/>
-          <p:nvPr/>
-        </p:nvSpPr>
-        <p:spPr>
-          <a:xfrm>
-            <a:off x="731520" y="3977640"/>
-            <a:ext cx="7772400" cy="640080"/>
+          <p:cNvPr id="24" name="Text 22"/>
+          <p:cNvSpPr/>
+          <p:nvPr/>
+        </p:nvSpPr>
+        <p:spPr>
+          <a:xfrm>
+            <a:off x="685800" y="4206240"/>
+            <a:ext cx="7818120" cy="521208"/>
           </a:xfrm>
           <a:prstGeom prst="rect">
             <a:avLst/>
@@ -3533,56 +4190,17 @@
               <a:buNone/>
             </a:pPr>
             <a:r>
-              <a:rPr lang="en-US" sz="1100" dirty="0">
+              <a:rPr lang="en-US" sz="1200" dirty="0">
                 <a:solidFill>
-                  <a:srgbClr val="0D47A1"/>
-                </a:solidFill>
-                <a:latin typeface="JetBrains Mono" pitchFamily="34" charset="0"/>
-                <a:ea typeface="JetBrains Mono" pitchFamily="34" charset="-122"/>
-                <a:cs typeface="JetBrains Mono" pitchFamily="34" charset="-120"/>
-              </a:rPr>
-              <a:t>Différence avec procédure : RETURNS obligatoire, pas de CALL</a:t>
-            </a:r>
-            <a:endParaRPr lang="en-US" sz="1100" dirty="0"/>
-          </a:p>
-        </p:txBody>
-      </p:sp>
-      <p:sp>
-        <p:nvSpPr>
-          <p:cNvPr id="19" name="Text 17"/>
-          <p:cNvSpPr/>
-          <p:nvPr/>
-        </p:nvSpPr>
-        <p:spPr>
-          <a:xfrm>
-            <a:off x="8229600" y="4754880"/>
-            <a:ext cx="731520" cy="274320"/>
-          </a:xfrm>
-          <a:prstGeom prst="rect">
-            <a:avLst/>
-          </a:prstGeom>
-          <a:noFill/>
-          <a:ln/>
-        </p:spPr>
-        <p:txBody>
-          <a:bodyPr wrap="square" lIns="0" tIns="0" rIns="0" bIns="0" rtlCol="0" anchor="ctr"/>
-          <a:lstStyle/>
-          <a:p>
-            <a:pPr algn="r" indent="0" marL="0">
-              <a:buNone/>
-            </a:pPr>
-            <a:r>
-              <a:rPr lang="en-US" sz="900" dirty="0">
-                <a:solidFill>
-                  <a:srgbClr val="AAAAAA"/>
+                  <a:srgbClr val="1A1A2E"/>
                 </a:solidFill>
                 <a:latin typeface="Calibri" pitchFamily="34" charset="0"/>
                 <a:ea typeface="Calibri" pitchFamily="34" charset="-122"/>
                 <a:cs typeface="Calibri" pitchFamily="34" charset="-120"/>
               </a:rPr>
-              <a:t>4/6</a:t>
-            </a:r>
-            <a:endParaRPr lang="en-US" sz="900" dirty="0"/>
+              <a:t>Voir sql/03_views_procedures_security.sql pour les exemples complets</a:t>
+            </a:r>
+            <a:endParaRPr lang="en-US" sz="1200" dirty="0"/>
           </a:p>
         </p:txBody>
       </p:sp>
@@ -3627,7 +4245,7 @@
         <p:spPr>
           <a:xfrm>
             <a:off x="0" y="0"/>
-            <a:ext cx="9144000" cy="73152"/>
+            <a:ext cx="9144000" cy="54864"/>
           </a:xfrm>
           <a:prstGeom prst="rect">
             <a:avLst/>
@@ -3646,8 +4264,8 @@
         </p:nvSpPr>
         <p:spPr>
           <a:xfrm>
-            <a:off x="457200" y="228600"/>
-            <a:ext cx="8229600" cy="640080"/>
+            <a:off x="457200" y="182880"/>
+            <a:ext cx="8229600" cy="594360"/>
           </a:xfrm>
           <a:prstGeom prst="rect">
             <a:avLst/>
@@ -3663,7 +4281,7 @@
               <a:buNone/>
             </a:pPr>
             <a:r>
-              <a:rPr lang="en-US" sz="2600" b="1" dirty="0">
+              <a:rPr lang="en-US" sz="2400" b="1" dirty="0">
                 <a:solidFill>
                   <a:srgbClr val="0D47A1"/>
                 </a:solidFill>
@@ -3671,9 +4289,9 @@
                 <a:ea typeface="Trebuchet MS" pitchFamily="34" charset="-122"/>
                 <a:cs typeface="Trebuchet MS" pitchFamily="34" charset="-120"/>
               </a:rPr>
-              <a:t>Triggers</a:t>
-            </a:r>
-            <a:endParaRPr lang="en-US" sz="2600" dirty="0"/>
+              <a:t>Exercice Module 15</a:t>
+            </a:r>
+            <a:endParaRPr lang="en-US" sz="2400" dirty="0"/>
           </a:p>
         </p:txBody>
       </p:sp>
@@ -3685,8 +4303,8 @@
         </p:nvSpPr>
         <p:spPr>
           <a:xfrm>
-            <a:off x="457200" y="1051560"/>
-            <a:ext cx="8229600" cy="640080"/>
+            <a:off x="457200" y="914400"/>
+            <a:ext cx="8229600" cy="521208"/>
           </a:xfrm>
           <a:prstGeom prst="rect">
             <a:avLst/>
@@ -3712,8 +4330,8 @@
         </p:nvSpPr>
         <p:spPr>
           <a:xfrm>
-            <a:off x="457200" y="1051560"/>
-            <a:ext cx="54864" cy="640080"/>
+            <a:off x="457200" y="914400"/>
+            <a:ext cx="45720" cy="521208"/>
           </a:xfrm>
           <a:prstGeom prst="rect">
             <a:avLst/>
@@ -3732,8 +4350,8 @@
         </p:nvSpPr>
         <p:spPr>
           <a:xfrm>
-            <a:off x="731520" y="1051560"/>
-            <a:ext cx="7772400" cy="640080"/>
+            <a:off x="685800" y="914400"/>
+            <a:ext cx="7818120" cy="521208"/>
           </a:xfrm>
           <a:prstGeom prst="rect">
             <a:avLst/>
@@ -3749,17 +4367,17 @@
               <a:buNone/>
             </a:pPr>
             <a:r>
-              <a:rPr lang="en-US" sz="1100" dirty="0">
+              <a:rPr lang="en-US" sz="1200" dirty="0">
                 <a:solidFill>
-                  <a:srgbClr val="0D47A1"/>
+                  <a:srgbClr val="1A1A2E"/>
                 </a:solidFill>
-                <a:latin typeface="JetBrains Mono" pitchFamily="34" charset="0"/>
-                <a:ea typeface="JetBrains Mono" pitchFamily="34" charset="-122"/>
-                <a:cs typeface="JetBrains Mono" pitchFamily="34" charset="-120"/>
+                <a:latin typeface="Calibri" pitchFamily="34" charset="0"/>
+                <a:ea typeface="Calibri" pitchFamily="34" charset="-122"/>
+                <a:cs typeface="Calibri" pitchFamily="34" charset="-120"/>
               </a:rPr>
-              <a:t>Déclencheur automatique sur INSERT/UPDATE/DELETE</a:t>
-            </a:r>
-            <a:endParaRPr lang="en-US" sz="1100" dirty="0"/>
+              <a:t>Créer 3 vues : v_artistes_actifs, v_sessions_mois, v_dashboard_ca</a:t>
+            </a:r>
+            <a:endParaRPr lang="en-US" sz="1200" dirty="0"/>
           </a:p>
         </p:txBody>
       </p:sp>
@@ -3771,8 +4389,8 @@
         </p:nvSpPr>
         <p:spPr>
           <a:xfrm>
-            <a:off x="457200" y="1783080"/>
-            <a:ext cx="8229600" cy="640080"/>
+            <a:off x="457200" y="1463040"/>
+            <a:ext cx="8229600" cy="521208"/>
           </a:xfrm>
           <a:prstGeom prst="rect">
             <a:avLst/>
@@ -3798,8 +4416,8 @@
         </p:nvSpPr>
         <p:spPr>
           <a:xfrm>
-            <a:off x="457200" y="1783080"/>
-            <a:ext cx="54864" cy="640080"/>
+            <a:off x="457200" y="1463040"/>
+            <a:ext cx="45720" cy="521208"/>
           </a:xfrm>
           <a:prstGeom prst="rect">
             <a:avLst/>
@@ -3818,8 +4436,8 @@
         </p:nvSpPr>
         <p:spPr>
           <a:xfrm>
-            <a:off x="731520" y="1783080"/>
-            <a:ext cx="7772400" cy="640080"/>
+            <a:off x="685800" y="1463040"/>
+            <a:ext cx="7818120" cy="521208"/>
           </a:xfrm>
           <a:prstGeom prst="rect">
             <a:avLst/>
@@ -3835,7 +4453,7 @@
               <a:buNone/>
             </a:pPr>
             <a:r>
-              <a:rPr lang="en-US" sz="1300" dirty="0">
+              <a:rPr lang="en-US" sz="1200" dirty="0">
                 <a:solidFill>
                   <a:srgbClr val="1A1A2E"/>
                 </a:solidFill>
@@ -3843,9 +4461,9 @@
                 <a:ea typeface="Calibri" pitchFamily="34" charset="-122"/>
                 <a:cs typeface="Calibri" pitchFamily="34" charset="-120"/>
               </a:rPr>
-              <a:t>BEFORE ou AFTER l'opération</a:t>
-            </a:r>
-            <a:endParaRPr lang="en-US" sz="1300" dirty="0"/>
+              <a:t>Créer la procédure sp_ajouter_session avec vérification de disponibilité</a:t>
+            </a:r>
+            <a:endParaRPr lang="en-US" sz="1200" dirty="0"/>
           </a:p>
         </p:txBody>
       </p:sp>
@@ -3857,8 +4475,8 @@
         </p:nvSpPr>
         <p:spPr>
           <a:xfrm>
-            <a:off x="457200" y="2514600"/>
-            <a:ext cx="8229600" cy="640080"/>
+            <a:off x="457200" y="2011680"/>
+            <a:ext cx="8229600" cy="521208"/>
           </a:xfrm>
           <a:prstGeom prst="rect">
             <a:avLst/>
@@ -3884,8 +4502,8 @@
         </p:nvSpPr>
         <p:spPr>
           <a:xfrm>
-            <a:off x="457200" y="2514600"/>
-            <a:ext cx="54864" cy="640080"/>
+            <a:off x="457200" y="2011680"/>
+            <a:ext cx="45720" cy="521208"/>
           </a:xfrm>
           <a:prstGeom prst="rect">
             <a:avLst/>
@@ -3904,8 +4522,8 @@
         </p:nvSpPr>
         <p:spPr>
           <a:xfrm>
-            <a:off x="731520" y="2514600"/>
-            <a:ext cx="7772400" cy="640080"/>
+            <a:off x="685800" y="2011680"/>
+            <a:ext cx="7818120" cy="521208"/>
           </a:xfrm>
           <a:prstGeom prst="rect">
             <a:avLst/>
@@ -3921,17 +4539,17 @@
               <a:buNone/>
             </a:pPr>
             <a:r>
-              <a:rPr lang="en-US" sz="1100" dirty="0">
+              <a:rPr lang="en-US" sz="1200" dirty="0">
                 <a:solidFill>
-                  <a:srgbClr val="0D47A1"/>
+                  <a:srgbClr val="1A1A2E"/>
                 </a:solidFill>
-                <a:latin typeface="JetBrains Mono" pitchFamily="34" charset="0"/>
-                <a:ea typeface="JetBrains Mono" pitchFamily="34" charset="-122"/>
-                <a:cs typeface="JetBrains Mono" pitchFamily="34" charset="-120"/>
+                <a:latin typeface="Calibri" pitchFamily="34" charset="0"/>
+                <a:ea typeface="Calibri" pitchFamily="34" charset="-122"/>
+                <a:cs typeface="Calibri" pitchFamily="34" charset="-120"/>
               </a:rPr>
-              <a:t>CREATE TRIGGER trg_nom AFTER UPDATE ON facture FOR EACH ROW</a:t>
-            </a:r>
-            <a:endParaRPr lang="en-US" sz="1100" dirty="0"/>
+              <a:t>Créer la fonction fn_ca_artiste(id) qui retourne le CA payé</a:t>
+            </a:r>
+            <a:endParaRPr lang="en-US" sz="1200" dirty="0"/>
           </a:p>
         </p:txBody>
       </p:sp>
@@ -3943,8 +4561,8 @@
         </p:nvSpPr>
         <p:spPr>
           <a:xfrm>
-            <a:off x="457200" y="3246120"/>
-            <a:ext cx="8229600" cy="640080"/>
+            <a:off x="457200" y="2560320"/>
+            <a:ext cx="8229600" cy="521208"/>
           </a:xfrm>
           <a:prstGeom prst="rect">
             <a:avLst/>
@@ -3970,8 +4588,8 @@
         </p:nvSpPr>
         <p:spPr>
           <a:xfrm>
-            <a:off x="457200" y="3246120"/>
-            <a:ext cx="54864" cy="640080"/>
+            <a:off x="457200" y="2560320"/>
+            <a:ext cx="45720" cy="521208"/>
           </a:xfrm>
           <a:prstGeom prst="rect">
             <a:avLst/>
@@ -3990,8 +4608,8 @@
         </p:nvSpPr>
         <p:spPr>
           <a:xfrm>
-            <a:off x="731520" y="3246120"/>
-            <a:ext cx="7772400" cy="640080"/>
+            <a:off x="685800" y="2560320"/>
+            <a:ext cx="7818120" cy="521208"/>
           </a:xfrm>
           <a:prstGeom prst="rect">
             <a:avLst/>
@@ -4007,17 +4625,17 @@
               <a:buNone/>
             </a:pPr>
             <a:r>
-              <a:rPr lang="en-US" sz="1100" dirty="0">
+              <a:rPr lang="en-US" sz="1200" dirty="0">
                 <a:solidFill>
-                  <a:srgbClr val="0D47A1"/>
+                  <a:srgbClr val="1A1A2E"/>
                 </a:solidFill>
-                <a:latin typeface="JetBrains Mono" pitchFamily="34" charset="0"/>
-                <a:ea typeface="JetBrains Mono" pitchFamily="34" charset="-122"/>
-                <a:cs typeface="JetBrains Mono" pitchFamily="34" charset="-120"/>
+                <a:latin typeface="Calibri" pitchFamily="34" charset="0"/>
+                <a:ea typeface="Calibri" pitchFamily="34" charset="-122"/>
+                <a:cs typeface="Calibri" pitchFamily="34" charset="-120"/>
               </a:rPr>
-              <a:t>BEGIN ... utiliser NEW.colonne et OLD.colonne ... END</a:t>
-            </a:r>
-            <a:endParaRPr lang="en-US" sz="1100" dirty="0"/>
+              <a:t>Créer un trigger qui met à jour le statut session quand facture payée</a:t>
+            </a:r>
+            <a:endParaRPr lang="en-US" sz="1200" dirty="0"/>
           </a:p>
         </p:txBody>
       </p:sp>
@@ -4029,8 +4647,8 @@
         </p:nvSpPr>
         <p:spPr>
           <a:xfrm>
-            <a:off x="457200" y="3977640"/>
-            <a:ext cx="8229600" cy="640080"/>
+            <a:off x="457200" y="3108960"/>
+            <a:ext cx="8229600" cy="521208"/>
           </a:xfrm>
           <a:prstGeom prst="rect">
             <a:avLst/>
@@ -4056,8 +4674,8 @@
         </p:nvSpPr>
         <p:spPr>
           <a:xfrm>
-            <a:off x="457200" y="3977640"/>
-            <a:ext cx="54864" cy="640080"/>
+            <a:off x="457200" y="3108960"/>
+            <a:ext cx="45720" cy="521208"/>
           </a:xfrm>
           <a:prstGeom prst="rect">
             <a:avLst/>
@@ -4076,8 +4694,8 @@
         </p:nvSpPr>
         <p:spPr>
           <a:xfrm>
-            <a:off x="731520" y="3977640"/>
-            <a:ext cx="7772400" cy="640080"/>
+            <a:off x="685800" y="3108960"/>
+            <a:ext cx="7818120" cy="521208"/>
           </a:xfrm>
           <a:prstGeom prst="rect">
             <a:avLst/>
@@ -4093,7 +4711,7 @@
               <a:buNone/>
             </a:pPr>
             <a:r>
-              <a:rPr lang="en-US" sz="1300" dirty="0">
+              <a:rPr lang="en-US" sz="1200" dirty="0">
                 <a:solidFill>
                   <a:srgbClr val="1A1A2E"/>
                 </a:solidFill>
@@ -4101,22 +4719,69 @@
                 <a:ea typeface="Calibri" pitchFamily="34" charset="-122"/>
                 <a:cs typeface="Calibri" pitchFamily="34" charset="-120"/>
               </a:rPr>
-              <a:t>Exemple : mettre à jour le statut session quand facture payée</a:t>
-            </a:r>
-            <a:endParaRPr lang="en-US" sz="1300" dirty="0"/>
-          </a:p>
-        </p:txBody>
-      </p:sp>
-      <p:sp>
-        <p:nvSpPr>
-          <p:cNvPr id="19" name="Text 17"/>
-          <p:cNvSpPr/>
-          <p:nvPr/>
-        </p:nvSpPr>
-        <p:spPr>
-          <a:xfrm>
-            <a:off x="8229600" y="4754880"/>
-            <a:ext cx="731520" cy="274320"/>
+              <a:t>Tester chaque vue avec SELECT, chaque procédure avec CALL</a:t>
+            </a:r>
+            <a:endParaRPr lang="en-US" sz="1200" dirty="0"/>
+          </a:p>
+        </p:txBody>
+      </p:sp>
+      <p:sp>
+        <p:nvSpPr>
+          <p:cNvPr id="19" name="Shape 17"/>
+          <p:cNvSpPr/>
+          <p:nvPr/>
+        </p:nvSpPr>
+        <p:spPr>
+          <a:xfrm>
+            <a:off x="457200" y="3657600"/>
+            <a:ext cx="8229600" cy="521208"/>
+          </a:xfrm>
+          <a:prstGeom prst="rect">
+            <a:avLst/>
+          </a:prstGeom>
+          <a:solidFill>
+            <a:srgbClr val="E3F2FD"/>
+          </a:solidFill>
+          <a:ln/>
+          <a:effectLst>
+            <a:outerShdw sx="100000" sy="100000" kx="0" ky="0" algn="bl" rotWithShape="0" blurRad="50800" dist="25400" dir="8100000">
+              <a:srgbClr val="000000">
+                <a:alpha val="12000"/>
+              </a:srgbClr>
+            </a:outerShdw>
+          </a:effectLst>
+        </p:spPr>
+      </p:sp>
+      <p:sp>
+        <p:nvSpPr>
+          <p:cNvPr id="20" name="Shape 18"/>
+          <p:cNvSpPr/>
+          <p:nvPr/>
+        </p:nvSpPr>
+        <p:spPr>
+          <a:xfrm>
+            <a:off x="457200" y="3657600"/>
+            <a:ext cx="45720" cy="521208"/>
+          </a:xfrm>
+          <a:prstGeom prst="rect">
+            <a:avLst/>
+          </a:prstGeom>
+          <a:solidFill>
+            <a:srgbClr val="1565C0"/>
+          </a:solidFill>
+          <a:ln/>
+        </p:spPr>
+      </p:sp>
+      <p:sp>
+        <p:nvSpPr>
+          <p:cNvPr id="21" name="Text 19"/>
+          <p:cNvSpPr/>
+          <p:nvPr/>
+        </p:nvSpPr>
+        <p:spPr>
+          <a:xfrm>
+            <a:off x="685800" y="3657600"/>
+            <a:ext cx="7818120" cy="521208"/>
           </a:xfrm>
           <a:prstGeom prst="rect">
             <a:avLst/>
@@ -4128,21 +4793,21 @@
           <a:bodyPr wrap="square" lIns="0" tIns="0" rIns="0" bIns="0" rtlCol="0" anchor="ctr"/>
           <a:lstStyle/>
           <a:p>
-            <a:pPr algn="r" indent="0" marL="0">
+            <a:pPr indent="0" marL="0">
               <a:buNone/>
             </a:pPr>
             <a:r>
-              <a:rPr lang="en-US" sz="900" dirty="0">
+              <a:rPr lang="en-US" sz="1200" dirty="0">
                 <a:solidFill>
-                  <a:srgbClr val="AAAAAA"/>
+                  <a:srgbClr val="1A1A2E"/>
                 </a:solidFill>
                 <a:latin typeface="Calibri" pitchFamily="34" charset="0"/>
                 <a:ea typeface="Calibri" pitchFamily="34" charset="-122"/>
                 <a:cs typeface="Calibri" pitchFamily="34" charset="-120"/>
               </a:rPr>
-              <a:t>5/6</a:t>
-            </a:r>
-            <a:endParaRPr lang="en-US" sz="900" dirty="0"/>
+              <a:t>DÉFI : procédure avec gestion d'erreurs (DECLARE HANDLER)</a:t>
+            </a:r>
+            <a:endParaRPr lang="en-US" sz="1200" dirty="0"/>
           </a:p>
         </p:txBody>
       </p:sp>
@@ -4178,39 +4843,51 @@
           <a:chExt cx="0" cy="0"/>
         </a:xfrm>
       </p:grpSpPr>
-      <p:pic>
-        <p:nvPicPr>
-          <p:cNvPr id="2" name="Image 0" descr="preencoded.png">    </p:cNvPr>
-          <p:cNvPicPr>
-            <a:picLocks noChangeAspect="1"/>
-          </p:cNvPicPr>
-          <p:nvPr/>
-        </p:nvPicPr>
-        <p:blipFill>
-          <a:blip r:embed="rId1"/>
-          <a:stretch>
-            <a:fillRect/>
-          </a:stretch>
-        </p:blipFill>
-        <p:spPr>
-          <a:xfrm>
-            <a:off x="4023360" y="457200"/>
-            <a:ext cx="1097280" cy="1097280"/>
-          </a:xfrm>
-          <a:prstGeom prst="rect">
-            <a:avLst/>
-          </a:prstGeom>
-        </p:spPr>
-      </p:pic>
-      <p:sp>
-        <p:nvSpPr>
-          <p:cNvPr id="3" name="Text 0"/>
-          <p:cNvSpPr/>
-          <p:nvPr/>
-        </p:nvSpPr>
-        <p:spPr>
-          <a:xfrm>
-            <a:off x="457200" y="1737360"/>
+      <p:sp>
+        <p:nvSpPr>
+          <p:cNvPr id="2" name="Text 0"/>
+          <p:cNvSpPr/>
+          <p:nvPr/>
+        </p:nvSpPr>
+        <p:spPr>
+          <a:xfrm>
+            <a:off x="3840480" y="457200"/>
+            <a:ext cx="1463040" cy="1097280"/>
+          </a:xfrm>
+          <a:prstGeom prst="rect">
+            <a:avLst/>
+          </a:prstGeom>
+          <a:noFill/>
+          <a:ln/>
+        </p:spPr>
+        <p:txBody>
+          <a:bodyPr wrap="square" lIns="0" tIns="0" rIns="0" bIns="0" rtlCol="0" anchor="ctr"/>
+          <a:lstStyle/>
+          <a:p>
+            <a:pPr algn="ctr" indent="0" marL="0">
+              <a:buNone/>
+            </a:pPr>
+            <a:r>
+              <a:rPr lang="en-US" sz="6000" dirty="0">
+                <a:solidFill>
+                  <a:srgbClr val="000000"/>
+                </a:solidFill>
+              </a:rPr>
+              <a:t>🎮</a:t>
+            </a:r>
+            <a:endParaRPr lang="en-US" sz="6000" dirty="0"/>
+          </a:p>
+        </p:txBody>
+      </p:sp>
+      <p:sp>
+        <p:nvSpPr>
+          <p:cNvPr id="3" name="Text 1"/>
+          <p:cNvSpPr/>
+          <p:nvPr/>
+        </p:nvSpPr>
+        <p:spPr>
+          <a:xfrm>
+            <a:off x="457200" y="1645920"/>
             <a:ext cx="8229600" cy="548640"/>
           </a:xfrm>
           <a:prstGeom prst="rect">
@@ -4235,7 +4912,7 @@
                 <a:ea typeface="Trebuchet MS" pitchFamily="34" charset="-122"/>
                 <a:cs typeface="Trebuchet MS" pitchFamily="34" charset="-120"/>
               </a:rPr>
-              <a:t>🎮 Mini-jeu : Module 15</a:t>
+              <a:t>Mini-jeu : Le Masque de la Vue</a:t>
             </a:r>
             <a:endParaRPr lang="en-US" sz="2600" dirty="0"/>
           </a:p>
@@ -4243,14 +4920,14 @@
       </p:sp>
       <p:sp>
         <p:nvSpPr>
-          <p:cNvPr id="4" name="Text 1"/>
-          <p:cNvSpPr/>
-          <p:nvPr/>
-        </p:nvSpPr>
-        <p:spPr>
-          <a:xfrm>
-            <a:off x="914400" y="2377440"/>
-            <a:ext cx="7315200" cy="457200"/>
+          <p:cNvPr id="4" name="Text 2"/>
+          <p:cNvSpPr/>
+          <p:nvPr/>
+        </p:nvSpPr>
+        <p:spPr>
+          <a:xfrm>
+            <a:off x="1371600" y="2286000"/>
+            <a:ext cx="6400800" cy="731520"/>
           </a:xfrm>
           <a:prstGeom prst="rect">
             <a:avLst/>
@@ -4274,7 +4951,7 @@
                 <a:ea typeface="Calibri" pitchFamily="34" charset="-122"/>
                 <a:cs typeface="Calibri" pitchFamily="34" charset="-120"/>
               </a:rPr>
-              <a:t>Quiz interactif + Score + Correction automatique</a:t>
+              <a:t>Placez les bons masques pour filtrer les données !</a:t>
             </a:r>
             <a:endParaRPr lang="en-US" sz="1400" dirty="0"/>
           </a:p>
@@ -4282,13 +4959,13 @@
       </p:sp>
       <p:sp>
         <p:nvSpPr>
-          <p:cNvPr id="5" name="Shape 2"/>
-          <p:cNvSpPr/>
-          <p:nvPr/>
-        </p:nvSpPr>
-        <p:spPr>
-          <a:xfrm>
-            <a:off x="2286000" y="3200400"/>
+          <p:cNvPr id="5" name="Shape 3"/>
+          <p:cNvSpPr/>
+          <p:nvPr/>
+        </p:nvSpPr>
+        <p:spPr>
+          <a:xfrm>
+            <a:off x="2286000" y="3291840"/>
             <a:ext cx="4572000" cy="548640"/>
           </a:xfrm>
           <a:prstGeom prst="rect">
@@ -4302,13 +4979,13 @@
       </p:sp>
       <p:sp>
         <p:nvSpPr>
-          <p:cNvPr id="6" name="Text 3"/>
-          <p:cNvSpPr/>
-          <p:nvPr/>
-        </p:nvSpPr>
-        <p:spPr>
-          <a:xfrm>
-            <a:off x="2286000" y="3200400"/>
+          <p:cNvPr id="6" name="Text 4"/>
+          <p:cNvSpPr/>
+          <p:nvPr/>
+        </p:nvSpPr>
+        <p:spPr>
+          <a:xfrm>
+            <a:off x="2286000" y="3291840"/>
             <a:ext cx="4572000" cy="548640"/>
           </a:xfrm>
           <a:prstGeom prst="rect">
@@ -4333,7 +5010,7 @@
                 <a:ea typeface="Trebuchet MS" pitchFamily="34" charset="-122"/>
                 <a:cs typeface="Trebuchet MS" pitchFamily="34" charset="-120"/>
               </a:rPr>
-              <a:t>▶  Lancer le jeu sur Vercel</a:t>
+              <a:t>▶  Lancer le jeu</a:t>
             </a:r>
             <a:endParaRPr lang="en-US" sz="1800" dirty="0"/>
           </a:p>
@@ -4379,8 +5056,8 @@
         </p:nvSpPr>
         <p:spPr>
           <a:xfrm>
-            <a:off x="457200" y="228600"/>
-            <a:ext cx="8229600" cy="457200"/>
+            <a:off x="457200" y="137160"/>
+            <a:ext cx="5486400" cy="411480"/>
           </a:xfrm>
           <a:prstGeom prst="rect">
             <a:avLst/>
@@ -4396,7 +5073,7 @@
               <a:buNone/>
             </a:pPr>
             <a:r>
-              <a:rPr lang="en-US" sz="2000" b="1" dirty="0">
+              <a:rPr lang="en-US" sz="1800" b="1" dirty="0">
                 <a:solidFill>
                   <a:srgbClr val="0D47A1"/>
                 </a:solidFill>
@@ -4404,9 +5081,9 @@
                 <a:ea typeface="Trebuchet MS" pitchFamily="34" charset="-122"/>
                 <a:cs typeface="Trebuchet MS" pitchFamily="34" charset="-120"/>
               </a:rPr>
-              <a:t>📋 Mémo Module 15 — Vues, procédures, fonctions</a:t>
-            </a:r>
-            <a:endParaRPr lang="en-US" sz="2000" dirty="0"/>
+              <a:t>📋 Mémo Module 15</a:t>
+            </a:r>
+            <a:endParaRPr lang="en-US" sz="1800" dirty="0"/>
           </a:p>
         </p:txBody>
       </p:sp>
@@ -4418,8 +5095,8 @@
         </p:nvSpPr>
         <p:spPr>
           <a:xfrm>
-            <a:off x="457200" y="731520"/>
-            <a:ext cx="8229600" cy="320040"/>
+            <a:off x="457200" y="548640"/>
+            <a:ext cx="8229600" cy="274320"/>
           </a:xfrm>
           <a:prstGeom prst="rect">
             <a:avLst/>
@@ -4438,8 +5115,8 @@
         </p:nvSpPr>
         <p:spPr>
           <a:xfrm>
-            <a:off x="640080" y="731520"/>
-            <a:ext cx="7772400" cy="320040"/>
+            <a:off x="640080" y="548640"/>
+            <a:ext cx="7772400" cy="274320"/>
           </a:xfrm>
           <a:prstGeom prst="rect">
             <a:avLst/>
@@ -4455,7 +5132,7 @@
               <a:buNone/>
             </a:pPr>
             <a:r>
-              <a:rPr lang="en-US" sz="1000" b="1" dirty="0">
+              <a:rPr lang="en-US" sz="900" b="1" dirty="0">
                 <a:solidFill>
                   <a:srgbClr val="E65100"/>
                 </a:solidFill>
@@ -4463,9 +5140,9 @@
                 <a:ea typeface="Calibri" pitchFamily="34" charset="-122"/>
                 <a:cs typeface="Calibri" pitchFamily="34" charset="-120"/>
               </a:rPr>
-              <a:t>🔒 Ce mémo se débloque quand toutes les phases du module sont terminées !</a:t>
-            </a:r>
-            <a:endParaRPr lang="en-US" sz="1000" dirty="0"/>
+              <a:t>🔒 Déblocable après complétion</a:t>
+            </a:r>
+            <a:endParaRPr lang="en-US" sz="900" dirty="0"/>
           </a:p>
         </p:txBody>
       </p:sp>
@@ -4477,8 +5154,8 @@
         </p:nvSpPr>
         <p:spPr>
           <a:xfrm>
-            <a:off x="457200" y="1188720"/>
-            <a:ext cx="8229600" cy="713232"/>
+            <a:off x="457200" y="960120"/>
+            <a:ext cx="2286000" cy="475488"/>
           </a:xfrm>
           <a:prstGeom prst="rect">
             <a:avLst/>
@@ -4497,8 +5174,8 @@
         </p:nvSpPr>
         <p:spPr>
           <a:xfrm>
-            <a:off x="640080" y="1188720"/>
-            <a:ext cx="2560320" cy="713232"/>
+            <a:off x="548640" y="960120"/>
+            <a:ext cx="2103120" cy="475488"/>
           </a:xfrm>
           <a:prstGeom prst="rect">
             <a:avLst/>
@@ -4514,7 +5191,7 @@
               <a:buNone/>
             </a:pPr>
             <a:r>
-              <a:rPr lang="en-US" sz="1000" b="1" dirty="0">
+              <a:rPr lang="en-US" sz="900" b="1" dirty="0">
                 <a:solidFill>
                   <a:srgbClr val="0D47A1"/>
                 </a:solidFill>
@@ -4522,22 +5199,42 @@
                 <a:ea typeface="Trebuchet MS" pitchFamily="34" charset="-122"/>
                 <a:cs typeface="Trebuchet MS" pitchFamily="34" charset="-120"/>
               </a:rPr>
-              <a:t>Vues (VIEW)</a:t>
-            </a:r>
-            <a:endParaRPr lang="en-US" sz="1000" dirty="0"/>
-          </a:p>
-        </p:txBody>
-      </p:sp>
-      <p:sp>
-        <p:nvSpPr>
-          <p:cNvPr id="7" name="Text 5"/>
-          <p:cNvSpPr/>
-          <p:nvPr/>
-        </p:nvSpPr>
-        <p:spPr>
-          <a:xfrm>
-            <a:off x="3291840" y="1188720"/>
-            <a:ext cx="5212080" cy="713232"/>
+              <a:t>VIEW</a:t>
+            </a:r>
+            <a:endParaRPr lang="en-US" sz="900" dirty="0"/>
+          </a:p>
+        </p:txBody>
+      </p:sp>
+      <p:sp>
+        <p:nvSpPr>
+          <p:cNvPr id="7" name="Shape 5"/>
+          <p:cNvSpPr/>
+          <p:nvPr/>
+        </p:nvSpPr>
+        <p:spPr>
+          <a:xfrm>
+            <a:off x="2743200" y="960120"/>
+            <a:ext cx="5943600" cy="475488"/>
+          </a:xfrm>
+          <a:prstGeom prst="rect">
+            <a:avLst/>
+          </a:prstGeom>
+          <a:solidFill>
+            <a:srgbClr val="E3F2FD"/>
+          </a:solidFill>
+          <a:ln/>
+        </p:spPr>
+      </p:sp>
+      <p:sp>
+        <p:nvSpPr>
+          <p:cNvPr id="8" name="Text 6"/>
+          <p:cNvSpPr/>
+          <p:nvPr/>
+        </p:nvSpPr>
+        <p:spPr>
+          <a:xfrm>
+            <a:off x="2834640" y="960120"/>
+            <a:ext cx="5760720" cy="475488"/>
           </a:xfrm>
           <a:prstGeom prst="rect">
             <a:avLst/>
@@ -4561,7 +5258,7 @@
                 <a:ea typeface="Calibri" pitchFamily="34" charset="-122"/>
                 <a:cs typeface="Calibri" pitchFamily="34" charset="-120"/>
               </a:rPr>
-              <a:t>CREATE VIEW v_artistes_actifs AS SELECT ... WHERE actif = TRUE; | Requête enregistrée qui se comporte comme une table vi...</a:t>
+              <a:t>Requête sauvegardée = table virtuelle, pas de stockage</a:t>
             </a:r>
             <a:endParaRPr lang="en-US" sz="900" dirty="0"/>
           </a:p>
@@ -4569,34 +5266,34 @@
       </p:sp>
       <p:sp>
         <p:nvSpPr>
-          <p:cNvPr id="8" name="Shape 6"/>
-          <p:cNvSpPr/>
-          <p:nvPr/>
-        </p:nvSpPr>
-        <p:spPr>
-          <a:xfrm>
-            <a:off x="457200" y="1965960"/>
-            <a:ext cx="8229600" cy="713232"/>
-          </a:xfrm>
-          <a:prstGeom prst="rect">
-            <a:avLst/>
-          </a:prstGeom>
-          <a:solidFill>
-            <a:srgbClr val="FFFFFF"/>
-          </a:solidFill>
-          <a:ln/>
-        </p:spPr>
-      </p:sp>
-      <p:sp>
-        <p:nvSpPr>
-          <p:cNvPr id="9" name="Text 7"/>
-          <p:cNvSpPr/>
-          <p:nvPr/>
-        </p:nvSpPr>
-        <p:spPr>
-          <a:xfrm>
-            <a:off x="640080" y="1965960"/>
-            <a:ext cx="2560320" cy="713232"/>
+          <p:cNvPr id="9" name="Shape 7"/>
+          <p:cNvSpPr/>
+          <p:nvPr/>
+        </p:nvSpPr>
+        <p:spPr>
+          <a:xfrm>
+            <a:off x="457200" y="1463040"/>
+            <a:ext cx="2286000" cy="475488"/>
+          </a:xfrm>
+          <a:prstGeom prst="rect">
+            <a:avLst/>
+          </a:prstGeom>
+          <a:solidFill>
+            <a:srgbClr val="F0F0F0"/>
+          </a:solidFill>
+          <a:ln/>
+        </p:spPr>
+      </p:sp>
+      <p:sp>
+        <p:nvSpPr>
+          <p:cNvPr id="10" name="Text 8"/>
+          <p:cNvSpPr/>
+          <p:nvPr/>
+        </p:nvSpPr>
+        <p:spPr>
+          <a:xfrm>
+            <a:off x="548640" y="1463040"/>
+            <a:ext cx="2103120" cy="475488"/>
           </a:xfrm>
           <a:prstGeom prst="rect">
             <a:avLst/>
@@ -4612,7 +5309,7 @@
               <a:buNone/>
             </a:pPr>
             <a:r>
-              <a:rPr lang="en-US" sz="1000" b="1" dirty="0">
+              <a:rPr lang="en-US" sz="900" b="1" dirty="0">
                 <a:solidFill>
                   <a:srgbClr val="0D47A1"/>
                 </a:solidFill>
@@ -4620,22 +5317,42 @@
                 <a:ea typeface="Trebuchet MS" pitchFamily="34" charset="-122"/>
                 <a:cs typeface="Trebuchet MS" pitchFamily="34" charset="-120"/>
               </a:rPr>
-              <a:t>Procédures stockées</a:t>
-            </a:r>
-            <a:endParaRPr lang="en-US" sz="1000" dirty="0"/>
-          </a:p>
-        </p:txBody>
-      </p:sp>
-      <p:sp>
-        <p:nvSpPr>
-          <p:cNvPr id="10" name="Text 8"/>
-          <p:cNvSpPr/>
-          <p:nvPr/>
-        </p:nvSpPr>
-        <p:spPr>
-          <a:xfrm>
-            <a:off x="3291840" y="1965960"/>
-            <a:ext cx="5212080" cy="713232"/>
+              <a:t>PROCEDURE</a:t>
+            </a:r>
+            <a:endParaRPr lang="en-US" sz="900" dirty="0"/>
+          </a:p>
+        </p:txBody>
+      </p:sp>
+      <p:sp>
+        <p:nvSpPr>
+          <p:cNvPr id="11" name="Shape 9"/>
+          <p:cNvSpPr/>
+          <p:nvPr/>
+        </p:nvSpPr>
+        <p:spPr>
+          <a:xfrm>
+            <a:off x="2743200" y="1463040"/>
+            <a:ext cx="5943600" cy="475488"/>
+          </a:xfrm>
+          <a:prstGeom prst="rect">
+            <a:avLst/>
+          </a:prstGeom>
+          <a:solidFill>
+            <a:srgbClr val="F0F0F0"/>
+          </a:solidFill>
+          <a:ln/>
+        </p:spPr>
+      </p:sp>
+      <p:sp>
+        <p:nvSpPr>
+          <p:cNvPr id="12" name="Text 10"/>
+          <p:cNvSpPr/>
+          <p:nvPr/>
+        </p:nvSpPr>
+        <p:spPr>
+          <a:xfrm>
+            <a:off x="2834640" y="1463040"/>
+            <a:ext cx="5760720" cy="475488"/>
           </a:xfrm>
           <a:prstGeom prst="rect">
             <a:avLst/>
@@ -4659,7 +5376,7 @@
                 <a:ea typeface="Calibri" pitchFamily="34" charset="-122"/>
                 <a:cs typeface="Calibri" pitchFamily="34" charset="-120"/>
               </a:rPr>
-              <a:t>DELIMITER // | CREATE PROCEDURE sp_ajouter_session(IN p_date DATE, ...) | BEGIN</a:t>
+              <a:t>Bloc de code avec paramètres IN/OUT, CALL pour exécuter</a:t>
             </a:r>
             <a:endParaRPr lang="en-US" sz="900" dirty="0"/>
           </a:p>
@@ -4667,14 +5384,14 @@
       </p:sp>
       <p:sp>
         <p:nvSpPr>
-          <p:cNvPr id="11" name="Shape 9"/>
-          <p:cNvSpPr/>
-          <p:nvPr/>
-        </p:nvSpPr>
-        <p:spPr>
-          <a:xfrm>
-            <a:off x="457200" y="2743200"/>
-            <a:ext cx="8229600" cy="713232"/>
+          <p:cNvPr id="13" name="Shape 11"/>
+          <p:cNvSpPr/>
+          <p:nvPr/>
+        </p:nvSpPr>
+        <p:spPr>
+          <a:xfrm>
+            <a:off x="457200" y="1965960"/>
+            <a:ext cx="2286000" cy="475488"/>
           </a:xfrm>
           <a:prstGeom prst="rect">
             <a:avLst/>
@@ -4687,14 +5404,14 @@
       </p:sp>
       <p:sp>
         <p:nvSpPr>
-          <p:cNvPr id="12" name="Text 10"/>
-          <p:cNvSpPr/>
-          <p:nvPr/>
-        </p:nvSpPr>
-        <p:spPr>
-          <a:xfrm>
-            <a:off x="640080" y="2743200"/>
-            <a:ext cx="2560320" cy="713232"/>
+          <p:cNvPr id="14" name="Text 12"/>
+          <p:cNvSpPr/>
+          <p:nvPr/>
+        </p:nvSpPr>
+        <p:spPr>
+          <a:xfrm>
+            <a:off x="548640" y="1965960"/>
+            <a:ext cx="2103120" cy="475488"/>
           </a:xfrm>
           <a:prstGeom prst="rect">
             <a:avLst/>
@@ -4710,7 +5427,7 @@
               <a:buNone/>
             </a:pPr>
             <a:r>
-              <a:rPr lang="en-US" sz="1000" b="1" dirty="0">
+              <a:rPr lang="en-US" sz="900" b="1" dirty="0">
                 <a:solidFill>
                   <a:srgbClr val="0D47A1"/>
                 </a:solidFill>
@@ -4718,22 +5435,42 @@
                 <a:ea typeface="Trebuchet MS" pitchFamily="34" charset="-122"/>
                 <a:cs typeface="Trebuchet MS" pitchFamily="34" charset="-120"/>
               </a:rPr>
-              <a:t>Fonctions personnalisées</a:t>
-            </a:r>
-            <a:endParaRPr lang="en-US" sz="1000" dirty="0"/>
-          </a:p>
-        </p:txBody>
-      </p:sp>
-      <p:sp>
-        <p:nvSpPr>
-          <p:cNvPr id="13" name="Text 11"/>
-          <p:cNvSpPr/>
-          <p:nvPr/>
-        </p:nvSpPr>
-        <p:spPr>
-          <a:xfrm>
-            <a:off x="3291840" y="2743200"/>
-            <a:ext cx="5212080" cy="713232"/>
+              <a:t>FUNCTION</a:t>
+            </a:r>
+            <a:endParaRPr lang="en-US" sz="900" dirty="0"/>
+          </a:p>
+        </p:txBody>
+      </p:sp>
+      <p:sp>
+        <p:nvSpPr>
+          <p:cNvPr id="15" name="Shape 13"/>
+          <p:cNvSpPr/>
+          <p:nvPr/>
+        </p:nvSpPr>
+        <p:spPr>
+          <a:xfrm>
+            <a:off x="2743200" y="1965960"/>
+            <a:ext cx="5943600" cy="475488"/>
+          </a:xfrm>
+          <a:prstGeom prst="rect">
+            <a:avLst/>
+          </a:prstGeom>
+          <a:solidFill>
+            <a:srgbClr val="E3F2FD"/>
+          </a:solidFill>
+          <a:ln/>
+        </p:spPr>
+      </p:sp>
+      <p:sp>
+        <p:nvSpPr>
+          <p:cNvPr id="16" name="Text 14"/>
+          <p:cNvSpPr/>
+          <p:nvPr/>
+        </p:nvSpPr>
+        <p:spPr>
+          <a:xfrm>
+            <a:off x="2834640" y="1965960"/>
+            <a:ext cx="5760720" cy="475488"/>
           </a:xfrm>
           <a:prstGeom prst="rect">
             <a:avLst/>
@@ -4757,7 +5494,7 @@
                 <a:ea typeface="Calibri" pitchFamily="34" charset="-122"/>
                 <a:cs typeface="Calibri" pitchFamily="34" charset="-120"/>
               </a:rPr>
-              <a:t>CREATE FUNCTION fn_ca_artiste(p_id INT) RETURNS DECIMAL(10,2) | DETERMINISTIC READS SQL DATA | BEGIN ... RETURN valeur; ...</a:t>
+              <a:t>Retourne une valeur, utilisable dans SELECT</a:t>
             </a:r>
             <a:endParaRPr lang="en-US" sz="900" dirty="0"/>
           </a:p>
@@ -4765,34 +5502,34 @@
       </p:sp>
       <p:sp>
         <p:nvSpPr>
-          <p:cNvPr id="14" name="Shape 12"/>
-          <p:cNvSpPr/>
-          <p:nvPr/>
-        </p:nvSpPr>
-        <p:spPr>
-          <a:xfrm>
-            <a:off x="457200" y="3520440"/>
-            <a:ext cx="8229600" cy="713232"/>
-          </a:xfrm>
-          <a:prstGeom prst="rect">
-            <a:avLst/>
-          </a:prstGeom>
-          <a:solidFill>
-            <a:srgbClr val="FFFFFF"/>
-          </a:solidFill>
-          <a:ln/>
-        </p:spPr>
-      </p:sp>
-      <p:sp>
-        <p:nvSpPr>
-          <p:cNvPr id="15" name="Text 13"/>
-          <p:cNvSpPr/>
-          <p:nvPr/>
-        </p:nvSpPr>
-        <p:spPr>
-          <a:xfrm>
-            <a:off x="640080" y="3520440"/>
-            <a:ext cx="2560320" cy="713232"/>
+          <p:cNvPr id="17" name="Shape 15"/>
+          <p:cNvSpPr/>
+          <p:nvPr/>
+        </p:nvSpPr>
+        <p:spPr>
+          <a:xfrm>
+            <a:off x="457200" y="2468880"/>
+            <a:ext cx="2286000" cy="475488"/>
+          </a:xfrm>
+          <a:prstGeom prst="rect">
+            <a:avLst/>
+          </a:prstGeom>
+          <a:solidFill>
+            <a:srgbClr val="F0F0F0"/>
+          </a:solidFill>
+          <a:ln/>
+        </p:spPr>
+      </p:sp>
+      <p:sp>
+        <p:nvSpPr>
+          <p:cNvPr id="18" name="Text 16"/>
+          <p:cNvSpPr/>
+          <p:nvPr/>
+        </p:nvSpPr>
+        <p:spPr>
+          <a:xfrm>
+            <a:off x="548640" y="2468880"/>
+            <a:ext cx="2103120" cy="475488"/>
           </a:xfrm>
           <a:prstGeom prst="rect">
             <a:avLst/>
@@ -4808,7 +5545,7 @@
               <a:buNone/>
             </a:pPr>
             <a:r>
-              <a:rPr lang="en-US" sz="1000" b="1" dirty="0">
+              <a:rPr lang="en-US" sz="900" b="1" dirty="0">
                 <a:solidFill>
                   <a:srgbClr val="0D47A1"/>
                 </a:solidFill>
@@ -4816,22 +5553,42 @@
                 <a:ea typeface="Trebuchet MS" pitchFamily="34" charset="-122"/>
                 <a:cs typeface="Trebuchet MS" pitchFamily="34" charset="-120"/>
               </a:rPr>
-              <a:t>Triggers</a:t>
-            </a:r>
-            <a:endParaRPr lang="en-US" sz="1000" dirty="0"/>
-          </a:p>
-        </p:txBody>
-      </p:sp>
-      <p:sp>
-        <p:nvSpPr>
-          <p:cNvPr id="16" name="Text 14"/>
-          <p:cNvSpPr/>
-          <p:nvPr/>
-        </p:nvSpPr>
-        <p:spPr>
-          <a:xfrm>
-            <a:off x="3291840" y="3520440"/>
-            <a:ext cx="5212080" cy="713232"/>
+              <a:t>TRIGGER</a:t>
+            </a:r>
+            <a:endParaRPr lang="en-US" sz="900" dirty="0"/>
+          </a:p>
+        </p:txBody>
+      </p:sp>
+      <p:sp>
+        <p:nvSpPr>
+          <p:cNvPr id="19" name="Shape 17"/>
+          <p:cNvSpPr/>
+          <p:nvPr/>
+        </p:nvSpPr>
+        <p:spPr>
+          <a:xfrm>
+            <a:off x="2743200" y="2468880"/>
+            <a:ext cx="5943600" cy="475488"/>
+          </a:xfrm>
+          <a:prstGeom prst="rect">
+            <a:avLst/>
+          </a:prstGeom>
+          <a:solidFill>
+            <a:srgbClr val="F0F0F0"/>
+          </a:solidFill>
+          <a:ln/>
+        </p:spPr>
+      </p:sp>
+      <p:sp>
+        <p:nvSpPr>
+          <p:cNvPr id="20" name="Text 18"/>
+          <p:cNvSpPr/>
+          <p:nvPr/>
+        </p:nvSpPr>
+        <p:spPr>
+          <a:xfrm>
+            <a:off x="2834640" y="2468880"/>
+            <a:ext cx="5760720" cy="475488"/>
           </a:xfrm>
           <a:prstGeom prst="rect">
             <a:avLst/>
@@ -4855,7 +5612,243 @@
                 <a:ea typeface="Calibri" pitchFamily="34" charset="-122"/>
                 <a:cs typeface="Calibri" pitchFamily="34" charset="-120"/>
               </a:rPr>
-              <a:t>Déclencheur automatique sur INSERT/UPDATE/DELETE | BEFORE ou AFTER l'opération | CREATE TRIGGER trg_nom AFTER UPDATE ON ...</a:t>
+              <a:t>Automatique : BEFORE/AFTER + INSERT/UPDATE/DELETE</a:t>
+            </a:r>
+            <a:endParaRPr lang="en-US" sz="900" dirty="0"/>
+          </a:p>
+        </p:txBody>
+      </p:sp>
+      <p:sp>
+        <p:nvSpPr>
+          <p:cNvPr id="21" name="Shape 19"/>
+          <p:cNvSpPr/>
+          <p:nvPr/>
+        </p:nvSpPr>
+        <p:spPr>
+          <a:xfrm>
+            <a:off x="457200" y="2971800"/>
+            <a:ext cx="2286000" cy="475488"/>
+          </a:xfrm>
+          <a:prstGeom prst="rect">
+            <a:avLst/>
+          </a:prstGeom>
+          <a:solidFill>
+            <a:srgbClr val="E3F2FD"/>
+          </a:solidFill>
+          <a:ln/>
+        </p:spPr>
+      </p:sp>
+      <p:sp>
+        <p:nvSpPr>
+          <p:cNvPr id="22" name="Text 20"/>
+          <p:cNvSpPr/>
+          <p:nvPr/>
+        </p:nvSpPr>
+        <p:spPr>
+          <a:xfrm>
+            <a:off x="548640" y="2971800"/>
+            <a:ext cx="2103120" cy="475488"/>
+          </a:xfrm>
+          <a:prstGeom prst="rect">
+            <a:avLst/>
+          </a:prstGeom>
+          <a:noFill/>
+          <a:ln/>
+        </p:spPr>
+        <p:txBody>
+          <a:bodyPr wrap="square" lIns="0" tIns="0" rIns="0" bIns="0" rtlCol="0" anchor="ctr"/>
+          <a:lstStyle/>
+          <a:p>
+            <a:pPr indent="0" marL="0">
+              <a:buNone/>
+            </a:pPr>
+            <a:r>
+              <a:rPr lang="en-US" sz="900" b="1" dirty="0">
+                <a:solidFill>
+                  <a:srgbClr val="0D47A1"/>
+                </a:solidFill>
+                <a:latin typeface="Trebuchet MS" pitchFamily="34" charset="0"/>
+                <a:ea typeface="Trebuchet MS" pitchFamily="34" charset="-122"/>
+                <a:cs typeface="Trebuchet MS" pitchFamily="34" charset="-120"/>
+              </a:rPr>
+              <a:t>DELIMITER</a:t>
+            </a:r>
+            <a:endParaRPr lang="en-US" sz="900" dirty="0"/>
+          </a:p>
+        </p:txBody>
+      </p:sp>
+      <p:sp>
+        <p:nvSpPr>
+          <p:cNvPr id="23" name="Shape 21"/>
+          <p:cNvSpPr/>
+          <p:nvPr/>
+        </p:nvSpPr>
+        <p:spPr>
+          <a:xfrm>
+            <a:off x="2743200" y="2971800"/>
+            <a:ext cx="5943600" cy="475488"/>
+          </a:xfrm>
+          <a:prstGeom prst="rect">
+            <a:avLst/>
+          </a:prstGeom>
+          <a:solidFill>
+            <a:srgbClr val="E3F2FD"/>
+          </a:solidFill>
+          <a:ln/>
+        </p:spPr>
+      </p:sp>
+      <p:sp>
+        <p:nvSpPr>
+          <p:cNvPr id="24" name="Text 22"/>
+          <p:cNvSpPr/>
+          <p:nvPr/>
+        </p:nvSpPr>
+        <p:spPr>
+          <a:xfrm>
+            <a:off x="2834640" y="2971800"/>
+            <a:ext cx="5760720" cy="475488"/>
+          </a:xfrm>
+          <a:prstGeom prst="rect">
+            <a:avLst/>
+          </a:prstGeom>
+          <a:noFill/>
+          <a:ln/>
+        </p:spPr>
+        <p:txBody>
+          <a:bodyPr wrap="square" lIns="0" tIns="0" rIns="0" bIns="0" rtlCol="0" anchor="ctr"/>
+          <a:lstStyle/>
+          <a:p>
+            <a:pPr indent="0" marL="0">
+              <a:buNone/>
+            </a:pPr>
+            <a:r>
+              <a:rPr lang="en-US" sz="900" dirty="0">
+                <a:solidFill>
+                  <a:srgbClr val="333333"/>
+                </a:solidFill>
+                <a:latin typeface="Calibri" pitchFamily="34" charset="0"/>
+                <a:ea typeface="Calibri" pitchFamily="34" charset="-122"/>
+                <a:cs typeface="Calibri" pitchFamily="34" charset="-120"/>
+              </a:rPr>
+              <a:t>Changer le séparateur pour écrire des ; dans le code</a:t>
+            </a:r>
+            <a:endParaRPr lang="en-US" sz="900" dirty="0"/>
+          </a:p>
+        </p:txBody>
+      </p:sp>
+      <p:sp>
+        <p:nvSpPr>
+          <p:cNvPr id="25" name="Shape 23"/>
+          <p:cNvSpPr/>
+          <p:nvPr/>
+        </p:nvSpPr>
+        <p:spPr>
+          <a:xfrm>
+            <a:off x="457200" y="3474720"/>
+            <a:ext cx="2286000" cy="475488"/>
+          </a:xfrm>
+          <a:prstGeom prst="rect">
+            <a:avLst/>
+          </a:prstGeom>
+          <a:solidFill>
+            <a:srgbClr val="F0F0F0"/>
+          </a:solidFill>
+          <a:ln/>
+        </p:spPr>
+      </p:sp>
+      <p:sp>
+        <p:nvSpPr>
+          <p:cNvPr id="26" name="Text 24"/>
+          <p:cNvSpPr/>
+          <p:nvPr/>
+        </p:nvSpPr>
+        <p:spPr>
+          <a:xfrm>
+            <a:off x="548640" y="3474720"/>
+            <a:ext cx="2103120" cy="475488"/>
+          </a:xfrm>
+          <a:prstGeom prst="rect">
+            <a:avLst/>
+          </a:prstGeom>
+          <a:noFill/>
+          <a:ln/>
+        </p:spPr>
+        <p:txBody>
+          <a:bodyPr wrap="square" lIns="0" tIns="0" rIns="0" bIns="0" rtlCol="0" anchor="ctr"/>
+          <a:lstStyle/>
+          <a:p>
+            <a:pPr indent="0" marL="0">
+              <a:buNone/>
+            </a:pPr>
+            <a:r>
+              <a:rPr lang="en-US" sz="900" b="1" dirty="0">
+                <a:solidFill>
+                  <a:srgbClr val="0D47A1"/>
+                </a:solidFill>
+                <a:latin typeface="Trebuchet MS" pitchFamily="34" charset="0"/>
+                <a:ea typeface="Trebuchet MS" pitchFamily="34" charset="-122"/>
+                <a:cs typeface="Trebuchet MS" pitchFamily="34" charset="-120"/>
+              </a:rPr>
+              <a:t>Sécurité vue</a:t>
+            </a:r>
+            <a:endParaRPr lang="en-US" sz="900" dirty="0"/>
+          </a:p>
+        </p:txBody>
+      </p:sp>
+      <p:sp>
+        <p:nvSpPr>
+          <p:cNvPr id="27" name="Shape 25"/>
+          <p:cNvSpPr/>
+          <p:nvPr/>
+        </p:nvSpPr>
+        <p:spPr>
+          <a:xfrm>
+            <a:off x="2743200" y="3474720"/>
+            <a:ext cx="5943600" cy="475488"/>
+          </a:xfrm>
+          <a:prstGeom prst="rect">
+            <a:avLst/>
+          </a:prstGeom>
+          <a:solidFill>
+            <a:srgbClr val="F0F0F0"/>
+          </a:solidFill>
+          <a:ln/>
+        </p:spPr>
+      </p:sp>
+      <p:sp>
+        <p:nvSpPr>
+          <p:cNvPr id="28" name="Text 26"/>
+          <p:cNvSpPr/>
+          <p:nvPr/>
+        </p:nvSpPr>
+        <p:spPr>
+          <a:xfrm>
+            <a:off x="2834640" y="3474720"/>
+            <a:ext cx="5760720" cy="475488"/>
+          </a:xfrm>
+          <a:prstGeom prst="rect">
+            <a:avLst/>
+          </a:prstGeom>
+          <a:noFill/>
+          <a:ln/>
+        </p:spPr>
+        <p:txBody>
+          <a:bodyPr wrap="square" lIns="0" tIns="0" rIns="0" bIns="0" rtlCol="0" anchor="ctr"/>
+          <a:lstStyle/>
+          <a:p>
+            <a:pPr indent="0" marL="0">
+              <a:buNone/>
+            </a:pPr>
+            <a:r>
+              <a:rPr lang="en-US" sz="900" dirty="0">
+                <a:solidFill>
+                  <a:srgbClr val="333333"/>
+                </a:solidFill>
+                <a:latin typeface="Calibri" pitchFamily="34" charset="0"/>
+                <a:ea typeface="Calibri" pitchFamily="34" charset="-122"/>
+                <a:cs typeface="Calibri" pitchFamily="34" charset="-120"/>
+              </a:rPr>
+              <a:t>Donner accès à la vue, pas à la table source</a:t>
             </a:r>
             <a:endParaRPr lang="en-US" sz="900" dirty="0"/>
           </a:p>

</xml_diff>

<commit_message>
🏁 LIVRAISON COMPLÈTE: 29 exercices GESCOM liés au sandbox + Boss Final (20q LO1→LO4) + 6 PPTX enrichis (10,12,15,16,17,18) + exercices BD intégrés
</commit_message>
<xml_diff>
--- a/pptx/Module15_Vues_procédures_fonctions.pptx
+++ b/pptx/Module15_Vues_procédures_fonctions.pptx
@@ -12,9 +12,10 @@
     <p:sldId id="260" r:id="rId6"/>
     <p:sldId id="261" r:id="rId7"/>
     <p:sldId id="262" r:id="rId8"/>
+    <p:sldId id="263" r:id="rId9"/>
   </p:sldIdLst>
   <p:notesMasterIdLst>
-    <p:notesMasterId r:id="rId9"/>
+    <p:notesMasterId r:id="rId10"/>
   </p:notesMasterIdLst>
   <p:sldSz cx="9144000" cy="5143500"/>
   <p:notesSz cx="5143500" cy="9144000"/>
@@ -596,7 +597,7 @@
           <a:p>
             <a:r>
               <a:rPr lang="en-US" dirty="0"/>
-              <a:t>Les vues sont un outil de sécurité puissant : donner accès à la vue sans accès à la table source.</a:t>
+              <a:t>Les vues sont un outil de sécurité puissant.</a:t>
             </a:r>
             <a:endParaRPr lang="en-US" dirty="0"/>
           </a:p>
@@ -684,7 +685,7 @@
           <a:p>
             <a:r>
               <a:rPr lang="en-US" dirty="0"/>
-              <a:t>Le DELIMITER est nécessaire car la procédure contient des ; internes.</a:t>
+              <a:t>Le DELIMITER est TOUJOURS source de confusion. Expliquer pourquoi : la procedure contient des ; internes.</a:t>
             </a:r>
             <a:endParaRPr lang="en-US" dirty="0"/>
           </a:p>
@@ -772,7 +773,7 @@
           <a:p>
             <a:r>
               <a:rPr lang="en-US" dirty="0"/>
-              <a:t>Fonctions = réutilisables dans des SELECT. Triggers = automatisation sans intervention.</a:t>
+              <a:t>Fonction = retourne 1 valeur, utilisable dans SELECT. Procedure = execute des actions, appelée avec CALL.</a:t>
             </a:r>
             <a:endParaRPr lang="en-US" dirty="0"/>
           </a:p>
@@ -860,7 +861,7 @@
           <a:p>
             <a:r>
               <a:rPr lang="en-US" dirty="0"/>
-              <a:t>Module technique important pour M2 (système complet avec sécurité et maintenance).</a:t>
+              <a:t>Triggers = automatisation sans intervention humaine. Excellent pour la cohérence des données.</a:t>
             </a:r>
             <a:endParaRPr lang="en-US" dirty="0"/>
           </a:p>
@@ -948,7 +949,7 @@
           <a:p>
             <a:r>
               <a:rPr lang="en-US" dirty="0"/>
-              <a:t/>
+              <a:t>Module technique important pour M2.</a:t>
             </a:r>
             <a:endParaRPr lang="en-US" dirty="0"/>
           </a:p>
@@ -1060,6 +1061,94 @@
             <a:fld id="{F7021451-1387-4CA6-816F-3879F97B5CBC}" type="slidenum">
               <a:rPr lang="en-US"/>
               <a:t>7</a:t>
+            </a:fld>
+            <a:endParaRPr lang="en-US"/>
+          </a:p>
+        </p:txBody>
+      </p:sp>
+    </p:spTree>
+    <p:extLst>
+      <p:ext uri="{BB962C8B-B14F-4D97-AF65-F5344CB8AC3E}">
+        <p14:creationId xmlns:p14="http://schemas.microsoft.com/office/powerpoint/2010/main" val="1024086991"/>
+      </p:ext>
+    </p:extLst>
+  </p:cSld>
+  <p:clrMapOvr>
+    <a:masterClrMapping/>
+  </p:clrMapOvr>
+</p:notes>
+</file>
+
+<file path=ppt/notesSlides/notesSlide8.xml><?xml version="1.0" encoding="utf-8"?>
+<p:notes xmlns:a="http://schemas.openxmlformats.org/drawingml/2006/main" xmlns:r="http://schemas.openxmlformats.org/officeDocument/2006/relationships" xmlns:p="http://schemas.openxmlformats.org/presentationml/2006/main">
+  <p:cSld>
+    <p:spTree>
+      <p:nvGrpSpPr>
+        <p:cNvPr id="1" name=""/>
+        <p:cNvGrpSpPr/>
+        <p:nvPr/>
+      </p:nvGrpSpPr>
+      <p:grpSpPr>
+        <a:xfrm>
+          <a:off x="0" y="0"/>
+          <a:ext cx="0" cy="0"/>
+          <a:chOff x="0" y="0"/>
+          <a:chExt cx="0" cy="0"/>
+        </a:xfrm>
+      </p:grpSpPr>
+      <p:sp>
+        <p:nvSpPr>
+          <p:cNvPr id="2" name="Slide Image Placeholder 1"/>
+          <p:cNvSpPr>
+            <a:spLocks noGrp="1" noRot="1" noChangeAspect="1"/>
+          </p:cNvSpPr>
+          <p:nvPr>
+            <p:ph type="sldImg"/>
+          </p:nvPr>
+        </p:nvSpPr>
+        <p:spPr/>
+      </p:sp>
+      <p:sp>
+        <p:nvSpPr>
+          <p:cNvPr id="3" name="Notes Placeholder 2"/>
+          <p:cNvSpPr>
+            <a:spLocks noGrp="1"/>
+          </p:cNvSpPr>
+          <p:nvPr>
+            <p:ph type="body" idx="1"/>
+          </p:nvPr>
+        </p:nvSpPr>
+        <p:spPr/>
+        <p:txBody>
+          <a:bodyPr/>
+          <a:lstStyle/>
+          <a:p>
+            <a:r>
+              <a:rPr lang="en-US" dirty="0"/>
+              <a:t/>
+            </a:r>
+            <a:endParaRPr lang="en-US" dirty="0"/>
+          </a:p>
+        </p:txBody>
+      </p:sp>
+      <p:sp>
+        <p:nvSpPr>
+          <p:cNvPr id="4" name="Slide Number Placeholder 3"/>
+          <p:cNvSpPr>
+            <a:spLocks noGrp="1"/>
+          </p:cNvSpPr>
+          <p:nvPr>
+            <p:ph type="sldNum" sz="quarter" idx="10"/>
+          </p:nvPr>
+        </p:nvSpPr>
+        <p:spPr/>
+        <p:txBody>
+          <a:bodyPr/>
+          <a:lstStyle/>
+          <a:p>
+            <a:fld id="{F7021451-1387-4CA6-816F-3879F97B5CBC}" type="slidenum">
+              <a:rPr lang="en-US"/>
+              <a:t>8</a:t>
             </a:fld>
             <a:endParaRPr lang="en-US"/>
           </a:p>
@@ -1517,7 +1606,7 @@
               <a:buNone/>
             </a:pPr>
             <a:r>
-              <a:rPr lang="en-US" sz="3200" b="1" dirty="0">
+              <a:rPr lang="en-US" sz="3000" b="1" dirty="0">
                 <a:solidFill>
                   <a:srgbClr val="FFFFFF"/>
                 </a:solidFill>
@@ -1525,9 +1614,9 @@
                 <a:ea typeface="Trebuchet MS" pitchFamily="34" charset="-122"/>
                 <a:cs typeface="Trebuchet MS" pitchFamily="34" charset="-120"/>
               </a:rPr>
-              <a:t>Vues procédures fonctions</a:t>
-            </a:r>
-            <a:endParaRPr lang="en-US" sz="3200" dirty="0"/>
+              <a:t>Vues, procedures, fonctions, triggers</a:t>
+            </a:r>
+            <a:endParaRPr lang="en-US" sz="3000" dirty="0"/>
           </a:p>
         </p:txBody>
       </p:sp>
@@ -1556,7 +1645,7 @@
               <a:buNone/>
             </a:pPr>
             <a:r>
-              <a:rPr lang="en-US" sz="1500" dirty="0">
+              <a:rPr lang="en-US" sz="1400" dirty="0">
                 <a:solidFill>
                   <a:srgbClr val="CCCCCC"/>
                 </a:solidFill>
@@ -1564,9 +1653,9 @@
                 <a:ea typeface="Calibri" pitchFamily="34" charset="-122"/>
                 <a:cs typeface="Calibri" pitchFamily="34" charset="-120"/>
               </a:rPr>
-              <a:t>CREATE VIEW · PROCEDURE · FUNCTION · Triggers</a:t>
-            </a:r>
-            <a:endParaRPr lang="en-US" sz="1500" dirty="0"/>
+              <a:t>CREATE VIEW, PROCEDURE, FUNCTION, TRIGGER, DELIMITER</a:t>
+            </a:r>
+            <a:endParaRPr lang="en-US" sz="1400" dirty="0"/>
           </a:p>
         </p:txBody>
       </p:sp>
@@ -1670,7 +1759,7 @@
         <p:spPr>
           <a:xfrm>
             <a:off x="457200" y="182880"/>
-            <a:ext cx="8229600" cy="594360"/>
+            <a:ext cx="8229600" cy="548640"/>
           </a:xfrm>
           <a:prstGeom prst="rect">
             <a:avLst/>
@@ -1686,7 +1775,7 @@
               <a:buNone/>
             </a:pPr>
             <a:r>
-              <a:rPr lang="en-US" sz="2400" b="1" dirty="0">
+              <a:rPr lang="en-US" sz="2200" b="1" dirty="0">
                 <a:solidFill>
                   <a:srgbClr val="0D47A1"/>
                 </a:solidFill>
@@ -1696,7 +1785,7 @@
               </a:rPr>
               <a:t>Vues : tables virtuelles</a:t>
             </a:r>
-            <a:endParaRPr lang="en-US" sz="2400" dirty="0"/>
+            <a:endParaRPr lang="en-US" sz="2200" dirty="0"/>
           </a:p>
         </p:txBody>
       </p:sp>
@@ -1708,8 +1797,8 @@
         </p:nvSpPr>
         <p:spPr>
           <a:xfrm>
-            <a:off x="457200" y="914400"/>
-            <a:ext cx="8229600" cy="521208"/>
+            <a:off x="457200" y="868680"/>
+            <a:ext cx="8229600" cy="475488"/>
           </a:xfrm>
           <a:prstGeom prst="rect">
             <a:avLst/>
@@ -1718,13 +1807,6 @@
             <a:srgbClr val="FFFFFF"/>
           </a:solidFill>
           <a:ln/>
-          <a:effectLst>
-            <a:outerShdw sx="100000" sy="100000" kx="0" ky="0" algn="bl" rotWithShape="0" blurRad="50800" dist="25400" dir="8100000">
-              <a:srgbClr val="000000">
-                <a:alpha val="12000"/>
-              </a:srgbClr>
-            </a:outerShdw>
-          </a:effectLst>
         </p:spPr>
       </p:sp>
       <p:sp>
@@ -1735,8 +1817,8 @@
         </p:nvSpPr>
         <p:spPr>
           <a:xfrm>
-            <a:off x="457200" y="914400"/>
-            <a:ext cx="45720" cy="521208"/>
+            <a:off x="457200" y="868680"/>
+            <a:ext cx="45720" cy="475488"/>
           </a:xfrm>
           <a:prstGeom prst="rect">
             <a:avLst/>
@@ -1755,8 +1837,8 @@
         </p:nvSpPr>
         <p:spPr>
           <a:xfrm>
-            <a:off x="685800" y="914400"/>
-            <a:ext cx="7818120" cy="521208"/>
+            <a:off x="640080" y="868680"/>
+            <a:ext cx="7863840" cy="475488"/>
           </a:xfrm>
           <a:prstGeom prst="rect">
             <a:avLst/>
@@ -1794,8 +1876,8 @@
         </p:nvSpPr>
         <p:spPr>
           <a:xfrm>
-            <a:off x="457200" y="1463040"/>
-            <a:ext cx="8229600" cy="521208"/>
+            <a:off x="457200" y="1371600"/>
+            <a:ext cx="8229600" cy="475488"/>
           </a:xfrm>
           <a:prstGeom prst="rect">
             <a:avLst/>
@@ -1804,13 +1886,6 @@
             <a:srgbClr val="E3F2FD"/>
           </a:solidFill>
           <a:ln/>
-          <a:effectLst>
-            <a:outerShdw sx="100000" sy="100000" kx="0" ky="0" algn="bl" rotWithShape="0" blurRad="50800" dist="25400" dir="8100000">
-              <a:srgbClr val="000000">
-                <a:alpha val="12000"/>
-              </a:srgbClr>
-            </a:outerShdw>
-          </a:effectLst>
         </p:spPr>
       </p:sp>
       <p:sp>
@@ -1821,8 +1896,8 @@
         </p:nvSpPr>
         <p:spPr>
           <a:xfrm>
-            <a:off x="457200" y="1463040"/>
-            <a:ext cx="45720" cy="521208"/>
+            <a:off x="457200" y="1371600"/>
+            <a:ext cx="45720" cy="475488"/>
           </a:xfrm>
           <a:prstGeom prst="rect">
             <a:avLst/>
@@ -1841,8 +1916,8 @@
         </p:nvSpPr>
         <p:spPr>
           <a:xfrm>
-            <a:off x="685800" y="1463040"/>
-            <a:ext cx="7818120" cy="521208"/>
+            <a:off x="640080" y="1371600"/>
+            <a:ext cx="7863840" cy="475488"/>
           </a:xfrm>
           <a:prstGeom prst="rect">
             <a:avLst/>
@@ -1858,7 +1933,7 @@
               <a:buNone/>
             </a:pPr>
             <a:r>
-              <a:rPr lang="en-US" sz="1200" dirty="0">
+              <a:rPr lang="en-US" sz="1100" dirty="0">
                 <a:solidFill>
                   <a:srgbClr val="1A1A2E"/>
                 </a:solidFill>
@@ -1868,7 +1943,7 @@
               </a:rPr>
               <a:t>Utilisation : SELECT * FROM v_artistes_actifs; (comme une table)</a:t>
             </a:r>
-            <a:endParaRPr lang="en-US" sz="1200" dirty="0"/>
+            <a:endParaRPr lang="en-US" sz="1100" dirty="0"/>
           </a:p>
         </p:txBody>
       </p:sp>
@@ -1880,8 +1955,8 @@
         </p:nvSpPr>
         <p:spPr>
           <a:xfrm>
-            <a:off x="457200" y="2011680"/>
-            <a:ext cx="8229600" cy="521208"/>
+            <a:off x="457200" y="1874520"/>
+            <a:ext cx="8229600" cy="475488"/>
           </a:xfrm>
           <a:prstGeom prst="rect">
             <a:avLst/>
@@ -1890,13 +1965,6 @@
             <a:srgbClr val="FFFFFF"/>
           </a:solidFill>
           <a:ln/>
-          <a:effectLst>
-            <a:outerShdw sx="100000" sy="100000" kx="0" ky="0" algn="bl" rotWithShape="0" blurRad="50800" dist="25400" dir="8100000">
-              <a:srgbClr val="000000">
-                <a:alpha val="12000"/>
-              </a:srgbClr>
-            </a:outerShdw>
-          </a:effectLst>
         </p:spPr>
       </p:sp>
       <p:sp>
@@ -1907,8 +1975,8 @@
         </p:nvSpPr>
         <p:spPr>
           <a:xfrm>
-            <a:off x="457200" y="2011680"/>
-            <a:ext cx="45720" cy="521208"/>
+            <a:off x="457200" y="1874520"/>
+            <a:ext cx="45720" cy="475488"/>
           </a:xfrm>
           <a:prstGeom prst="rect">
             <a:avLst/>
@@ -1927,8 +1995,8 @@
         </p:nvSpPr>
         <p:spPr>
           <a:xfrm>
-            <a:off x="685800" y="2011680"/>
-            <a:ext cx="7818120" cy="521208"/>
+            <a:off x="640080" y="1874520"/>
+            <a:ext cx="7863840" cy="475488"/>
           </a:xfrm>
           <a:prstGeom prst="rect">
             <a:avLst/>
@@ -1944,7 +2012,7 @@
               <a:buNone/>
             </a:pPr>
             <a:r>
-              <a:rPr lang="en-US" sz="1200" dirty="0">
+              <a:rPr lang="en-US" sz="1100" dirty="0">
                 <a:solidFill>
                   <a:srgbClr val="1A1A2E"/>
                 </a:solidFill>
@@ -1952,9 +2020,9 @@
                 <a:ea typeface="Calibri" pitchFamily="34" charset="-122"/>
                 <a:cs typeface="Calibri" pitchFamily="34" charset="-120"/>
               </a:rPr>
-              <a:t>Avantages : simplification (requête complexe → nom simple)</a:t>
-            </a:r>
-            <a:endParaRPr lang="en-US" sz="1200" dirty="0"/>
+              <a:t>Avantages : simplification, securite, abstraction</a:t>
+            </a:r>
+            <a:endParaRPr lang="en-US" sz="1100" dirty="0"/>
           </a:p>
         </p:txBody>
       </p:sp>
@@ -1966,8 +2034,8 @@
         </p:nvSpPr>
         <p:spPr>
           <a:xfrm>
-            <a:off x="457200" y="2560320"/>
-            <a:ext cx="8229600" cy="521208"/>
+            <a:off x="457200" y="2377440"/>
+            <a:ext cx="8229600" cy="475488"/>
           </a:xfrm>
           <a:prstGeom prst="rect">
             <a:avLst/>
@@ -1976,13 +2044,6 @@
             <a:srgbClr val="E3F2FD"/>
           </a:solidFill>
           <a:ln/>
-          <a:effectLst>
-            <a:outerShdw sx="100000" sy="100000" kx="0" ky="0" algn="bl" rotWithShape="0" blurRad="50800" dist="25400" dir="8100000">
-              <a:srgbClr val="000000">
-                <a:alpha val="12000"/>
-              </a:srgbClr>
-            </a:outerShdw>
-          </a:effectLst>
         </p:spPr>
       </p:sp>
       <p:sp>
@@ -1993,8 +2054,8 @@
         </p:nvSpPr>
         <p:spPr>
           <a:xfrm>
-            <a:off x="457200" y="2560320"/>
-            <a:ext cx="45720" cy="521208"/>
+            <a:off x="457200" y="2377440"/>
+            <a:ext cx="45720" cy="475488"/>
           </a:xfrm>
           <a:prstGeom prst="rect">
             <a:avLst/>
@@ -2013,8 +2074,8 @@
         </p:nvSpPr>
         <p:spPr>
           <a:xfrm>
-            <a:off x="685800" y="2560320"/>
-            <a:ext cx="7818120" cy="521208"/>
+            <a:off x="640080" y="2377440"/>
+            <a:ext cx="7863840" cy="475488"/>
           </a:xfrm>
           <a:prstGeom prst="rect">
             <a:avLst/>
@@ -2030,7 +2091,7 @@
               <a:buNone/>
             </a:pPr>
             <a:r>
-              <a:rPr lang="en-US" sz="1200" dirty="0">
+              <a:rPr lang="en-US" sz="1100" dirty="0">
                 <a:solidFill>
                   <a:srgbClr val="1A1A2E"/>
                 </a:solidFill>
@@ -2038,9 +2099,9 @@
                 <a:ea typeface="Calibri" pitchFamily="34" charset="-122"/>
                 <a:cs typeface="Calibri" pitchFamily="34" charset="-120"/>
               </a:rPr>
-              <a:t>Sécurité : masquer des colonnes sensibles aux utilisateurs</a:t>
-            </a:r>
-            <a:endParaRPr lang="en-US" sz="1200" dirty="0"/>
+              <a:t>Pas de stockage physique → recalculee a chaque appel</a:t>
+            </a:r>
+            <a:endParaRPr lang="en-US" sz="1100" dirty="0"/>
           </a:p>
         </p:txBody>
       </p:sp>
@@ -2052,8 +2113,8 @@
         </p:nvSpPr>
         <p:spPr>
           <a:xfrm>
-            <a:off x="457200" y="3108960"/>
-            <a:ext cx="8229600" cy="521208"/>
+            <a:off x="457200" y="2880360"/>
+            <a:ext cx="8229600" cy="475488"/>
           </a:xfrm>
           <a:prstGeom prst="rect">
             <a:avLst/>
@@ -2062,13 +2123,6 @@
             <a:srgbClr val="FFFFFF"/>
           </a:solidFill>
           <a:ln/>
-          <a:effectLst>
-            <a:outerShdw sx="100000" sy="100000" kx="0" ky="0" algn="bl" rotWithShape="0" blurRad="50800" dist="25400" dir="8100000">
-              <a:srgbClr val="000000">
-                <a:alpha val="12000"/>
-              </a:srgbClr>
-            </a:outerShdw>
-          </a:effectLst>
         </p:spPr>
       </p:sp>
       <p:sp>
@@ -2079,8 +2133,8 @@
         </p:nvSpPr>
         <p:spPr>
           <a:xfrm>
-            <a:off x="457200" y="3108960"/>
-            <a:ext cx="45720" cy="521208"/>
+            <a:off x="457200" y="2880360"/>
+            <a:ext cx="45720" cy="475488"/>
           </a:xfrm>
           <a:prstGeom prst="rect">
             <a:avLst/>
@@ -2099,8 +2153,8 @@
         </p:nvSpPr>
         <p:spPr>
           <a:xfrm>
-            <a:off x="685800" y="3108960"/>
-            <a:ext cx="7818120" cy="521208"/>
+            <a:off x="640080" y="2880360"/>
+            <a:ext cx="7863840" cy="475488"/>
           </a:xfrm>
           <a:prstGeom prst="rect">
             <a:avLst/>
@@ -2116,17 +2170,17 @@
               <a:buNone/>
             </a:pPr>
             <a:r>
-              <a:rPr lang="en-US" sz="1200" dirty="0">
+              <a:rPr lang="en-US" sz="1000" dirty="0">
                 <a:solidFill>
-                  <a:srgbClr val="1A1A2E"/>
+                  <a:srgbClr val="0D47A1"/>
                 </a:solidFill>
-                <a:latin typeface="Calibri" pitchFamily="34" charset="0"/>
-                <a:ea typeface="Calibri" pitchFamily="34" charset="-122"/>
-                <a:cs typeface="Calibri" pitchFamily="34" charset="-120"/>
+                <a:latin typeface="JetBrains Mono" pitchFamily="34" charset="0"/>
+                <a:ea typeface="JetBrains Mono" pitchFamily="34" charset="-122"/>
+                <a:cs typeface="JetBrains Mono" pitchFamily="34" charset="-120"/>
               </a:rPr>
-              <a:t>Abstraction : changer la requête sans modifier le code client</a:t>
-            </a:r>
-            <a:endParaRPr lang="en-US" sz="1200" dirty="0"/>
+              <a:t>CREATE OR REPLACE VIEW ... pour modifier</a:t>
+            </a:r>
+            <a:endParaRPr lang="en-US" sz="1000" dirty="0"/>
           </a:p>
         </p:txBody>
       </p:sp>
@@ -2138,8 +2192,8 @@
         </p:nvSpPr>
         <p:spPr>
           <a:xfrm>
-            <a:off x="457200" y="3657600"/>
-            <a:ext cx="8229600" cy="521208"/>
+            <a:off x="457200" y="3383280"/>
+            <a:ext cx="8229600" cy="475488"/>
           </a:xfrm>
           <a:prstGeom prst="rect">
             <a:avLst/>
@@ -2148,13 +2202,6 @@
             <a:srgbClr val="E3F2FD"/>
           </a:solidFill>
           <a:ln/>
-          <a:effectLst>
-            <a:outerShdw sx="100000" sy="100000" kx="0" ky="0" algn="bl" rotWithShape="0" blurRad="50800" dist="25400" dir="8100000">
-              <a:srgbClr val="000000">
-                <a:alpha val="12000"/>
-              </a:srgbClr>
-            </a:outerShdw>
-          </a:effectLst>
         </p:spPr>
       </p:sp>
       <p:sp>
@@ -2165,8 +2212,8 @@
         </p:nvSpPr>
         <p:spPr>
           <a:xfrm>
-            <a:off x="457200" y="3657600"/>
-            <a:ext cx="45720" cy="521208"/>
+            <a:off x="457200" y="3383280"/>
+            <a:ext cx="45720" cy="475488"/>
           </a:xfrm>
           <a:prstGeom prst="rect">
             <a:avLst/>
@@ -2185,94 +2232,8 @@
         </p:nvSpPr>
         <p:spPr>
           <a:xfrm>
-            <a:off x="685800" y="3657600"/>
-            <a:ext cx="7818120" cy="521208"/>
-          </a:xfrm>
-          <a:prstGeom prst="rect">
-            <a:avLst/>
-          </a:prstGeom>
-          <a:noFill/>
-          <a:ln/>
-        </p:spPr>
-        <p:txBody>
-          <a:bodyPr wrap="square" lIns="0" tIns="0" rIns="0" bIns="0" rtlCol="0" anchor="ctr"/>
-          <a:lstStyle/>
-          <a:p>
-            <a:pPr indent="0" marL="0">
-              <a:buNone/>
-            </a:pPr>
-            <a:r>
-              <a:rPr lang="en-US" sz="1200" dirty="0">
-                <a:solidFill>
-                  <a:srgbClr val="1A1A2E"/>
-                </a:solidFill>
-                <a:latin typeface="Calibri" pitchFamily="34" charset="0"/>
-                <a:ea typeface="Calibri" pitchFamily="34" charset="-122"/>
-                <a:cs typeface="Calibri" pitchFamily="34" charset="-120"/>
-              </a:rPr>
-              <a:t>Pas de stockage physique → recalculée à chaque appel</a:t>
-            </a:r>
-            <a:endParaRPr lang="en-US" sz="1200" dirty="0"/>
-          </a:p>
-        </p:txBody>
-      </p:sp>
-      <p:sp>
-        <p:nvSpPr>
-          <p:cNvPr id="22" name="Shape 20"/>
-          <p:cNvSpPr/>
-          <p:nvPr/>
-        </p:nvSpPr>
-        <p:spPr>
-          <a:xfrm>
-            <a:off x="457200" y="4206240"/>
-            <a:ext cx="8229600" cy="521208"/>
-          </a:xfrm>
-          <a:prstGeom prst="rect">
-            <a:avLst/>
-          </a:prstGeom>
-          <a:solidFill>
-            <a:srgbClr val="FFFFFF"/>
-          </a:solidFill>
-          <a:ln/>
-          <a:effectLst>
-            <a:outerShdw sx="100000" sy="100000" kx="0" ky="0" algn="bl" rotWithShape="0" blurRad="50800" dist="25400" dir="8100000">
-              <a:srgbClr val="000000">
-                <a:alpha val="12000"/>
-              </a:srgbClr>
-            </a:outerShdw>
-          </a:effectLst>
-        </p:spPr>
-      </p:sp>
-      <p:sp>
-        <p:nvSpPr>
-          <p:cNvPr id="23" name="Shape 21"/>
-          <p:cNvSpPr/>
-          <p:nvPr/>
-        </p:nvSpPr>
-        <p:spPr>
-          <a:xfrm>
-            <a:off x="457200" y="4206240"/>
-            <a:ext cx="45720" cy="521208"/>
-          </a:xfrm>
-          <a:prstGeom prst="rect">
-            <a:avLst/>
-          </a:prstGeom>
-          <a:solidFill>
-            <a:srgbClr val="1565C0"/>
-          </a:solidFill>
-          <a:ln/>
-        </p:spPr>
-      </p:sp>
-      <p:sp>
-        <p:nvSpPr>
-          <p:cNvPr id="24" name="Text 22"/>
-          <p:cNvSpPr/>
-          <p:nvPr/>
-        </p:nvSpPr>
-        <p:spPr>
-          <a:xfrm>
-            <a:off x="685800" y="4206240"/>
-            <a:ext cx="7818120" cy="521208"/>
+            <a:off x="640080" y="3383280"/>
+            <a:ext cx="7863840" cy="475488"/>
           </a:xfrm>
           <a:prstGeom prst="rect">
             <a:avLst/>
@@ -2299,6 +2260,85 @@
               <a:t>DROP VIEW IF EXISTS v_artistes_actifs;</a:t>
             </a:r>
             <a:endParaRPr lang="en-US" sz="1000" dirty="0"/>
+          </a:p>
+        </p:txBody>
+      </p:sp>
+      <p:sp>
+        <p:nvSpPr>
+          <p:cNvPr id="22" name="Shape 20"/>
+          <p:cNvSpPr/>
+          <p:nvPr/>
+        </p:nvSpPr>
+        <p:spPr>
+          <a:xfrm>
+            <a:off x="457200" y="3886200"/>
+            <a:ext cx="8229600" cy="475488"/>
+          </a:xfrm>
+          <a:prstGeom prst="rect">
+            <a:avLst/>
+          </a:prstGeom>
+          <a:solidFill>
+            <a:srgbClr val="FFFFFF"/>
+          </a:solidFill>
+          <a:ln/>
+        </p:spPr>
+      </p:sp>
+      <p:sp>
+        <p:nvSpPr>
+          <p:cNvPr id="23" name="Shape 21"/>
+          <p:cNvSpPr/>
+          <p:nvPr/>
+        </p:nvSpPr>
+        <p:spPr>
+          <a:xfrm>
+            <a:off x="457200" y="3886200"/>
+            <a:ext cx="45720" cy="475488"/>
+          </a:xfrm>
+          <a:prstGeom prst="rect">
+            <a:avLst/>
+          </a:prstGeom>
+          <a:solidFill>
+            <a:srgbClr val="1565C0"/>
+          </a:solidFill>
+          <a:ln/>
+        </p:spPr>
+      </p:sp>
+      <p:sp>
+        <p:nvSpPr>
+          <p:cNvPr id="24" name="Text 22"/>
+          <p:cNvSpPr/>
+          <p:nvPr/>
+        </p:nvSpPr>
+        <p:spPr>
+          <a:xfrm>
+            <a:off x="640080" y="3886200"/>
+            <a:ext cx="7863840" cy="475488"/>
+          </a:xfrm>
+          <a:prstGeom prst="rect">
+            <a:avLst/>
+          </a:prstGeom>
+          <a:noFill/>
+          <a:ln/>
+        </p:spPr>
+        <p:txBody>
+          <a:bodyPr wrap="square" lIns="0" tIns="0" rIns="0" bIns="0" rtlCol="0" anchor="ctr"/>
+          <a:lstStyle/>
+          <a:p>
+            <a:pPr indent="0" marL="0">
+              <a:buNone/>
+            </a:pPr>
+            <a:r>
+              <a:rPr lang="en-US" sz="1100" dirty="0">
+                <a:solidFill>
+                  <a:srgbClr val="1A1A2E"/>
+                </a:solidFill>
+                <a:latin typeface="Calibri" pitchFamily="34" charset="0"/>
+                <a:ea typeface="Calibri" pitchFamily="34" charset="-122"/>
+                <a:cs typeface="Calibri" pitchFamily="34" charset="-120"/>
+              </a:rPr>
+              <a:t>Securite : GRANT SELECT sur la vue, pas sur la table source</a:t>
+            </a:r>
+            <a:endParaRPr lang="en-US" sz="1100" dirty="0"/>
           </a:p>
         </p:txBody>
       </p:sp>
@@ -2363,7 +2403,7 @@
         <p:spPr>
           <a:xfrm>
             <a:off x="457200" y="182880"/>
-            <a:ext cx="8229600" cy="594360"/>
+            <a:ext cx="8229600" cy="548640"/>
           </a:xfrm>
           <a:prstGeom prst="rect">
             <a:avLst/>
@@ -2379,7 +2419,7 @@
               <a:buNone/>
             </a:pPr>
             <a:r>
-              <a:rPr lang="en-US" sz="2400" b="1" dirty="0">
+              <a:rPr lang="en-US" sz="2200" b="1" dirty="0">
                 <a:solidFill>
                   <a:srgbClr val="0D47A1"/>
                 </a:solidFill>
@@ -2387,9 +2427,9 @@
                 <a:ea typeface="Trebuchet MS" pitchFamily="34" charset="-122"/>
                 <a:cs typeface="Trebuchet MS" pitchFamily="34" charset="-120"/>
               </a:rPr>
-              <a:t>Procédures stockées</a:t>
-            </a:r>
-            <a:endParaRPr lang="en-US" sz="2400" dirty="0"/>
+              <a:t>Procedures stockees — syntaxe MySQL</a:t>
+            </a:r>
+            <a:endParaRPr lang="en-US" sz="2200" dirty="0"/>
           </a:p>
         </p:txBody>
       </p:sp>
@@ -2401,8 +2441,8 @@
         </p:nvSpPr>
         <p:spPr>
           <a:xfrm>
-            <a:off x="457200" y="914400"/>
-            <a:ext cx="8229600" cy="275023"/>
+            <a:off x="457200" y="868680"/>
+            <a:ext cx="8229600" cy="330015"/>
           </a:xfrm>
           <a:prstGeom prst="rect">
             <a:avLst/>
@@ -2411,13 +2451,6 @@
             <a:srgbClr val="FFFFFF"/>
           </a:solidFill>
           <a:ln/>
-          <a:effectLst>
-            <a:outerShdw sx="100000" sy="100000" kx="0" ky="0" algn="bl" rotWithShape="0" blurRad="50800" dist="25400" dir="8100000">
-              <a:srgbClr val="000000">
-                <a:alpha val="12000"/>
-              </a:srgbClr>
-            </a:outerShdw>
-          </a:effectLst>
         </p:spPr>
       </p:sp>
       <p:sp>
@@ -2428,8 +2461,8 @@
         </p:nvSpPr>
         <p:spPr>
           <a:xfrm>
-            <a:off x="457200" y="914400"/>
-            <a:ext cx="45720" cy="275023"/>
+            <a:off x="457200" y="868680"/>
+            <a:ext cx="45720" cy="330015"/>
           </a:xfrm>
           <a:prstGeom prst="rect">
             <a:avLst/>
@@ -2448,8 +2481,8 @@
         </p:nvSpPr>
         <p:spPr>
           <a:xfrm>
-            <a:off x="685800" y="914400"/>
-            <a:ext cx="7818120" cy="275023"/>
+            <a:off x="640080" y="868680"/>
+            <a:ext cx="7863840" cy="330015"/>
           </a:xfrm>
           <a:prstGeom prst="rect">
             <a:avLst/>
@@ -2487,8 +2520,8 @@
         </p:nvSpPr>
         <p:spPr>
           <a:xfrm>
-            <a:off x="457200" y="1216855"/>
-            <a:ext cx="8229600" cy="275023"/>
+            <a:off x="457200" y="1226127"/>
+            <a:ext cx="8229600" cy="330015"/>
           </a:xfrm>
           <a:prstGeom prst="rect">
             <a:avLst/>
@@ -2497,13 +2530,6 @@
             <a:srgbClr val="E3F2FD"/>
           </a:solidFill>
           <a:ln/>
-          <a:effectLst>
-            <a:outerShdw sx="100000" sy="100000" kx="0" ky="0" algn="bl" rotWithShape="0" blurRad="50800" dist="25400" dir="8100000">
-              <a:srgbClr val="000000">
-                <a:alpha val="12000"/>
-              </a:srgbClr>
-            </a:outerShdw>
-          </a:effectLst>
         </p:spPr>
       </p:sp>
       <p:sp>
@@ -2514,8 +2540,8 @@
         </p:nvSpPr>
         <p:spPr>
           <a:xfrm>
-            <a:off x="457200" y="1216855"/>
-            <a:ext cx="45720" cy="275023"/>
+            <a:off x="457200" y="1226127"/>
+            <a:ext cx="45720" cy="330015"/>
           </a:xfrm>
           <a:prstGeom prst="rect">
             <a:avLst/>
@@ -2534,8 +2560,8 @@
         </p:nvSpPr>
         <p:spPr>
           <a:xfrm>
-            <a:off x="685800" y="1216855"/>
-            <a:ext cx="7818120" cy="275023"/>
+            <a:off x="640080" y="1226127"/>
+            <a:ext cx="7863840" cy="330015"/>
           </a:xfrm>
           <a:prstGeom prst="rect">
             <a:avLst/>
@@ -2573,8 +2599,8 @@
         </p:nvSpPr>
         <p:spPr>
           <a:xfrm>
-            <a:off x="457200" y="1519311"/>
-            <a:ext cx="8229600" cy="275023"/>
+            <a:off x="457200" y="1583575"/>
+            <a:ext cx="8229600" cy="330015"/>
           </a:xfrm>
           <a:prstGeom prst="rect">
             <a:avLst/>
@@ -2583,13 +2609,6 @@
             <a:srgbClr val="FFFFFF"/>
           </a:solidFill>
           <a:ln/>
-          <a:effectLst>
-            <a:outerShdw sx="100000" sy="100000" kx="0" ky="0" algn="bl" rotWithShape="0" blurRad="50800" dist="25400" dir="8100000">
-              <a:srgbClr val="000000">
-                <a:alpha val="12000"/>
-              </a:srgbClr>
-            </a:outerShdw>
-          </a:effectLst>
         </p:spPr>
       </p:sp>
       <p:sp>
@@ -2600,8 +2619,8 @@
         </p:nvSpPr>
         <p:spPr>
           <a:xfrm>
-            <a:off x="457200" y="1519311"/>
-            <a:ext cx="45720" cy="275023"/>
+            <a:off x="457200" y="1583575"/>
+            <a:ext cx="45720" cy="330015"/>
           </a:xfrm>
           <a:prstGeom prst="rect">
             <a:avLst/>
@@ -2620,8 +2639,8 @@
         </p:nvSpPr>
         <p:spPr>
           <a:xfrm>
-            <a:off x="685800" y="1519311"/>
-            <a:ext cx="7818120" cy="275023"/>
+            <a:off x="640080" y="1583575"/>
+            <a:ext cx="7863840" cy="330015"/>
           </a:xfrm>
           <a:prstGeom prst="rect">
             <a:avLst/>
@@ -2659,8 +2678,8 @@
         </p:nvSpPr>
         <p:spPr>
           <a:xfrm>
-            <a:off x="457200" y="1821766"/>
-            <a:ext cx="8229600" cy="275023"/>
+            <a:off x="457200" y="1941022"/>
+            <a:ext cx="8229600" cy="330015"/>
           </a:xfrm>
           <a:prstGeom prst="rect">
             <a:avLst/>
@@ -2669,13 +2688,6 @@
             <a:srgbClr val="E3F2FD"/>
           </a:solidFill>
           <a:ln/>
-          <a:effectLst>
-            <a:outerShdw sx="100000" sy="100000" kx="0" ky="0" algn="bl" rotWithShape="0" blurRad="50800" dist="25400" dir="8100000">
-              <a:srgbClr val="000000">
-                <a:alpha val="12000"/>
-              </a:srgbClr>
-            </a:outerShdw>
-          </a:effectLst>
         </p:spPr>
       </p:sp>
       <p:sp>
@@ -2686,8 +2698,8 @@
         </p:nvSpPr>
         <p:spPr>
           <a:xfrm>
-            <a:off x="457200" y="1821766"/>
-            <a:ext cx="45720" cy="275023"/>
+            <a:off x="457200" y="1941022"/>
+            <a:ext cx="45720" cy="330015"/>
           </a:xfrm>
           <a:prstGeom prst="rect">
             <a:avLst/>
@@ -2706,8 +2718,8 @@
         </p:nvSpPr>
         <p:spPr>
           <a:xfrm>
-            <a:off x="685800" y="1821766"/>
-            <a:ext cx="7818120" cy="275023"/>
+            <a:off x="640080" y="1941022"/>
+            <a:ext cx="7863840" cy="330015"/>
           </a:xfrm>
           <a:prstGeom prst="rect">
             <a:avLst/>
@@ -2723,7 +2735,7 @@
               <a:buNone/>
             </a:pPr>
             <a:r>
-              <a:rPr lang="en-US" sz="1200" dirty="0">
+              <a:rPr lang="en-US" sz="1100" dirty="0">
                 <a:solidFill>
                   <a:srgbClr val="1A1A2E"/>
                 </a:solidFill>
@@ -2733,7 +2745,7 @@
               </a:rPr>
               <a:t>  DECLARE v_conflit INT;</a:t>
             </a:r>
-            <a:endParaRPr lang="en-US" sz="1200" dirty="0"/>
+            <a:endParaRPr lang="en-US" sz="1100" dirty="0"/>
           </a:p>
         </p:txBody>
       </p:sp>
@@ -2745,8 +2757,8 @@
         </p:nvSpPr>
         <p:spPr>
           <a:xfrm>
-            <a:off x="457200" y="2124222"/>
-            <a:ext cx="8229600" cy="275023"/>
+            <a:off x="457200" y="2298469"/>
+            <a:ext cx="8229600" cy="330015"/>
           </a:xfrm>
           <a:prstGeom prst="rect">
             <a:avLst/>
@@ -2755,13 +2767,6 @@
             <a:srgbClr val="FFFFFF"/>
           </a:solidFill>
           <a:ln/>
-          <a:effectLst>
-            <a:outerShdw sx="100000" sy="100000" kx="0" ky="0" algn="bl" rotWithShape="0" blurRad="50800" dist="25400" dir="8100000">
-              <a:srgbClr val="000000">
-                <a:alpha val="12000"/>
-              </a:srgbClr>
-            </a:outerShdw>
-          </a:effectLst>
         </p:spPr>
       </p:sp>
       <p:sp>
@@ -2772,8 +2777,8 @@
         </p:nvSpPr>
         <p:spPr>
           <a:xfrm>
-            <a:off x="457200" y="2124222"/>
-            <a:ext cx="45720" cy="275023"/>
+            <a:off x="457200" y="2298469"/>
+            <a:ext cx="45720" cy="330015"/>
           </a:xfrm>
           <a:prstGeom prst="rect">
             <a:avLst/>
@@ -2792,8 +2797,8 @@
         </p:nvSpPr>
         <p:spPr>
           <a:xfrm>
-            <a:off x="685800" y="2124222"/>
-            <a:ext cx="7818120" cy="275023"/>
+            <a:off x="640080" y="2298469"/>
+            <a:ext cx="7863840" cy="330015"/>
           </a:xfrm>
           <a:prstGeom prst="rect">
             <a:avLst/>
@@ -2831,8 +2836,8 @@
         </p:nvSpPr>
         <p:spPr>
           <a:xfrm>
-            <a:off x="457200" y="2426677"/>
-            <a:ext cx="8229600" cy="275023"/>
+            <a:off x="457200" y="2655916"/>
+            <a:ext cx="8229600" cy="330015"/>
           </a:xfrm>
           <a:prstGeom prst="rect">
             <a:avLst/>
@@ -2841,13 +2846,6 @@
             <a:srgbClr val="E3F2FD"/>
           </a:solidFill>
           <a:ln/>
-          <a:effectLst>
-            <a:outerShdw sx="100000" sy="100000" kx="0" ky="0" algn="bl" rotWithShape="0" blurRad="50800" dist="25400" dir="8100000">
-              <a:srgbClr val="000000">
-                <a:alpha val="12000"/>
-              </a:srgbClr>
-            </a:outerShdw>
-          </a:effectLst>
         </p:spPr>
       </p:sp>
       <p:sp>
@@ -2858,8 +2856,8 @@
         </p:nvSpPr>
         <p:spPr>
           <a:xfrm>
-            <a:off x="457200" y="2426677"/>
-            <a:ext cx="45720" cy="275023"/>
+            <a:off x="457200" y="2655916"/>
+            <a:ext cx="45720" cy="330015"/>
           </a:xfrm>
           <a:prstGeom prst="rect">
             <a:avLst/>
@@ -2878,8 +2876,8 @@
         </p:nvSpPr>
         <p:spPr>
           <a:xfrm>
-            <a:off x="685800" y="2426677"/>
-            <a:ext cx="7818120" cy="275023"/>
+            <a:off x="640080" y="2655916"/>
+            <a:ext cx="7863840" cy="330015"/>
           </a:xfrm>
           <a:prstGeom prst="rect">
             <a:avLst/>
@@ -2895,7 +2893,7 @@
               <a:buNone/>
             </a:pPr>
             <a:r>
-              <a:rPr lang="en-US" sz="1200" dirty="0">
+              <a:rPr lang="en-US" sz="1100" dirty="0">
                 <a:solidFill>
                   <a:srgbClr val="1A1A2E"/>
                 </a:solidFill>
@@ -2903,9 +2901,9 @@
                 <a:ea typeface="Calibri" pitchFamily="34" charset="-122"/>
                 <a:cs typeface="Calibri" pitchFamily="34" charset="-120"/>
               </a:rPr>
-              <a:t>  IF v_conflit &gt; 0 THEN</a:t>
-            </a:r>
-            <a:endParaRPr lang="en-US" sz="1200" dirty="0"/>
+              <a:t>  IF v_conflit &gt; 0 THEN SIGNAL SQLSTATE '45000' ...</a:t>
+            </a:r>
+            <a:endParaRPr lang="en-US" sz="1100" dirty="0"/>
           </a:p>
         </p:txBody>
       </p:sp>
@@ -2917,8 +2915,8 @@
         </p:nvSpPr>
         <p:spPr>
           <a:xfrm>
-            <a:off x="457200" y="2729132"/>
-            <a:ext cx="8229600" cy="275023"/>
+            <a:off x="457200" y="3013364"/>
+            <a:ext cx="8229600" cy="330015"/>
           </a:xfrm>
           <a:prstGeom prst="rect">
             <a:avLst/>
@@ -2927,13 +2925,6 @@
             <a:srgbClr val="FFFFFF"/>
           </a:solidFill>
           <a:ln/>
-          <a:effectLst>
-            <a:outerShdw sx="100000" sy="100000" kx="0" ky="0" algn="bl" rotWithShape="0" blurRad="50800" dist="25400" dir="8100000">
-              <a:srgbClr val="000000">
-                <a:alpha val="12000"/>
-              </a:srgbClr>
-            </a:outerShdw>
-          </a:effectLst>
         </p:spPr>
       </p:sp>
       <p:sp>
@@ -2944,8 +2935,8 @@
         </p:nvSpPr>
         <p:spPr>
           <a:xfrm>
-            <a:off x="457200" y="2729132"/>
-            <a:ext cx="45720" cy="275023"/>
+            <a:off x="457200" y="3013364"/>
+            <a:ext cx="45720" cy="330015"/>
           </a:xfrm>
           <a:prstGeom prst="rect">
             <a:avLst/>
@@ -2964,8 +2955,8 @@
         </p:nvSpPr>
         <p:spPr>
           <a:xfrm>
-            <a:off x="685800" y="2729132"/>
-            <a:ext cx="7818120" cy="275023"/>
+            <a:off x="640080" y="3013364"/>
+            <a:ext cx="7863840" cy="330015"/>
           </a:xfrm>
           <a:prstGeom prst="rect">
             <a:avLst/>
@@ -2981,7 +2972,7 @@
               <a:buNone/>
             </a:pPr>
             <a:r>
-              <a:rPr lang="en-US" sz="1200" dirty="0">
+              <a:rPr lang="en-US" sz="1100" dirty="0">
                 <a:solidFill>
                   <a:srgbClr val="1A1A2E"/>
                 </a:solidFill>
@@ -2989,9 +2980,9 @@
                 <a:ea typeface="Calibri" pitchFamily="34" charset="-122"/>
                 <a:cs typeface="Calibri" pitchFamily="34" charset="-120"/>
               </a:rPr>
-              <a:t>    SIGNAL SQLSTATE '45000' SET MESSAGE_TEXT = 'Salle occupée';</a:t>
-            </a:r>
-            <a:endParaRPr lang="en-US" sz="1200" dirty="0"/>
+              <a:t>  ELSE INSERT INTO session (...) VALUES (...);</a:t>
+            </a:r>
+            <a:endParaRPr lang="en-US" sz="1100" dirty="0"/>
           </a:p>
         </p:txBody>
       </p:sp>
@@ -3003,8 +2994,8 @@
         </p:nvSpPr>
         <p:spPr>
           <a:xfrm>
-            <a:off x="457200" y="3031588"/>
-            <a:ext cx="8229600" cy="275023"/>
+            <a:off x="457200" y="3370811"/>
+            <a:ext cx="8229600" cy="330015"/>
           </a:xfrm>
           <a:prstGeom prst="rect">
             <a:avLst/>
@@ -3013,13 +3004,6 @@
             <a:srgbClr val="E3F2FD"/>
           </a:solidFill>
           <a:ln/>
-          <a:effectLst>
-            <a:outerShdw sx="100000" sy="100000" kx="0" ky="0" algn="bl" rotWithShape="0" blurRad="50800" dist="25400" dir="8100000">
-              <a:srgbClr val="000000">
-                <a:alpha val="12000"/>
-              </a:srgbClr>
-            </a:outerShdw>
-          </a:effectLst>
         </p:spPr>
       </p:sp>
       <p:sp>
@@ -3030,8 +3014,8 @@
         </p:nvSpPr>
         <p:spPr>
           <a:xfrm>
-            <a:off x="457200" y="3031588"/>
-            <a:ext cx="45720" cy="275023"/>
+            <a:off x="457200" y="3370811"/>
+            <a:ext cx="45720" cy="330015"/>
           </a:xfrm>
           <a:prstGeom prst="rect">
             <a:avLst/>
@@ -3050,8 +3034,8 @@
         </p:nvSpPr>
         <p:spPr>
           <a:xfrm>
-            <a:off x="685800" y="3031588"/>
-            <a:ext cx="7818120" cy="275023"/>
+            <a:off x="640080" y="3370811"/>
+            <a:ext cx="7863840" cy="330015"/>
           </a:xfrm>
           <a:prstGeom prst="rect">
             <a:avLst/>
@@ -3067,179 +3051,7 @@
               <a:buNone/>
             </a:pPr>
             <a:r>
-              <a:rPr lang="en-US" sz="1200" dirty="0">
-                <a:solidFill>
-                  <a:srgbClr val="1A1A2E"/>
-                </a:solidFill>
-                <a:latin typeface="Calibri" pitchFamily="34" charset="0"/>
-                <a:ea typeface="Calibri" pitchFamily="34" charset="-122"/>
-                <a:cs typeface="Calibri" pitchFamily="34" charset="-120"/>
-              </a:rPr>
-              <a:t>  ELSE</a:t>
-            </a:r>
-            <a:endParaRPr lang="en-US" sz="1200" dirty="0"/>
-          </a:p>
-        </p:txBody>
-      </p:sp>
-      <p:sp>
-        <p:nvSpPr>
-          <p:cNvPr id="28" name="Shape 26"/>
-          <p:cNvSpPr/>
-          <p:nvPr/>
-        </p:nvSpPr>
-        <p:spPr>
-          <a:xfrm>
-            <a:off x="457200" y="3334043"/>
-            <a:ext cx="8229600" cy="275023"/>
-          </a:xfrm>
-          <a:prstGeom prst="rect">
-            <a:avLst/>
-          </a:prstGeom>
-          <a:solidFill>
-            <a:srgbClr val="FFFFFF"/>
-          </a:solidFill>
-          <a:ln/>
-          <a:effectLst>
-            <a:outerShdw sx="100000" sy="100000" kx="0" ky="0" algn="bl" rotWithShape="0" blurRad="50800" dist="25400" dir="8100000">
-              <a:srgbClr val="000000">
-                <a:alpha val="12000"/>
-              </a:srgbClr>
-            </a:outerShdw>
-          </a:effectLst>
-        </p:spPr>
-      </p:sp>
-      <p:sp>
-        <p:nvSpPr>
-          <p:cNvPr id="29" name="Shape 27"/>
-          <p:cNvSpPr/>
-          <p:nvPr/>
-        </p:nvSpPr>
-        <p:spPr>
-          <a:xfrm>
-            <a:off x="457200" y="3334043"/>
-            <a:ext cx="45720" cy="275023"/>
-          </a:xfrm>
-          <a:prstGeom prst="rect">
-            <a:avLst/>
-          </a:prstGeom>
-          <a:solidFill>
-            <a:srgbClr val="1565C0"/>
-          </a:solidFill>
-          <a:ln/>
-        </p:spPr>
-      </p:sp>
-      <p:sp>
-        <p:nvSpPr>
-          <p:cNvPr id="30" name="Text 28"/>
-          <p:cNvSpPr/>
-          <p:nvPr/>
-        </p:nvSpPr>
-        <p:spPr>
-          <a:xfrm>
-            <a:off x="685800" y="3334043"/>
-            <a:ext cx="7818120" cy="275023"/>
-          </a:xfrm>
-          <a:prstGeom prst="rect">
-            <a:avLst/>
-          </a:prstGeom>
-          <a:noFill/>
-          <a:ln/>
-        </p:spPr>
-        <p:txBody>
-          <a:bodyPr wrap="square" lIns="0" tIns="0" rIns="0" bIns="0" rtlCol="0" anchor="ctr"/>
-          <a:lstStyle/>
-          <a:p>
-            <a:pPr indent="0" marL="0">
-              <a:buNone/>
-            </a:pPr>
-            <a:r>
-              <a:rPr lang="en-US" sz="1000" dirty="0">
-                <a:solidFill>
-                  <a:srgbClr val="0D47A1"/>
-                </a:solidFill>
-                <a:latin typeface="JetBrains Mono" pitchFamily="34" charset="0"/>
-                <a:ea typeface="JetBrains Mono" pitchFamily="34" charset="-122"/>
-                <a:cs typeface="JetBrains Mono" pitchFamily="34" charset="-120"/>
-              </a:rPr>
-              <a:t>    INSERT INTO session (...) VALUES (...);</a:t>
-            </a:r>
-            <a:endParaRPr lang="en-US" sz="1000" dirty="0"/>
-          </a:p>
-        </p:txBody>
-      </p:sp>
-      <p:sp>
-        <p:nvSpPr>
-          <p:cNvPr id="31" name="Shape 29"/>
-          <p:cNvSpPr/>
-          <p:nvPr/>
-        </p:nvSpPr>
-        <p:spPr>
-          <a:xfrm>
-            <a:off x="457200" y="3636498"/>
-            <a:ext cx="8229600" cy="275023"/>
-          </a:xfrm>
-          <a:prstGeom prst="rect">
-            <a:avLst/>
-          </a:prstGeom>
-          <a:solidFill>
-            <a:srgbClr val="E3F2FD"/>
-          </a:solidFill>
-          <a:ln/>
-          <a:effectLst>
-            <a:outerShdw sx="100000" sy="100000" kx="0" ky="0" algn="bl" rotWithShape="0" blurRad="50800" dist="25400" dir="8100000">
-              <a:srgbClr val="000000">
-                <a:alpha val="12000"/>
-              </a:srgbClr>
-            </a:outerShdw>
-          </a:effectLst>
-        </p:spPr>
-      </p:sp>
-      <p:sp>
-        <p:nvSpPr>
-          <p:cNvPr id="32" name="Shape 30"/>
-          <p:cNvSpPr/>
-          <p:nvPr/>
-        </p:nvSpPr>
-        <p:spPr>
-          <a:xfrm>
-            <a:off x="457200" y="3636498"/>
-            <a:ext cx="45720" cy="275023"/>
-          </a:xfrm>
-          <a:prstGeom prst="rect">
-            <a:avLst/>
-          </a:prstGeom>
-          <a:solidFill>
-            <a:srgbClr val="1565C0"/>
-          </a:solidFill>
-          <a:ln/>
-        </p:spPr>
-      </p:sp>
-      <p:sp>
-        <p:nvSpPr>
-          <p:cNvPr id="33" name="Text 31"/>
-          <p:cNvSpPr/>
-          <p:nvPr/>
-        </p:nvSpPr>
-        <p:spPr>
-          <a:xfrm>
-            <a:off x="685800" y="3636498"/>
-            <a:ext cx="7818120" cy="275023"/>
-          </a:xfrm>
-          <a:prstGeom prst="rect">
-            <a:avLst/>
-          </a:prstGeom>
-          <a:noFill/>
-          <a:ln/>
-        </p:spPr>
-        <p:txBody>
-          <a:bodyPr wrap="square" lIns="0" tIns="0" rIns="0" bIns="0" rtlCol="0" anchor="ctr"/>
-          <a:lstStyle/>
-          <a:p>
-            <a:pPr indent="0" marL="0">
-              <a:buNone/>
-            </a:pPr>
-            <a:r>
-              <a:rPr lang="en-US" sz="1200" dirty="0">
+              <a:rPr lang="en-US" sz="1100" dirty="0">
                 <a:solidFill>
                   <a:srgbClr val="1A1A2E"/>
                 </a:solidFill>
@@ -3249,20 +3061,20 @@
               </a:rPr>
               <a:t>  END IF;</a:t>
             </a:r>
-            <a:endParaRPr lang="en-US" sz="1200" dirty="0"/>
-          </a:p>
-        </p:txBody>
-      </p:sp>
-      <p:sp>
-        <p:nvSpPr>
-          <p:cNvPr id="34" name="Shape 32"/>
-          <p:cNvSpPr/>
-          <p:nvPr/>
-        </p:nvSpPr>
-        <p:spPr>
-          <a:xfrm>
-            <a:off x="457200" y="3938954"/>
-            <a:ext cx="8229600" cy="275023"/>
+            <a:endParaRPr lang="en-US" sz="1100" dirty="0"/>
+          </a:p>
+        </p:txBody>
+      </p:sp>
+      <p:sp>
+        <p:nvSpPr>
+          <p:cNvPr id="28" name="Shape 26"/>
+          <p:cNvSpPr/>
+          <p:nvPr/>
+        </p:nvSpPr>
+        <p:spPr>
+          <a:xfrm>
+            <a:off x="457200" y="3728258"/>
+            <a:ext cx="8229600" cy="330015"/>
           </a:xfrm>
           <a:prstGeom prst="rect">
             <a:avLst/>
@@ -3271,25 +3083,18 @@
             <a:srgbClr val="FFFFFF"/>
           </a:solidFill>
           <a:ln/>
-          <a:effectLst>
-            <a:outerShdw sx="100000" sy="100000" kx="0" ky="0" algn="bl" rotWithShape="0" blurRad="50800" dist="25400" dir="8100000">
-              <a:srgbClr val="000000">
-                <a:alpha val="12000"/>
-              </a:srgbClr>
-            </a:outerShdw>
-          </a:effectLst>
-        </p:spPr>
-      </p:sp>
-      <p:sp>
-        <p:nvSpPr>
-          <p:cNvPr id="35" name="Shape 33"/>
-          <p:cNvSpPr/>
-          <p:nvPr/>
-        </p:nvSpPr>
-        <p:spPr>
-          <a:xfrm>
-            <a:off x="457200" y="3938954"/>
-            <a:ext cx="45720" cy="275023"/>
+        </p:spPr>
+      </p:sp>
+      <p:sp>
+        <p:nvSpPr>
+          <p:cNvPr id="29" name="Shape 27"/>
+          <p:cNvSpPr/>
+          <p:nvPr/>
+        </p:nvSpPr>
+        <p:spPr>
+          <a:xfrm>
+            <a:off x="457200" y="3728258"/>
+            <a:ext cx="45720" cy="330015"/>
           </a:xfrm>
           <a:prstGeom prst="rect">
             <a:avLst/>
@@ -3302,14 +3107,14 @@
       </p:sp>
       <p:sp>
         <p:nvSpPr>
-          <p:cNvPr id="36" name="Text 34"/>
-          <p:cNvSpPr/>
-          <p:nvPr/>
-        </p:nvSpPr>
-        <p:spPr>
-          <a:xfrm>
-            <a:off x="685800" y="3938954"/>
-            <a:ext cx="7818120" cy="275023"/>
+          <p:cNvPr id="30" name="Text 28"/>
+          <p:cNvSpPr/>
+          <p:nvPr/>
+        </p:nvSpPr>
+        <p:spPr>
+          <a:xfrm>
+            <a:off x="640080" y="3728258"/>
+            <a:ext cx="7863840" cy="330015"/>
           </a:xfrm>
           <a:prstGeom prst="rect">
             <a:avLst/>
@@ -3325,7 +3130,7 @@
               <a:buNone/>
             </a:pPr>
             <a:r>
-              <a:rPr lang="en-US" sz="1200" dirty="0">
+              <a:rPr lang="en-US" sz="1100" dirty="0">
                 <a:solidFill>
                   <a:srgbClr val="1A1A2E"/>
                 </a:solidFill>
@@ -3335,20 +3140,20 @@
               </a:rPr>
               <a:t>END //</a:t>
             </a:r>
-            <a:endParaRPr lang="en-US" sz="1200" dirty="0"/>
-          </a:p>
-        </p:txBody>
-      </p:sp>
-      <p:sp>
-        <p:nvSpPr>
-          <p:cNvPr id="37" name="Shape 35"/>
-          <p:cNvSpPr/>
-          <p:nvPr/>
-        </p:nvSpPr>
-        <p:spPr>
-          <a:xfrm>
-            <a:off x="457200" y="4241409"/>
-            <a:ext cx="8229600" cy="275023"/>
+            <a:endParaRPr lang="en-US" sz="1100" dirty="0"/>
+          </a:p>
+        </p:txBody>
+      </p:sp>
+      <p:sp>
+        <p:nvSpPr>
+          <p:cNvPr id="31" name="Shape 29"/>
+          <p:cNvSpPr/>
+          <p:nvPr/>
+        </p:nvSpPr>
+        <p:spPr>
+          <a:xfrm>
+            <a:off x="457200" y="4085705"/>
+            <a:ext cx="8229600" cy="330015"/>
           </a:xfrm>
           <a:prstGeom prst="rect">
             <a:avLst/>
@@ -3357,25 +3162,18 @@
             <a:srgbClr val="E3F2FD"/>
           </a:solidFill>
           <a:ln/>
-          <a:effectLst>
-            <a:outerShdw sx="100000" sy="100000" kx="0" ky="0" algn="bl" rotWithShape="0" blurRad="50800" dist="25400" dir="8100000">
-              <a:srgbClr val="000000">
-                <a:alpha val="12000"/>
-              </a:srgbClr>
-            </a:outerShdw>
-          </a:effectLst>
-        </p:spPr>
-      </p:sp>
-      <p:sp>
-        <p:nvSpPr>
-          <p:cNvPr id="38" name="Shape 36"/>
-          <p:cNvSpPr/>
-          <p:nvPr/>
-        </p:nvSpPr>
-        <p:spPr>
-          <a:xfrm>
-            <a:off x="457200" y="4241409"/>
-            <a:ext cx="45720" cy="275023"/>
+        </p:spPr>
+      </p:sp>
+      <p:sp>
+        <p:nvSpPr>
+          <p:cNvPr id="32" name="Shape 30"/>
+          <p:cNvSpPr/>
+          <p:nvPr/>
+        </p:nvSpPr>
+        <p:spPr>
+          <a:xfrm>
+            <a:off x="457200" y="4085705"/>
+            <a:ext cx="45720" cy="330015"/>
           </a:xfrm>
           <a:prstGeom prst="rect">
             <a:avLst/>
@@ -3388,14 +3186,14 @@
       </p:sp>
       <p:sp>
         <p:nvSpPr>
-          <p:cNvPr id="39" name="Text 37"/>
-          <p:cNvSpPr/>
-          <p:nvPr/>
-        </p:nvSpPr>
-        <p:spPr>
-          <a:xfrm>
-            <a:off x="685800" y="4241409"/>
-            <a:ext cx="7818120" cy="275023"/>
+          <p:cNvPr id="33" name="Text 31"/>
+          <p:cNvSpPr/>
+          <p:nvPr/>
+        </p:nvSpPr>
+        <p:spPr>
+          <a:xfrm>
+            <a:off x="640080" y="4085705"/>
+            <a:ext cx="7863840" cy="330015"/>
           </a:xfrm>
           <a:prstGeom prst="rect">
             <a:avLst/>
@@ -3427,14 +3225,14 @@
       </p:sp>
       <p:sp>
         <p:nvSpPr>
-          <p:cNvPr id="40" name="Shape 38"/>
-          <p:cNvSpPr/>
-          <p:nvPr/>
-        </p:nvSpPr>
-        <p:spPr>
-          <a:xfrm>
-            <a:off x="457200" y="4543865"/>
-            <a:ext cx="8229600" cy="275023"/>
+          <p:cNvPr id="34" name="Shape 32"/>
+          <p:cNvSpPr/>
+          <p:nvPr/>
+        </p:nvSpPr>
+        <p:spPr>
+          <a:xfrm>
+            <a:off x="457200" y="4443153"/>
+            <a:ext cx="8229600" cy="330015"/>
           </a:xfrm>
           <a:prstGeom prst="rect">
             <a:avLst/>
@@ -3443,25 +3241,18 @@
             <a:srgbClr val="FFFFFF"/>
           </a:solidFill>
           <a:ln/>
-          <a:effectLst>
-            <a:outerShdw sx="100000" sy="100000" kx="0" ky="0" algn="bl" rotWithShape="0" blurRad="50800" dist="25400" dir="8100000">
-              <a:srgbClr val="000000">
-                <a:alpha val="12000"/>
-              </a:srgbClr>
-            </a:outerShdw>
-          </a:effectLst>
-        </p:spPr>
-      </p:sp>
-      <p:sp>
-        <p:nvSpPr>
-          <p:cNvPr id="41" name="Shape 39"/>
-          <p:cNvSpPr/>
-          <p:nvPr/>
-        </p:nvSpPr>
-        <p:spPr>
-          <a:xfrm>
-            <a:off x="457200" y="4543865"/>
-            <a:ext cx="45720" cy="275023"/>
+        </p:spPr>
+      </p:sp>
+      <p:sp>
+        <p:nvSpPr>
+          <p:cNvPr id="35" name="Shape 33"/>
+          <p:cNvSpPr/>
+          <p:nvPr/>
+        </p:nvSpPr>
+        <p:spPr>
+          <a:xfrm>
+            <a:off x="457200" y="4443153"/>
+            <a:ext cx="45720" cy="330015"/>
           </a:xfrm>
           <a:prstGeom prst="rect">
             <a:avLst/>
@@ -3474,14 +3265,14 @@
       </p:sp>
       <p:sp>
         <p:nvSpPr>
-          <p:cNvPr id="42" name="Text 40"/>
-          <p:cNvSpPr/>
-          <p:nvPr/>
-        </p:nvSpPr>
-        <p:spPr>
-          <a:xfrm>
-            <a:off x="685800" y="4543865"/>
-            <a:ext cx="7818120" cy="275023"/>
+          <p:cNvPr id="36" name="Text 34"/>
+          <p:cNvSpPr/>
+          <p:nvPr/>
+        </p:nvSpPr>
+        <p:spPr>
+          <a:xfrm>
+            <a:off x="640080" y="4443153"/>
+            <a:ext cx="7863840" cy="330015"/>
           </a:xfrm>
           <a:prstGeom prst="rect">
             <a:avLst/>
@@ -3497,7 +3288,7 @@
               <a:buNone/>
             </a:pPr>
             <a:r>
-              <a:rPr lang="en-US" sz="1200" dirty="0">
+              <a:rPr lang="en-US" sz="1100" dirty="0">
                 <a:solidFill>
                   <a:srgbClr val="1A1A2E"/>
                 </a:solidFill>
@@ -3507,7 +3298,7 @@
               </a:rPr>
               <a:t>Appel : CALL sp_ajouter_session('2025-05-01', 1);</a:t>
             </a:r>
-            <a:endParaRPr lang="en-US" sz="1200" dirty="0"/>
+            <a:endParaRPr lang="en-US" sz="1100" dirty="0"/>
           </a:p>
         </p:txBody>
       </p:sp>
@@ -3572,7 +3363,7 @@
         <p:spPr>
           <a:xfrm>
             <a:off x="457200" y="182880"/>
-            <a:ext cx="8229600" cy="594360"/>
+            <a:ext cx="8229600" cy="548640"/>
           </a:xfrm>
           <a:prstGeom prst="rect">
             <a:avLst/>
@@ -3588,7 +3379,7 @@
               <a:buNone/>
             </a:pPr>
             <a:r>
-              <a:rPr lang="en-US" sz="2400" b="1" dirty="0">
+              <a:rPr lang="en-US" sz="2200" b="1" dirty="0">
                 <a:solidFill>
                   <a:srgbClr val="0D47A1"/>
                 </a:solidFill>
@@ -3596,9 +3387,9 @@
                 <a:ea typeface="Trebuchet MS" pitchFamily="34" charset="-122"/>
                 <a:cs typeface="Trebuchet MS" pitchFamily="34" charset="-120"/>
               </a:rPr>
-              <a:t>Fonctions et Triggers</a:t>
-            </a:r>
-            <a:endParaRPr lang="en-US" sz="2400" dirty="0"/>
+              <a:t>Fonctions — retournent une valeur</a:t>
+            </a:r>
+            <a:endParaRPr lang="en-US" sz="2200" dirty="0"/>
           </a:p>
         </p:txBody>
       </p:sp>
@@ -3610,8 +3401,8 @@
         </p:nvSpPr>
         <p:spPr>
           <a:xfrm>
-            <a:off x="457200" y="914400"/>
-            <a:ext cx="8229600" cy="521208"/>
+            <a:off x="457200" y="868680"/>
+            <a:ext cx="8229600" cy="409448"/>
           </a:xfrm>
           <a:prstGeom prst="rect">
             <a:avLst/>
@@ -3620,13 +3411,6 @@
             <a:srgbClr val="FFFFFF"/>
           </a:solidFill>
           <a:ln/>
-          <a:effectLst>
-            <a:outerShdw sx="100000" sy="100000" kx="0" ky="0" algn="bl" rotWithShape="0" blurRad="50800" dist="25400" dir="8100000">
-              <a:srgbClr val="000000">
-                <a:alpha val="12000"/>
-              </a:srgbClr>
-            </a:outerShdw>
-          </a:effectLst>
         </p:spPr>
       </p:sp>
       <p:sp>
@@ -3637,8 +3421,8 @@
         </p:nvSpPr>
         <p:spPr>
           <a:xfrm>
-            <a:off x="457200" y="914400"/>
-            <a:ext cx="45720" cy="521208"/>
+            <a:off x="457200" y="868680"/>
+            <a:ext cx="45720" cy="409448"/>
           </a:xfrm>
           <a:prstGeom prst="rect">
             <a:avLst/>
@@ -3657,94 +3441,8 @@
         </p:nvSpPr>
         <p:spPr>
           <a:xfrm>
-            <a:off x="685800" y="914400"/>
-            <a:ext cx="7818120" cy="521208"/>
-          </a:xfrm>
-          <a:prstGeom prst="rect">
-            <a:avLst/>
-          </a:prstGeom>
-          <a:noFill/>
-          <a:ln/>
-        </p:spPr>
-        <p:txBody>
-          <a:bodyPr wrap="square" lIns="0" tIns="0" rIns="0" bIns="0" rtlCol="0" anchor="ctr"/>
-          <a:lstStyle/>
-          <a:p>
-            <a:pPr indent="0" marL="0">
-              <a:buNone/>
-            </a:pPr>
-            <a:r>
-              <a:rPr lang="en-US" sz="1200" dirty="0">
-                <a:solidFill>
-                  <a:srgbClr val="1A1A2E"/>
-                </a:solidFill>
-                <a:latin typeface="Calibri" pitchFamily="34" charset="0"/>
-                <a:ea typeface="Calibri" pitchFamily="34" charset="-122"/>
-                <a:cs typeface="Calibri" pitchFamily="34" charset="-120"/>
-              </a:rPr>
-              <a:t>FONCTION : retourne une valeur, utilisable dans SELECT</a:t>
-            </a:r>
-            <a:endParaRPr lang="en-US" sz="1200" dirty="0"/>
-          </a:p>
-        </p:txBody>
-      </p:sp>
-      <p:sp>
-        <p:nvSpPr>
-          <p:cNvPr id="7" name="Shape 5"/>
-          <p:cNvSpPr/>
-          <p:nvPr/>
-        </p:nvSpPr>
-        <p:spPr>
-          <a:xfrm>
-            <a:off x="457200" y="1463040"/>
-            <a:ext cx="8229600" cy="521208"/>
-          </a:xfrm>
-          <a:prstGeom prst="rect">
-            <a:avLst/>
-          </a:prstGeom>
-          <a:solidFill>
-            <a:srgbClr val="E3F2FD"/>
-          </a:solidFill>
-          <a:ln/>
-          <a:effectLst>
-            <a:outerShdw sx="100000" sy="100000" kx="0" ky="0" algn="bl" rotWithShape="0" blurRad="50800" dist="25400" dir="8100000">
-              <a:srgbClr val="000000">
-                <a:alpha val="12000"/>
-              </a:srgbClr>
-            </a:outerShdw>
-          </a:effectLst>
-        </p:spPr>
-      </p:sp>
-      <p:sp>
-        <p:nvSpPr>
-          <p:cNvPr id="8" name="Shape 6"/>
-          <p:cNvSpPr/>
-          <p:nvPr/>
-        </p:nvSpPr>
-        <p:spPr>
-          <a:xfrm>
-            <a:off x="457200" y="1463040"/>
-            <a:ext cx="45720" cy="521208"/>
-          </a:xfrm>
-          <a:prstGeom prst="rect">
-            <a:avLst/>
-          </a:prstGeom>
-          <a:solidFill>
-            <a:srgbClr val="1565C0"/>
-          </a:solidFill>
-          <a:ln/>
-        </p:spPr>
-      </p:sp>
-      <p:sp>
-        <p:nvSpPr>
-          <p:cNvPr id="9" name="Text 7"/>
-          <p:cNvSpPr/>
-          <p:nvPr/>
-        </p:nvSpPr>
-        <p:spPr>
-          <a:xfrm>
-            <a:off x="685800" y="1463040"/>
-            <a:ext cx="7818120" cy="521208"/>
+            <a:off x="640080" y="868680"/>
+            <a:ext cx="7863840" cy="409448"/>
           </a:xfrm>
           <a:prstGeom prst="rect">
             <a:avLst/>
@@ -3768,7 +3466,7 @@
                 <a:ea typeface="JetBrains Mono" pitchFamily="34" charset="-122"/>
                 <a:cs typeface="JetBrains Mono" pitchFamily="34" charset="-120"/>
               </a:rPr>
-              <a:t>CREATE FUNCTION fn_ca_artiste(p_id INT) RETURNS DECIMAL(10,2) ...</a:t>
+              <a:t>CREATE FUNCTION fn_ca_artiste(p_id INT) RETURNS DECIMAL(10,2)</a:t>
             </a:r>
             <a:endParaRPr lang="en-US" sz="1000" dirty="0"/>
           </a:p>
@@ -3776,14 +3474,93 @@
       </p:sp>
       <p:sp>
         <p:nvSpPr>
+          <p:cNvPr id="7" name="Shape 5"/>
+          <p:cNvSpPr/>
+          <p:nvPr/>
+        </p:nvSpPr>
+        <p:spPr>
+          <a:xfrm>
+            <a:off x="457200" y="1305560"/>
+            <a:ext cx="8229600" cy="409448"/>
+          </a:xfrm>
+          <a:prstGeom prst="rect">
+            <a:avLst/>
+          </a:prstGeom>
+          <a:solidFill>
+            <a:srgbClr val="E3F2FD"/>
+          </a:solidFill>
+          <a:ln/>
+        </p:spPr>
+      </p:sp>
+      <p:sp>
+        <p:nvSpPr>
+          <p:cNvPr id="8" name="Shape 6"/>
+          <p:cNvSpPr/>
+          <p:nvPr/>
+        </p:nvSpPr>
+        <p:spPr>
+          <a:xfrm>
+            <a:off x="457200" y="1305560"/>
+            <a:ext cx="45720" cy="409448"/>
+          </a:xfrm>
+          <a:prstGeom prst="rect">
+            <a:avLst/>
+          </a:prstGeom>
+          <a:solidFill>
+            <a:srgbClr val="1565C0"/>
+          </a:solidFill>
+          <a:ln/>
+        </p:spPr>
+      </p:sp>
+      <p:sp>
+        <p:nvSpPr>
+          <p:cNvPr id="9" name="Text 7"/>
+          <p:cNvSpPr/>
+          <p:nvPr/>
+        </p:nvSpPr>
+        <p:spPr>
+          <a:xfrm>
+            <a:off x="640080" y="1305560"/>
+            <a:ext cx="7863840" cy="409448"/>
+          </a:xfrm>
+          <a:prstGeom prst="rect">
+            <a:avLst/>
+          </a:prstGeom>
+          <a:noFill/>
+          <a:ln/>
+        </p:spPr>
+        <p:txBody>
+          <a:bodyPr wrap="square" lIns="0" tIns="0" rIns="0" bIns="0" rtlCol="0" anchor="ctr"/>
+          <a:lstStyle/>
+          <a:p>
+            <a:pPr indent="0" marL="0">
+              <a:buNone/>
+            </a:pPr>
+            <a:r>
+              <a:rPr lang="en-US" sz="1100" dirty="0">
+                <a:solidFill>
+                  <a:srgbClr val="1A1A2E"/>
+                </a:solidFill>
+                <a:latin typeface="Calibri" pitchFamily="34" charset="0"/>
+                <a:ea typeface="Calibri" pitchFamily="34" charset="-122"/>
+                <a:cs typeface="Calibri" pitchFamily="34" charset="-120"/>
+              </a:rPr>
+              <a:t>DETERMINISTIC READS SQL DATA</a:t>
+            </a:r>
+            <a:endParaRPr lang="en-US" sz="1100" dirty="0"/>
+          </a:p>
+        </p:txBody>
+      </p:sp>
+      <p:sp>
+        <p:nvSpPr>
           <p:cNvPr id="10" name="Shape 8"/>
           <p:cNvSpPr/>
           <p:nvPr/>
         </p:nvSpPr>
         <p:spPr>
           <a:xfrm>
-            <a:off x="457200" y="2011680"/>
-            <a:ext cx="8229600" cy="521208"/>
+            <a:off x="457200" y="1742440"/>
+            <a:ext cx="8229600" cy="409448"/>
           </a:xfrm>
           <a:prstGeom prst="rect">
             <a:avLst/>
@@ -3792,13 +3569,6 @@
             <a:srgbClr val="FFFFFF"/>
           </a:solidFill>
           <a:ln/>
-          <a:effectLst>
-            <a:outerShdw sx="100000" sy="100000" kx="0" ky="0" algn="bl" rotWithShape="0" blurRad="50800" dist="25400" dir="8100000">
-              <a:srgbClr val="000000">
-                <a:alpha val="12000"/>
-              </a:srgbClr>
-            </a:outerShdw>
-          </a:effectLst>
         </p:spPr>
       </p:sp>
       <p:sp>
@@ -3809,8 +3579,8 @@
         </p:nvSpPr>
         <p:spPr>
           <a:xfrm>
-            <a:off x="457200" y="2011680"/>
-            <a:ext cx="45720" cy="521208"/>
+            <a:off x="457200" y="1742440"/>
+            <a:ext cx="45720" cy="409448"/>
           </a:xfrm>
           <a:prstGeom prst="rect">
             <a:avLst/>
@@ -3829,8 +3599,8 @@
         </p:nvSpPr>
         <p:spPr>
           <a:xfrm>
-            <a:off x="685800" y="2011680"/>
-            <a:ext cx="7818120" cy="521208"/>
+            <a:off x="640080" y="1742440"/>
+            <a:ext cx="7863840" cy="409448"/>
           </a:xfrm>
           <a:prstGeom prst="rect">
             <a:avLst/>
@@ -3854,7 +3624,7 @@
                 <a:ea typeface="JetBrains Mono" pitchFamily="34" charset="-122"/>
                 <a:cs typeface="JetBrains Mono" pitchFamily="34" charset="-120"/>
               </a:rPr>
-              <a:t>SELECT nom, fn_ca_artiste(id_artiste) AS ca FROM artiste;</a:t>
+              <a:t>BEGIN</a:t>
             </a:r>
             <a:endParaRPr lang="en-US" sz="1000" dirty="0"/>
           </a:p>
@@ -3868,8 +3638,8 @@
         </p:nvSpPr>
         <p:spPr>
           <a:xfrm>
-            <a:off x="457200" y="2560320"/>
-            <a:ext cx="8229600" cy="521208"/>
+            <a:off x="457200" y="2179320"/>
+            <a:ext cx="8229600" cy="409448"/>
           </a:xfrm>
           <a:prstGeom prst="rect">
             <a:avLst/>
@@ -3878,13 +3648,6 @@
             <a:srgbClr val="E3F2FD"/>
           </a:solidFill>
           <a:ln/>
-          <a:effectLst>
-            <a:outerShdw sx="100000" sy="100000" kx="0" ky="0" algn="bl" rotWithShape="0" blurRad="50800" dist="25400" dir="8100000">
-              <a:srgbClr val="000000">
-                <a:alpha val="12000"/>
-              </a:srgbClr>
-            </a:outerShdw>
-          </a:effectLst>
         </p:spPr>
       </p:sp>
       <p:sp>
@@ -3895,8 +3658,8 @@
         </p:nvSpPr>
         <p:spPr>
           <a:xfrm>
-            <a:off x="457200" y="2560320"/>
-            <a:ext cx="45720" cy="521208"/>
+            <a:off x="457200" y="2179320"/>
+            <a:ext cx="45720" cy="409448"/>
           </a:xfrm>
           <a:prstGeom prst="rect">
             <a:avLst/>
@@ -3915,8 +3678,8 @@
         </p:nvSpPr>
         <p:spPr>
           <a:xfrm>
-            <a:off x="685800" y="2560320"/>
-            <a:ext cx="7818120" cy="521208"/>
+            <a:off x="640080" y="2179320"/>
+            <a:ext cx="7863840" cy="409448"/>
           </a:xfrm>
           <a:prstGeom prst="rect">
             <a:avLst/>
@@ -3932,7 +3695,7 @@
               <a:buNone/>
             </a:pPr>
             <a:r>
-              <a:rPr lang="en-US" sz="1200" dirty="0">
+              <a:rPr lang="en-US" sz="1100" dirty="0">
                 <a:solidFill>
                   <a:srgbClr val="1A1A2E"/>
                 </a:solidFill>
@@ -3940,9 +3703,9 @@
                 <a:ea typeface="Calibri" pitchFamily="34" charset="-122"/>
                 <a:cs typeface="Calibri" pitchFamily="34" charset="-120"/>
               </a:rPr>
-              <a:t>TRIGGER : se déclenche AUTOMATIQUEMENT</a:t>
-            </a:r>
-            <a:endParaRPr lang="en-US" sz="1200" dirty="0"/>
+              <a:t>  DECLARE v_ca DECIMAL(10,2);</a:t>
+            </a:r>
+            <a:endParaRPr lang="en-US" sz="1100" dirty="0"/>
           </a:p>
         </p:txBody>
       </p:sp>
@@ -3954,8 +3717,8 @@
         </p:nvSpPr>
         <p:spPr>
           <a:xfrm>
-            <a:off x="457200" y="3108960"/>
-            <a:ext cx="8229600" cy="521208"/>
+            <a:off x="457200" y="2616200"/>
+            <a:ext cx="8229600" cy="409448"/>
           </a:xfrm>
           <a:prstGeom prst="rect">
             <a:avLst/>
@@ -3964,13 +3727,6 @@
             <a:srgbClr val="FFFFFF"/>
           </a:solidFill>
           <a:ln/>
-          <a:effectLst>
-            <a:outerShdw sx="100000" sy="100000" kx="0" ky="0" algn="bl" rotWithShape="0" blurRad="50800" dist="25400" dir="8100000">
-              <a:srgbClr val="000000">
-                <a:alpha val="12000"/>
-              </a:srgbClr>
-            </a:outerShdw>
-          </a:effectLst>
         </p:spPr>
       </p:sp>
       <p:sp>
@@ -3981,8 +3737,8 @@
         </p:nvSpPr>
         <p:spPr>
           <a:xfrm>
-            <a:off x="457200" y="3108960"/>
-            <a:ext cx="45720" cy="521208"/>
+            <a:off x="457200" y="2616200"/>
+            <a:ext cx="45720" cy="409448"/>
           </a:xfrm>
           <a:prstGeom prst="rect">
             <a:avLst/>
@@ -4001,8 +3757,8 @@
         </p:nvSpPr>
         <p:spPr>
           <a:xfrm>
-            <a:off x="685800" y="3108960"/>
-            <a:ext cx="7818120" cy="521208"/>
+            <a:off x="640080" y="2616200"/>
+            <a:ext cx="7863840" cy="409448"/>
           </a:xfrm>
           <a:prstGeom prst="rect">
             <a:avLst/>
@@ -4026,7 +3782,7 @@
                 <a:ea typeface="JetBrains Mono" pitchFamily="34" charset="-122"/>
                 <a:cs typeface="JetBrains Mono" pitchFamily="34" charset="-120"/>
               </a:rPr>
-              <a:t>CREATE TRIGGER trg_after_update_facture AFTER UPDATE ON facture ...</a:t>
+              <a:t>  SELECT COALESCE(SUM(montant_total), 0) INTO v_ca</a:t>
             </a:r>
             <a:endParaRPr lang="en-US" sz="1000" dirty="0"/>
           </a:p>
@@ -4040,8 +3796,8 @@
         </p:nvSpPr>
         <p:spPr>
           <a:xfrm>
-            <a:off x="457200" y="3657600"/>
-            <a:ext cx="8229600" cy="521208"/>
+            <a:off x="457200" y="3053080"/>
+            <a:ext cx="8229600" cy="409448"/>
           </a:xfrm>
           <a:prstGeom prst="rect">
             <a:avLst/>
@@ -4050,13 +3806,6 @@
             <a:srgbClr val="E3F2FD"/>
           </a:solidFill>
           <a:ln/>
-          <a:effectLst>
-            <a:outerShdw sx="100000" sy="100000" kx="0" ky="0" algn="bl" rotWithShape="0" blurRad="50800" dist="25400" dir="8100000">
-              <a:srgbClr val="000000">
-                <a:alpha val="12000"/>
-              </a:srgbClr>
-            </a:outerShdw>
-          </a:effectLst>
         </p:spPr>
       </p:sp>
       <p:sp>
@@ -4067,8 +3816,8 @@
         </p:nvSpPr>
         <p:spPr>
           <a:xfrm>
-            <a:off x="457200" y="3657600"/>
-            <a:ext cx="45720" cy="521208"/>
+            <a:off x="457200" y="3053080"/>
+            <a:ext cx="45720" cy="409448"/>
           </a:xfrm>
           <a:prstGeom prst="rect">
             <a:avLst/>
@@ -4087,8 +3836,8 @@
         </p:nvSpPr>
         <p:spPr>
           <a:xfrm>
-            <a:off x="685800" y="3657600"/>
-            <a:ext cx="7818120" cy="521208"/>
+            <a:off x="640080" y="3053080"/>
+            <a:ext cx="7863840" cy="409448"/>
           </a:xfrm>
           <a:prstGeom prst="rect">
             <a:avLst/>
@@ -4104,7 +3853,86 @@
               <a:buNone/>
             </a:pPr>
             <a:r>
-              <a:rPr lang="en-US" sz="1200" dirty="0">
+              <a:rPr lang="en-US" sz="1000" dirty="0">
+                <a:solidFill>
+                  <a:srgbClr val="0D47A1"/>
+                </a:solidFill>
+                <a:latin typeface="JetBrains Mono" pitchFamily="34" charset="0"/>
+                <a:ea typeface="JetBrains Mono" pitchFamily="34" charset="-122"/>
+                <a:cs typeface="JetBrains Mono" pitchFamily="34" charset="-120"/>
+              </a:rPr>
+              <a:t>  FROM facture WHERE id_artiste = p_id AND statut_paiement = 'payee';</a:t>
+            </a:r>
+            <a:endParaRPr lang="en-US" sz="1000" dirty="0"/>
+          </a:p>
+        </p:txBody>
+      </p:sp>
+      <p:sp>
+        <p:nvSpPr>
+          <p:cNvPr id="22" name="Shape 20"/>
+          <p:cNvSpPr/>
+          <p:nvPr/>
+        </p:nvSpPr>
+        <p:spPr>
+          <a:xfrm>
+            <a:off x="457200" y="3489960"/>
+            <a:ext cx="8229600" cy="409448"/>
+          </a:xfrm>
+          <a:prstGeom prst="rect">
+            <a:avLst/>
+          </a:prstGeom>
+          <a:solidFill>
+            <a:srgbClr val="FFFFFF"/>
+          </a:solidFill>
+          <a:ln/>
+        </p:spPr>
+      </p:sp>
+      <p:sp>
+        <p:nvSpPr>
+          <p:cNvPr id="23" name="Shape 21"/>
+          <p:cNvSpPr/>
+          <p:nvPr/>
+        </p:nvSpPr>
+        <p:spPr>
+          <a:xfrm>
+            <a:off x="457200" y="3489960"/>
+            <a:ext cx="45720" cy="409448"/>
+          </a:xfrm>
+          <a:prstGeom prst="rect">
+            <a:avLst/>
+          </a:prstGeom>
+          <a:solidFill>
+            <a:srgbClr val="1565C0"/>
+          </a:solidFill>
+          <a:ln/>
+        </p:spPr>
+      </p:sp>
+      <p:sp>
+        <p:nvSpPr>
+          <p:cNvPr id="24" name="Text 22"/>
+          <p:cNvSpPr/>
+          <p:nvPr/>
+        </p:nvSpPr>
+        <p:spPr>
+          <a:xfrm>
+            <a:off x="640080" y="3489960"/>
+            <a:ext cx="7863840" cy="409448"/>
+          </a:xfrm>
+          <a:prstGeom prst="rect">
+            <a:avLst/>
+          </a:prstGeom>
+          <a:noFill/>
+          <a:ln/>
+        </p:spPr>
+        <p:txBody>
+          <a:bodyPr wrap="square" lIns="0" tIns="0" rIns="0" bIns="0" rtlCol="0" anchor="ctr"/>
+          <a:lstStyle/>
+          <a:p>
+            <a:pPr indent="0" marL="0">
+              <a:buNone/>
+            </a:pPr>
+            <a:r>
+              <a:rPr lang="en-US" sz="1100" dirty="0">
                 <a:solidFill>
                   <a:srgbClr val="1A1A2E"/>
                 </a:solidFill>
@@ -4112,49 +3940,42 @@
                 <a:ea typeface="Calibri" pitchFamily="34" charset="-122"/>
                 <a:cs typeface="Calibri" pitchFamily="34" charset="-120"/>
               </a:rPr>
-              <a:t>Pas de CALL : le trigger s'exécute tout seul après INSERT/UPDATE/DELETE</a:t>
-            </a:r>
-            <a:endParaRPr lang="en-US" sz="1200" dirty="0"/>
-          </a:p>
-        </p:txBody>
-      </p:sp>
-      <p:sp>
-        <p:nvSpPr>
-          <p:cNvPr id="22" name="Shape 20"/>
-          <p:cNvSpPr/>
-          <p:nvPr/>
-        </p:nvSpPr>
-        <p:spPr>
-          <a:xfrm>
-            <a:off x="457200" y="4206240"/>
-            <a:ext cx="8229600" cy="521208"/>
-          </a:xfrm>
-          <a:prstGeom prst="rect">
-            <a:avLst/>
-          </a:prstGeom>
-          <a:solidFill>
-            <a:srgbClr val="FFFFFF"/>
-          </a:solidFill>
-          <a:ln/>
-          <a:effectLst>
-            <a:outerShdw sx="100000" sy="100000" kx="0" ky="0" algn="bl" rotWithShape="0" blurRad="50800" dist="25400" dir="8100000">
-              <a:srgbClr val="000000">
-                <a:alpha val="12000"/>
-              </a:srgbClr>
-            </a:outerShdw>
-          </a:effectLst>
-        </p:spPr>
-      </p:sp>
-      <p:sp>
-        <p:nvSpPr>
-          <p:cNvPr id="23" name="Shape 21"/>
-          <p:cNvSpPr/>
-          <p:nvPr/>
-        </p:nvSpPr>
-        <p:spPr>
-          <a:xfrm>
-            <a:off x="457200" y="4206240"/>
-            <a:ext cx="45720" cy="521208"/>
+              <a:t>  RETURN v_ca;</a:t>
+            </a:r>
+            <a:endParaRPr lang="en-US" sz="1100" dirty="0"/>
+          </a:p>
+        </p:txBody>
+      </p:sp>
+      <p:sp>
+        <p:nvSpPr>
+          <p:cNvPr id="25" name="Shape 23"/>
+          <p:cNvSpPr/>
+          <p:nvPr/>
+        </p:nvSpPr>
+        <p:spPr>
+          <a:xfrm>
+            <a:off x="457200" y="3926840"/>
+            <a:ext cx="8229600" cy="409448"/>
+          </a:xfrm>
+          <a:prstGeom prst="rect">
+            <a:avLst/>
+          </a:prstGeom>
+          <a:solidFill>
+            <a:srgbClr val="E3F2FD"/>
+          </a:solidFill>
+          <a:ln/>
+        </p:spPr>
+      </p:sp>
+      <p:sp>
+        <p:nvSpPr>
+          <p:cNvPr id="26" name="Shape 24"/>
+          <p:cNvSpPr/>
+          <p:nvPr/>
+        </p:nvSpPr>
+        <p:spPr>
+          <a:xfrm>
+            <a:off x="457200" y="3926840"/>
+            <a:ext cx="45720" cy="409448"/>
           </a:xfrm>
           <a:prstGeom prst="rect">
             <a:avLst/>
@@ -4167,14 +3988,14 @@
       </p:sp>
       <p:sp>
         <p:nvSpPr>
-          <p:cNvPr id="24" name="Text 22"/>
-          <p:cNvSpPr/>
-          <p:nvPr/>
-        </p:nvSpPr>
-        <p:spPr>
-          <a:xfrm>
-            <a:off x="685800" y="4206240"/>
-            <a:ext cx="7818120" cy="521208"/>
+          <p:cNvPr id="27" name="Text 25"/>
+          <p:cNvSpPr/>
+          <p:nvPr/>
+        </p:nvSpPr>
+        <p:spPr>
+          <a:xfrm>
+            <a:off x="640080" y="3926840"/>
+            <a:ext cx="7863840" cy="409448"/>
           </a:xfrm>
           <a:prstGeom prst="rect">
             <a:avLst/>
@@ -4190,7 +4011,7 @@
               <a:buNone/>
             </a:pPr>
             <a:r>
-              <a:rPr lang="en-US" sz="1200" dirty="0">
+              <a:rPr lang="en-US" sz="1100" dirty="0">
                 <a:solidFill>
                   <a:srgbClr val="1A1A2E"/>
                 </a:solidFill>
@@ -4198,9 +4019,88 @@
                 <a:ea typeface="Calibri" pitchFamily="34" charset="-122"/>
                 <a:cs typeface="Calibri" pitchFamily="34" charset="-120"/>
               </a:rPr>
-              <a:t>Voir sql/03_views_procedures_security.sql pour les exemples complets</a:t>
-            </a:r>
-            <a:endParaRPr lang="en-US" sz="1200" dirty="0"/>
+              <a:t>END</a:t>
+            </a:r>
+            <a:endParaRPr lang="en-US" sz="1100" dirty="0"/>
+          </a:p>
+        </p:txBody>
+      </p:sp>
+      <p:sp>
+        <p:nvSpPr>
+          <p:cNvPr id="28" name="Shape 26"/>
+          <p:cNvSpPr/>
+          <p:nvPr/>
+        </p:nvSpPr>
+        <p:spPr>
+          <a:xfrm>
+            <a:off x="457200" y="4363720"/>
+            <a:ext cx="8229600" cy="409448"/>
+          </a:xfrm>
+          <a:prstGeom prst="rect">
+            <a:avLst/>
+          </a:prstGeom>
+          <a:solidFill>
+            <a:srgbClr val="FFFFFF"/>
+          </a:solidFill>
+          <a:ln/>
+        </p:spPr>
+      </p:sp>
+      <p:sp>
+        <p:nvSpPr>
+          <p:cNvPr id="29" name="Shape 27"/>
+          <p:cNvSpPr/>
+          <p:nvPr/>
+        </p:nvSpPr>
+        <p:spPr>
+          <a:xfrm>
+            <a:off x="457200" y="4363720"/>
+            <a:ext cx="45720" cy="409448"/>
+          </a:xfrm>
+          <a:prstGeom prst="rect">
+            <a:avLst/>
+          </a:prstGeom>
+          <a:solidFill>
+            <a:srgbClr val="1565C0"/>
+          </a:solidFill>
+          <a:ln/>
+        </p:spPr>
+      </p:sp>
+      <p:sp>
+        <p:nvSpPr>
+          <p:cNvPr id="30" name="Text 28"/>
+          <p:cNvSpPr/>
+          <p:nvPr/>
+        </p:nvSpPr>
+        <p:spPr>
+          <a:xfrm>
+            <a:off x="640080" y="4363720"/>
+            <a:ext cx="7863840" cy="409448"/>
+          </a:xfrm>
+          <a:prstGeom prst="rect">
+            <a:avLst/>
+          </a:prstGeom>
+          <a:noFill/>
+          <a:ln/>
+        </p:spPr>
+        <p:txBody>
+          <a:bodyPr wrap="square" lIns="0" tIns="0" rIns="0" bIns="0" rtlCol="0" anchor="ctr"/>
+          <a:lstStyle/>
+          <a:p>
+            <a:pPr indent="0" marL="0">
+              <a:buNone/>
+            </a:pPr>
+            <a:r>
+              <a:rPr lang="en-US" sz="1100" dirty="0">
+                <a:solidFill>
+                  <a:srgbClr val="1A1A2E"/>
+                </a:solidFill>
+                <a:latin typeface="Calibri" pitchFamily="34" charset="0"/>
+                <a:ea typeface="Calibri" pitchFamily="34" charset="-122"/>
+                <a:cs typeface="Calibri" pitchFamily="34" charset="-120"/>
+              </a:rPr>
+              <a:t>Utilisation dans SELECT : SELECT nom, fn_ca_artiste(id_artiste) AS ca FROM artiste;</a:t>
+            </a:r>
+            <a:endParaRPr lang="en-US" sz="1100" dirty="0"/>
           </a:p>
         </p:txBody>
       </p:sp>
@@ -4265,7 +4165,7 @@
         <p:spPr>
           <a:xfrm>
             <a:off x="457200" y="182880"/>
-            <a:ext cx="8229600" cy="594360"/>
+            <a:ext cx="8229600" cy="548640"/>
           </a:xfrm>
           <a:prstGeom prst="rect">
             <a:avLst/>
@@ -4281,7 +4181,7 @@
               <a:buNone/>
             </a:pPr>
             <a:r>
-              <a:rPr lang="en-US" sz="2400" b="1" dirty="0">
+              <a:rPr lang="en-US" sz="2200" b="1" dirty="0">
                 <a:solidFill>
                   <a:srgbClr val="0D47A1"/>
                 </a:solidFill>
@@ -4289,9 +4189,9 @@
                 <a:ea typeface="Trebuchet MS" pitchFamily="34" charset="-122"/>
                 <a:cs typeface="Trebuchet MS" pitchFamily="34" charset="-120"/>
               </a:rPr>
-              <a:t>Exercice Module 15</a:t>
-            </a:r>
-            <a:endParaRPr lang="en-US" sz="2400" dirty="0"/>
+              <a:t>Triggers — automatisation</a:t>
+            </a:r>
+            <a:endParaRPr lang="en-US" sz="2200" dirty="0"/>
           </a:p>
         </p:txBody>
       </p:sp>
@@ -4303,8 +4203,8 @@
         </p:nvSpPr>
         <p:spPr>
           <a:xfrm>
-            <a:off x="457200" y="914400"/>
-            <a:ext cx="8229600" cy="521208"/>
+            <a:off x="457200" y="868680"/>
+            <a:ext cx="8229600" cy="409448"/>
           </a:xfrm>
           <a:prstGeom prst="rect">
             <a:avLst/>
@@ -4313,13 +4213,6 @@
             <a:srgbClr val="FFFFFF"/>
           </a:solidFill>
           <a:ln/>
-          <a:effectLst>
-            <a:outerShdw sx="100000" sy="100000" kx="0" ky="0" algn="bl" rotWithShape="0" blurRad="50800" dist="25400" dir="8100000">
-              <a:srgbClr val="000000">
-                <a:alpha val="12000"/>
-              </a:srgbClr>
-            </a:outerShdw>
-          </a:effectLst>
         </p:spPr>
       </p:sp>
       <p:sp>
@@ -4330,8 +4223,8 @@
         </p:nvSpPr>
         <p:spPr>
           <a:xfrm>
-            <a:off x="457200" y="914400"/>
-            <a:ext cx="45720" cy="521208"/>
+            <a:off x="457200" y="868680"/>
+            <a:ext cx="45720" cy="409448"/>
           </a:xfrm>
           <a:prstGeom prst="rect">
             <a:avLst/>
@@ -4350,8 +4243,8 @@
         </p:nvSpPr>
         <p:spPr>
           <a:xfrm>
-            <a:off x="685800" y="914400"/>
-            <a:ext cx="7818120" cy="521208"/>
+            <a:off x="640080" y="868680"/>
+            <a:ext cx="7863840" cy="409448"/>
           </a:xfrm>
           <a:prstGeom prst="rect">
             <a:avLst/>
@@ -4367,7 +4260,244 @@
               <a:buNone/>
             </a:pPr>
             <a:r>
-              <a:rPr lang="en-US" sz="1200" dirty="0">
+              <a:rPr lang="en-US" sz="1000" dirty="0">
+                <a:solidFill>
+                  <a:srgbClr val="0D47A1"/>
+                </a:solidFill>
+                <a:latin typeface="JetBrains Mono" pitchFamily="34" charset="0"/>
+                <a:ea typeface="JetBrains Mono" pitchFamily="34" charset="-122"/>
+                <a:cs typeface="JetBrains Mono" pitchFamily="34" charset="-120"/>
+              </a:rPr>
+              <a:t>CREATE TRIGGER trg_after_update_facture</a:t>
+            </a:r>
+            <a:endParaRPr lang="en-US" sz="1000" dirty="0"/>
+          </a:p>
+        </p:txBody>
+      </p:sp>
+      <p:sp>
+        <p:nvSpPr>
+          <p:cNvPr id="7" name="Shape 5"/>
+          <p:cNvSpPr/>
+          <p:nvPr/>
+        </p:nvSpPr>
+        <p:spPr>
+          <a:xfrm>
+            <a:off x="457200" y="1305560"/>
+            <a:ext cx="8229600" cy="409448"/>
+          </a:xfrm>
+          <a:prstGeom prst="rect">
+            <a:avLst/>
+          </a:prstGeom>
+          <a:solidFill>
+            <a:srgbClr val="E3F2FD"/>
+          </a:solidFill>
+          <a:ln/>
+        </p:spPr>
+      </p:sp>
+      <p:sp>
+        <p:nvSpPr>
+          <p:cNvPr id="8" name="Shape 6"/>
+          <p:cNvSpPr/>
+          <p:nvPr/>
+        </p:nvSpPr>
+        <p:spPr>
+          <a:xfrm>
+            <a:off x="457200" y="1305560"/>
+            <a:ext cx="45720" cy="409448"/>
+          </a:xfrm>
+          <a:prstGeom prst="rect">
+            <a:avLst/>
+          </a:prstGeom>
+          <a:solidFill>
+            <a:srgbClr val="1565C0"/>
+          </a:solidFill>
+          <a:ln/>
+        </p:spPr>
+      </p:sp>
+      <p:sp>
+        <p:nvSpPr>
+          <p:cNvPr id="9" name="Text 7"/>
+          <p:cNvSpPr/>
+          <p:nvPr/>
+        </p:nvSpPr>
+        <p:spPr>
+          <a:xfrm>
+            <a:off x="640080" y="1305560"/>
+            <a:ext cx="7863840" cy="409448"/>
+          </a:xfrm>
+          <a:prstGeom prst="rect">
+            <a:avLst/>
+          </a:prstGeom>
+          <a:noFill/>
+          <a:ln/>
+        </p:spPr>
+        <p:txBody>
+          <a:bodyPr wrap="square" lIns="0" tIns="0" rIns="0" bIns="0" rtlCol="0" anchor="ctr"/>
+          <a:lstStyle/>
+          <a:p>
+            <a:pPr indent="0" marL="0">
+              <a:buNone/>
+            </a:pPr>
+            <a:r>
+              <a:rPr lang="en-US" sz="1000" dirty="0">
+                <a:solidFill>
+                  <a:srgbClr val="0D47A1"/>
+                </a:solidFill>
+                <a:latin typeface="JetBrains Mono" pitchFamily="34" charset="0"/>
+                <a:ea typeface="JetBrains Mono" pitchFamily="34" charset="-122"/>
+                <a:cs typeface="JetBrains Mono" pitchFamily="34" charset="-120"/>
+              </a:rPr>
+              <a:t>AFTER UPDATE ON facture FOR EACH ROW</a:t>
+            </a:r>
+            <a:endParaRPr lang="en-US" sz="1000" dirty="0"/>
+          </a:p>
+        </p:txBody>
+      </p:sp>
+      <p:sp>
+        <p:nvSpPr>
+          <p:cNvPr id="10" name="Shape 8"/>
+          <p:cNvSpPr/>
+          <p:nvPr/>
+        </p:nvSpPr>
+        <p:spPr>
+          <a:xfrm>
+            <a:off x="457200" y="1742440"/>
+            <a:ext cx="8229600" cy="409448"/>
+          </a:xfrm>
+          <a:prstGeom prst="rect">
+            <a:avLst/>
+          </a:prstGeom>
+          <a:solidFill>
+            <a:srgbClr val="FFFFFF"/>
+          </a:solidFill>
+          <a:ln/>
+        </p:spPr>
+      </p:sp>
+      <p:sp>
+        <p:nvSpPr>
+          <p:cNvPr id="11" name="Shape 9"/>
+          <p:cNvSpPr/>
+          <p:nvPr/>
+        </p:nvSpPr>
+        <p:spPr>
+          <a:xfrm>
+            <a:off x="457200" y="1742440"/>
+            <a:ext cx="45720" cy="409448"/>
+          </a:xfrm>
+          <a:prstGeom prst="rect">
+            <a:avLst/>
+          </a:prstGeom>
+          <a:solidFill>
+            <a:srgbClr val="1565C0"/>
+          </a:solidFill>
+          <a:ln/>
+        </p:spPr>
+      </p:sp>
+      <p:sp>
+        <p:nvSpPr>
+          <p:cNvPr id="12" name="Text 10"/>
+          <p:cNvSpPr/>
+          <p:nvPr/>
+        </p:nvSpPr>
+        <p:spPr>
+          <a:xfrm>
+            <a:off x="640080" y="1742440"/>
+            <a:ext cx="7863840" cy="409448"/>
+          </a:xfrm>
+          <a:prstGeom prst="rect">
+            <a:avLst/>
+          </a:prstGeom>
+          <a:noFill/>
+          <a:ln/>
+        </p:spPr>
+        <p:txBody>
+          <a:bodyPr wrap="square" lIns="0" tIns="0" rIns="0" bIns="0" rtlCol="0" anchor="ctr"/>
+          <a:lstStyle/>
+          <a:p>
+            <a:pPr indent="0" marL="0">
+              <a:buNone/>
+            </a:pPr>
+            <a:r>
+              <a:rPr lang="en-US" sz="1000" dirty="0">
+                <a:solidFill>
+                  <a:srgbClr val="0D47A1"/>
+                </a:solidFill>
+                <a:latin typeface="JetBrains Mono" pitchFamily="34" charset="0"/>
+                <a:ea typeface="JetBrains Mono" pitchFamily="34" charset="-122"/>
+                <a:cs typeface="JetBrains Mono" pitchFamily="34" charset="-120"/>
+              </a:rPr>
+              <a:t>BEGIN</a:t>
+            </a:r>
+            <a:endParaRPr lang="en-US" sz="1000" dirty="0"/>
+          </a:p>
+        </p:txBody>
+      </p:sp>
+      <p:sp>
+        <p:nvSpPr>
+          <p:cNvPr id="13" name="Shape 11"/>
+          <p:cNvSpPr/>
+          <p:nvPr/>
+        </p:nvSpPr>
+        <p:spPr>
+          <a:xfrm>
+            <a:off x="457200" y="2179320"/>
+            <a:ext cx="8229600" cy="409448"/>
+          </a:xfrm>
+          <a:prstGeom prst="rect">
+            <a:avLst/>
+          </a:prstGeom>
+          <a:solidFill>
+            <a:srgbClr val="E3F2FD"/>
+          </a:solidFill>
+          <a:ln/>
+        </p:spPr>
+      </p:sp>
+      <p:sp>
+        <p:nvSpPr>
+          <p:cNvPr id="14" name="Shape 12"/>
+          <p:cNvSpPr/>
+          <p:nvPr/>
+        </p:nvSpPr>
+        <p:spPr>
+          <a:xfrm>
+            <a:off x="457200" y="2179320"/>
+            <a:ext cx="45720" cy="409448"/>
+          </a:xfrm>
+          <a:prstGeom prst="rect">
+            <a:avLst/>
+          </a:prstGeom>
+          <a:solidFill>
+            <a:srgbClr val="1565C0"/>
+          </a:solidFill>
+          <a:ln/>
+        </p:spPr>
+      </p:sp>
+      <p:sp>
+        <p:nvSpPr>
+          <p:cNvPr id="15" name="Text 13"/>
+          <p:cNvSpPr/>
+          <p:nvPr/>
+        </p:nvSpPr>
+        <p:spPr>
+          <a:xfrm>
+            <a:off x="640080" y="2179320"/>
+            <a:ext cx="7863840" cy="409448"/>
+          </a:xfrm>
+          <a:prstGeom prst="rect">
+            <a:avLst/>
+          </a:prstGeom>
+          <a:noFill/>
+          <a:ln/>
+        </p:spPr>
+        <p:txBody>
+          <a:bodyPr wrap="square" lIns="0" tIns="0" rIns="0" bIns="0" rtlCol="0" anchor="ctr"/>
+          <a:lstStyle/>
+          <a:p>
+            <a:pPr indent="0" marL="0">
+              <a:buNone/>
+            </a:pPr>
+            <a:r>
+              <a:rPr lang="en-US" sz="1100" dirty="0">
                 <a:solidFill>
                   <a:srgbClr val="1A1A2E"/>
                 </a:solidFill>
@@ -4375,49 +4505,42 @@
                 <a:ea typeface="Calibri" pitchFamily="34" charset="-122"/>
                 <a:cs typeface="Calibri" pitchFamily="34" charset="-120"/>
               </a:rPr>
-              <a:t>Créer 3 vues : v_artistes_actifs, v_sessions_mois, v_dashboard_ca</a:t>
-            </a:r>
-            <a:endParaRPr lang="en-US" sz="1200" dirty="0"/>
-          </a:p>
-        </p:txBody>
-      </p:sp>
-      <p:sp>
-        <p:nvSpPr>
-          <p:cNvPr id="7" name="Shape 5"/>
-          <p:cNvSpPr/>
-          <p:nvPr/>
-        </p:nvSpPr>
-        <p:spPr>
-          <a:xfrm>
-            <a:off x="457200" y="1463040"/>
-            <a:ext cx="8229600" cy="521208"/>
-          </a:xfrm>
-          <a:prstGeom prst="rect">
-            <a:avLst/>
-          </a:prstGeom>
-          <a:solidFill>
-            <a:srgbClr val="E3F2FD"/>
-          </a:solidFill>
-          <a:ln/>
-          <a:effectLst>
-            <a:outerShdw sx="100000" sy="100000" kx="0" ky="0" algn="bl" rotWithShape="0" blurRad="50800" dist="25400" dir="8100000">
-              <a:srgbClr val="000000">
-                <a:alpha val="12000"/>
-              </a:srgbClr>
-            </a:outerShdw>
-          </a:effectLst>
-        </p:spPr>
-      </p:sp>
-      <p:sp>
-        <p:nvSpPr>
-          <p:cNvPr id="8" name="Shape 6"/>
-          <p:cNvSpPr/>
-          <p:nvPr/>
-        </p:nvSpPr>
-        <p:spPr>
-          <a:xfrm>
-            <a:off x="457200" y="1463040"/>
-            <a:ext cx="45720" cy="521208"/>
+              <a:t>  IF NEW.statut_paiement = 'payee' AND OLD.statut_paiement &lt;&gt; 'payee' THEN</a:t>
+            </a:r>
+            <a:endParaRPr lang="en-US" sz="1100" dirty="0"/>
+          </a:p>
+        </p:txBody>
+      </p:sp>
+      <p:sp>
+        <p:nvSpPr>
+          <p:cNvPr id="16" name="Shape 14"/>
+          <p:cNvSpPr/>
+          <p:nvPr/>
+        </p:nvSpPr>
+        <p:spPr>
+          <a:xfrm>
+            <a:off x="457200" y="2616200"/>
+            <a:ext cx="8229600" cy="409448"/>
+          </a:xfrm>
+          <a:prstGeom prst="rect">
+            <a:avLst/>
+          </a:prstGeom>
+          <a:solidFill>
+            <a:srgbClr val="FFFFFF"/>
+          </a:solidFill>
+          <a:ln/>
+        </p:spPr>
+      </p:sp>
+      <p:sp>
+        <p:nvSpPr>
+          <p:cNvPr id="17" name="Shape 15"/>
+          <p:cNvSpPr/>
+          <p:nvPr/>
+        </p:nvSpPr>
+        <p:spPr>
+          <a:xfrm>
+            <a:off x="457200" y="2616200"/>
+            <a:ext cx="45720" cy="409448"/>
           </a:xfrm>
           <a:prstGeom prst="rect">
             <a:avLst/>
@@ -4430,14 +4553,14 @@
       </p:sp>
       <p:sp>
         <p:nvSpPr>
-          <p:cNvPr id="9" name="Text 7"/>
-          <p:cNvSpPr/>
-          <p:nvPr/>
-        </p:nvSpPr>
-        <p:spPr>
-          <a:xfrm>
-            <a:off x="685800" y="1463040"/>
-            <a:ext cx="7818120" cy="521208"/>
+          <p:cNvPr id="18" name="Text 16"/>
+          <p:cNvSpPr/>
+          <p:nvPr/>
+        </p:nvSpPr>
+        <p:spPr>
+          <a:xfrm>
+            <a:off x="640080" y="2616200"/>
+            <a:ext cx="7863840" cy="409448"/>
           </a:xfrm>
           <a:prstGeom prst="rect">
             <a:avLst/>
@@ -4453,7 +4576,7 @@
               <a:buNone/>
             </a:pPr>
             <a:r>
-              <a:rPr lang="en-US" sz="1200" dirty="0">
+              <a:rPr lang="en-US" sz="1100" dirty="0">
                 <a:solidFill>
                   <a:srgbClr val="1A1A2E"/>
                 </a:solidFill>
@@ -4461,49 +4584,42 @@
                 <a:ea typeface="Calibri" pitchFamily="34" charset="-122"/>
                 <a:cs typeface="Calibri" pitchFamily="34" charset="-120"/>
               </a:rPr>
-              <a:t>Créer la procédure sp_ajouter_session avec vérification de disponibilité</a:t>
-            </a:r>
-            <a:endParaRPr lang="en-US" sz="1200" dirty="0"/>
-          </a:p>
-        </p:txBody>
-      </p:sp>
-      <p:sp>
-        <p:nvSpPr>
-          <p:cNvPr id="10" name="Shape 8"/>
-          <p:cNvSpPr/>
-          <p:nvPr/>
-        </p:nvSpPr>
-        <p:spPr>
-          <a:xfrm>
-            <a:off x="457200" y="2011680"/>
-            <a:ext cx="8229600" cy="521208"/>
-          </a:xfrm>
-          <a:prstGeom prst="rect">
-            <a:avLst/>
-          </a:prstGeom>
-          <a:solidFill>
-            <a:srgbClr val="FFFFFF"/>
-          </a:solidFill>
-          <a:ln/>
-          <a:effectLst>
-            <a:outerShdw sx="100000" sy="100000" kx="0" ky="0" algn="bl" rotWithShape="0" blurRad="50800" dist="25400" dir="8100000">
-              <a:srgbClr val="000000">
-                <a:alpha val="12000"/>
-              </a:srgbClr>
-            </a:outerShdw>
-          </a:effectLst>
-        </p:spPr>
-      </p:sp>
-      <p:sp>
-        <p:nvSpPr>
-          <p:cNvPr id="11" name="Shape 9"/>
-          <p:cNvSpPr/>
-          <p:nvPr/>
-        </p:nvSpPr>
-        <p:spPr>
-          <a:xfrm>
-            <a:off x="457200" y="2011680"/>
-            <a:ext cx="45720" cy="521208"/>
+              <a:t>    UPDATE session SET statut = 'facturee' WHERE id_session = NEW.id_session;</a:t>
+            </a:r>
+            <a:endParaRPr lang="en-US" sz="1100" dirty="0"/>
+          </a:p>
+        </p:txBody>
+      </p:sp>
+      <p:sp>
+        <p:nvSpPr>
+          <p:cNvPr id="19" name="Shape 17"/>
+          <p:cNvSpPr/>
+          <p:nvPr/>
+        </p:nvSpPr>
+        <p:spPr>
+          <a:xfrm>
+            <a:off x="457200" y="3053080"/>
+            <a:ext cx="8229600" cy="409448"/>
+          </a:xfrm>
+          <a:prstGeom prst="rect">
+            <a:avLst/>
+          </a:prstGeom>
+          <a:solidFill>
+            <a:srgbClr val="E3F2FD"/>
+          </a:solidFill>
+          <a:ln/>
+        </p:spPr>
+      </p:sp>
+      <p:sp>
+        <p:nvSpPr>
+          <p:cNvPr id="20" name="Shape 18"/>
+          <p:cNvSpPr/>
+          <p:nvPr/>
+        </p:nvSpPr>
+        <p:spPr>
+          <a:xfrm>
+            <a:off x="457200" y="3053080"/>
+            <a:ext cx="45720" cy="409448"/>
           </a:xfrm>
           <a:prstGeom prst="rect">
             <a:avLst/>
@@ -4516,14 +4632,14 @@
       </p:sp>
       <p:sp>
         <p:nvSpPr>
-          <p:cNvPr id="12" name="Text 10"/>
-          <p:cNvSpPr/>
-          <p:nvPr/>
-        </p:nvSpPr>
-        <p:spPr>
-          <a:xfrm>
-            <a:off x="685800" y="2011680"/>
-            <a:ext cx="7818120" cy="521208"/>
+          <p:cNvPr id="21" name="Text 19"/>
+          <p:cNvSpPr/>
+          <p:nvPr/>
+        </p:nvSpPr>
+        <p:spPr>
+          <a:xfrm>
+            <a:off x="640080" y="3053080"/>
+            <a:ext cx="7863840" cy="409448"/>
           </a:xfrm>
           <a:prstGeom prst="rect">
             <a:avLst/>
@@ -4539,7 +4655,7 @@
               <a:buNone/>
             </a:pPr>
             <a:r>
-              <a:rPr lang="en-US" sz="1200" dirty="0">
+              <a:rPr lang="en-US" sz="1100" dirty="0">
                 <a:solidFill>
                   <a:srgbClr val="1A1A2E"/>
                 </a:solidFill>
@@ -4547,49 +4663,42 @@
                 <a:ea typeface="Calibri" pitchFamily="34" charset="-122"/>
                 <a:cs typeface="Calibri" pitchFamily="34" charset="-120"/>
               </a:rPr>
-              <a:t>Créer la fonction fn_ca_artiste(id) qui retourne le CA payé</a:t>
-            </a:r>
-            <a:endParaRPr lang="en-US" sz="1200" dirty="0"/>
-          </a:p>
-        </p:txBody>
-      </p:sp>
-      <p:sp>
-        <p:nvSpPr>
-          <p:cNvPr id="13" name="Shape 11"/>
-          <p:cNvSpPr/>
-          <p:nvPr/>
-        </p:nvSpPr>
-        <p:spPr>
-          <a:xfrm>
-            <a:off x="457200" y="2560320"/>
-            <a:ext cx="8229600" cy="521208"/>
-          </a:xfrm>
-          <a:prstGeom prst="rect">
-            <a:avLst/>
-          </a:prstGeom>
-          <a:solidFill>
-            <a:srgbClr val="E3F2FD"/>
-          </a:solidFill>
-          <a:ln/>
-          <a:effectLst>
-            <a:outerShdw sx="100000" sy="100000" kx="0" ky="0" algn="bl" rotWithShape="0" blurRad="50800" dist="25400" dir="8100000">
-              <a:srgbClr val="000000">
-                <a:alpha val="12000"/>
-              </a:srgbClr>
-            </a:outerShdw>
-          </a:effectLst>
-        </p:spPr>
-      </p:sp>
-      <p:sp>
-        <p:nvSpPr>
-          <p:cNvPr id="14" name="Shape 12"/>
-          <p:cNvSpPr/>
-          <p:nvPr/>
-        </p:nvSpPr>
-        <p:spPr>
-          <a:xfrm>
-            <a:off x="457200" y="2560320"/>
-            <a:ext cx="45720" cy="521208"/>
+              <a:t>  END IF;</a:t>
+            </a:r>
+            <a:endParaRPr lang="en-US" sz="1100" dirty="0"/>
+          </a:p>
+        </p:txBody>
+      </p:sp>
+      <p:sp>
+        <p:nvSpPr>
+          <p:cNvPr id="22" name="Shape 20"/>
+          <p:cNvSpPr/>
+          <p:nvPr/>
+        </p:nvSpPr>
+        <p:spPr>
+          <a:xfrm>
+            <a:off x="457200" y="3489960"/>
+            <a:ext cx="8229600" cy="409448"/>
+          </a:xfrm>
+          <a:prstGeom prst="rect">
+            <a:avLst/>
+          </a:prstGeom>
+          <a:solidFill>
+            <a:srgbClr val="FFFFFF"/>
+          </a:solidFill>
+          <a:ln/>
+        </p:spPr>
+      </p:sp>
+      <p:sp>
+        <p:nvSpPr>
+          <p:cNvPr id="23" name="Shape 21"/>
+          <p:cNvSpPr/>
+          <p:nvPr/>
+        </p:nvSpPr>
+        <p:spPr>
+          <a:xfrm>
+            <a:off x="457200" y="3489960"/>
+            <a:ext cx="45720" cy="409448"/>
           </a:xfrm>
           <a:prstGeom prst="rect">
             <a:avLst/>
@@ -4602,14 +4711,14 @@
       </p:sp>
       <p:sp>
         <p:nvSpPr>
-          <p:cNvPr id="15" name="Text 13"/>
-          <p:cNvSpPr/>
-          <p:nvPr/>
-        </p:nvSpPr>
-        <p:spPr>
-          <a:xfrm>
-            <a:off x="685800" y="2560320"/>
-            <a:ext cx="7818120" cy="521208"/>
+          <p:cNvPr id="24" name="Text 22"/>
+          <p:cNvSpPr/>
+          <p:nvPr/>
+        </p:nvSpPr>
+        <p:spPr>
+          <a:xfrm>
+            <a:off x="640080" y="3489960"/>
+            <a:ext cx="7863840" cy="409448"/>
           </a:xfrm>
           <a:prstGeom prst="rect">
             <a:avLst/>
@@ -4625,7 +4734,7 @@
               <a:buNone/>
             </a:pPr>
             <a:r>
-              <a:rPr lang="en-US" sz="1200" dirty="0">
+              <a:rPr lang="en-US" sz="1100" dirty="0">
                 <a:solidFill>
                   <a:srgbClr val="1A1A2E"/>
                 </a:solidFill>
@@ -4633,49 +4742,42 @@
                 <a:ea typeface="Calibri" pitchFamily="34" charset="-122"/>
                 <a:cs typeface="Calibri" pitchFamily="34" charset="-120"/>
               </a:rPr>
-              <a:t>Créer un trigger qui met à jour le statut session quand facture payée</a:t>
-            </a:r>
-            <a:endParaRPr lang="en-US" sz="1200" dirty="0"/>
-          </a:p>
-        </p:txBody>
-      </p:sp>
-      <p:sp>
-        <p:nvSpPr>
-          <p:cNvPr id="16" name="Shape 14"/>
-          <p:cNvSpPr/>
-          <p:nvPr/>
-        </p:nvSpPr>
-        <p:spPr>
-          <a:xfrm>
-            <a:off x="457200" y="3108960"/>
-            <a:ext cx="8229600" cy="521208"/>
-          </a:xfrm>
-          <a:prstGeom prst="rect">
-            <a:avLst/>
-          </a:prstGeom>
-          <a:solidFill>
-            <a:srgbClr val="FFFFFF"/>
-          </a:solidFill>
-          <a:ln/>
-          <a:effectLst>
-            <a:outerShdw sx="100000" sy="100000" kx="0" ky="0" algn="bl" rotWithShape="0" blurRad="50800" dist="25400" dir="8100000">
-              <a:srgbClr val="000000">
-                <a:alpha val="12000"/>
-              </a:srgbClr>
-            </a:outerShdw>
-          </a:effectLst>
-        </p:spPr>
-      </p:sp>
-      <p:sp>
-        <p:nvSpPr>
-          <p:cNvPr id="17" name="Shape 15"/>
-          <p:cNvSpPr/>
-          <p:nvPr/>
-        </p:nvSpPr>
-        <p:spPr>
-          <a:xfrm>
-            <a:off x="457200" y="3108960"/>
-            <a:ext cx="45720" cy="521208"/>
+              <a:t>END</a:t>
+            </a:r>
+            <a:endParaRPr lang="en-US" sz="1100" dirty="0"/>
+          </a:p>
+        </p:txBody>
+      </p:sp>
+      <p:sp>
+        <p:nvSpPr>
+          <p:cNvPr id="25" name="Shape 23"/>
+          <p:cNvSpPr/>
+          <p:nvPr/>
+        </p:nvSpPr>
+        <p:spPr>
+          <a:xfrm>
+            <a:off x="457200" y="3926840"/>
+            <a:ext cx="8229600" cy="409448"/>
+          </a:xfrm>
+          <a:prstGeom prst="rect">
+            <a:avLst/>
+          </a:prstGeom>
+          <a:solidFill>
+            <a:srgbClr val="E3F2FD"/>
+          </a:solidFill>
+          <a:ln/>
+        </p:spPr>
+      </p:sp>
+      <p:sp>
+        <p:nvSpPr>
+          <p:cNvPr id="26" name="Shape 24"/>
+          <p:cNvSpPr/>
+          <p:nvPr/>
+        </p:nvSpPr>
+        <p:spPr>
+          <a:xfrm>
+            <a:off x="457200" y="3926840"/>
+            <a:ext cx="45720" cy="409448"/>
           </a:xfrm>
           <a:prstGeom prst="rect">
             <a:avLst/>
@@ -4688,14 +4790,14 @@
       </p:sp>
       <p:sp>
         <p:nvSpPr>
-          <p:cNvPr id="18" name="Text 16"/>
-          <p:cNvSpPr/>
-          <p:nvPr/>
-        </p:nvSpPr>
-        <p:spPr>
-          <a:xfrm>
-            <a:off x="685800" y="3108960"/>
-            <a:ext cx="7818120" cy="521208"/>
+          <p:cNvPr id="27" name="Text 25"/>
+          <p:cNvSpPr/>
+          <p:nvPr/>
+        </p:nvSpPr>
+        <p:spPr>
+          <a:xfrm>
+            <a:off x="640080" y="3926840"/>
+            <a:ext cx="7863840" cy="409448"/>
           </a:xfrm>
           <a:prstGeom prst="rect">
             <a:avLst/>
@@ -4711,7 +4813,7 @@
               <a:buNone/>
             </a:pPr>
             <a:r>
-              <a:rPr lang="en-US" sz="1200" dirty="0">
+              <a:rPr lang="en-US" sz="1100" dirty="0">
                 <a:solidFill>
                   <a:srgbClr val="1A1A2E"/>
                 </a:solidFill>
@@ -4719,49 +4821,42 @@
                 <a:ea typeface="Calibri" pitchFamily="34" charset="-122"/>
                 <a:cs typeface="Calibri" pitchFamily="34" charset="-120"/>
               </a:rPr>
-              <a:t>Tester chaque vue avec SELECT, chaque procédure avec CALL</a:t>
-            </a:r>
-            <a:endParaRPr lang="en-US" sz="1200" dirty="0"/>
-          </a:p>
-        </p:txBody>
-      </p:sp>
-      <p:sp>
-        <p:nvSpPr>
-          <p:cNvPr id="19" name="Shape 17"/>
-          <p:cNvSpPr/>
-          <p:nvPr/>
-        </p:nvSpPr>
-        <p:spPr>
-          <a:xfrm>
-            <a:off x="457200" y="3657600"/>
-            <a:ext cx="8229600" cy="521208"/>
-          </a:xfrm>
-          <a:prstGeom prst="rect">
-            <a:avLst/>
-          </a:prstGeom>
-          <a:solidFill>
-            <a:srgbClr val="E3F2FD"/>
-          </a:solidFill>
-          <a:ln/>
-          <a:effectLst>
-            <a:outerShdw sx="100000" sy="100000" kx="0" ky="0" algn="bl" rotWithShape="0" blurRad="50800" dist="25400" dir="8100000">
-              <a:srgbClr val="000000">
-                <a:alpha val="12000"/>
-              </a:srgbClr>
-            </a:outerShdw>
-          </a:effectLst>
-        </p:spPr>
-      </p:sp>
-      <p:sp>
-        <p:nvSpPr>
-          <p:cNvPr id="20" name="Shape 18"/>
-          <p:cNvSpPr/>
-          <p:nvPr/>
-        </p:nvSpPr>
-        <p:spPr>
-          <a:xfrm>
-            <a:off x="457200" y="3657600"/>
-            <a:ext cx="45720" cy="521208"/>
+              <a:t>Pas de CALL : le trigger s'execute AUTOMATIQUEMENT</a:t>
+            </a:r>
+            <a:endParaRPr lang="en-US" sz="1100" dirty="0"/>
+          </a:p>
+        </p:txBody>
+      </p:sp>
+      <p:sp>
+        <p:nvSpPr>
+          <p:cNvPr id="28" name="Shape 26"/>
+          <p:cNvSpPr/>
+          <p:nvPr/>
+        </p:nvSpPr>
+        <p:spPr>
+          <a:xfrm>
+            <a:off x="457200" y="4363720"/>
+            <a:ext cx="8229600" cy="409448"/>
+          </a:xfrm>
+          <a:prstGeom prst="rect">
+            <a:avLst/>
+          </a:prstGeom>
+          <a:solidFill>
+            <a:srgbClr val="FFFFFF"/>
+          </a:solidFill>
+          <a:ln/>
+        </p:spPr>
+      </p:sp>
+      <p:sp>
+        <p:nvSpPr>
+          <p:cNvPr id="29" name="Shape 27"/>
+          <p:cNvSpPr/>
+          <p:nvPr/>
+        </p:nvSpPr>
+        <p:spPr>
+          <a:xfrm>
+            <a:off x="457200" y="4363720"/>
+            <a:ext cx="45720" cy="409448"/>
           </a:xfrm>
           <a:prstGeom prst="rect">
             <a:avLst/>
@@ -4774,14 +4869,14 @@
       </p:sp>
       <p:sp>
         <p:nvSpPr>
-          <p:cNvPr id="21" name="Text 19"/>
-          <p:cNvSpPr/>
-          <p:nvPr/>
-        </p:nvSpPr>
-        <p:spPr>
-          <a:xfrm>
-            <a:off x="685800" y="3657600"/>
-            <a:ext cx="7818120" cy="521208"/>
+          <p:cNvPr id="30" name="Text 28"/>
+          <p:cNvSpPr/>
+          <p:nvPr/>
+        </p:nvSpPr>
+        <p:spPr>
+          <a:xfrm>
+            <a:off x="640080" y="4363720"/>
+            <a:ext cx="7863840" cy="409448"/>
           </a:xfrm>
           <a:prstGeom prst="rect">
             <a:avLst/>
@@ -4797,17 +4892,17 @@
               <a:buNone/>
             </a:pPr>
             <a:r>
-              <a:rPr lang="en-US" sz="1200" dirty="0">
+              <a:rPr lang="en-US" sz="1000" dirty="0">
                 <a:solidFill>
-                  <a:srgbClr val="1A1A2E"/>
+                  <a:srgbClr val="0D47A1"/>
                 </a:solidFill>
-                <a:latin typeface="Calibri" pitchFamily="34" charset="0"/>
-                <a:ea typeface="Calibri" pitchFamily="34" charset="-122"/>
-                <a:cs typeface="Calibri" pitchFamily="34" charset="-120"/>
+                <a:latin typeface="JetBrains Mono" pitchFamily="34" charset="0"/>
+                <a:ea typeface="JetBrains Mono" pitchFamily="34" charset="-122"/>
+                <a:cs typeface="JetBrains Mono" pitchFamily="34" charset="-120"/>
               </a:rPr>
-              <a:t>DÉFI : procédure avec gestion d'erreurs (DECLARE HANDLER)</a:t>
-            </a:r>
-            <a:endParaRPr lang="en-US" sz="1200" dirty="0"/>
+              <a:t>BEFORE/AFTER + INSERT/UPDATE/DELETE = 6 combinaisons</a:t>
+            </a:r>
+            <a:endParaRPr lang="en-US" sz="1000" dirty="0"/>
           </a:p>
         </p:txBody>
       </p:sp>
@@ -4822,6 +4917,650 @@
 <file path=ppt/slides/slide6.xml><?xml version="1.0" encoding="utf-8"?>
 <p:sld xmlns:a="http://schemas.openxmlformats.org/drawingml/2006/main" xmlns:r="http://schemas.openxmlformats.org/officeDocument/2006/relationships" xmlns:p="http://schemas.openxmlformats.org/presentationml/2006/main">
   <p:cSld name="Slide 6">
+    <p:bg>
+      <p:bgPr>
+        <a:solidFill>
+          <a:srgbClr val="F5F7FA"/>
+        </a:solidFill>
+      </p:bgPr>
+    </p:bg>
+    <p:spTree>
+      <p:nvGrpSpPr>
+        <p:cNvPr id="1" name=""/>
+        <p:cNvGrpSpPr/>
+        <p:nvPr/>
+      </p:nvGrpSpPr>
+      <p:grpSpPr>
+        <a:xfrm>
+          <a:off x="0" y="0"/>
+          <a:ext cx="0" cy="0"/>
+          <a:chOff x="0" y="0"/>
+          <a:chExt cx="0" cy="0"/>
+        </a:xfrm>
+      </p:grpSpPr>
+      <p:sp>
+        <p:nvSpPr>
+          <p:cNvPr id="2" name="Shape 0"/>
+          <p:cNvSpPr/>
+          <p:nvPr/>
+        </p:nvSpPr>
+        <p:spPr>
+          <a:xfrm>
+            <a:off x="0" y="0"/>
+            <a:ext cx="9144000" cy="54864"/>
+          </a:xfrm>
+          <a:prstGeom prst="rect">
+            <a:avLst/>
+          </a:prstGeom>
+          <a:solidFill>
+            <a:srgbClr val="1565C0"/>
+          </a:solidFill>
+          <a:ln/>
+        </p:spPr>
+      </p:sp>
+      <p:sp>
+        <p:nvSpPr>
+          <p:cNvPr id="3" name="Text 1"/>
+          <p:cNvSpPr/>
+          <p:nvPr/>
+        </p:nvSpPr>
+        <p:spPr>
+          <a:xfrm>
+            <a:off x="457200" y="182880"/>
+            <a:ext cx="8229600" cy="548640"/>
+          </a:xfrm>
+          <a:prstGeom prst="rect">
+            <a:avLst/>
+          </a:prstGeom>
+          <a:noFill/>
+          <a:ln/>
+        </p:spPr>
+        <p:txBody>
+          <a:bodyPr wrap="square" lIns="0" tIns="0" rIns="0" bIns="0" rtlCol="0" anchor="ctr"/>
+          <a:lstStyle/>
+          <a:p>
+            <a:pPr indent="0" marL="0">
+              <a:buNone/>
+            </a:pPr>
+            <a:r>
+              <a:rPr lang="en-US" sz="2200" b="1" dirty="0">
+                <a:solidFill>
+                  <a:srgbClr val="0D47A1"/>
+                </a:solidFill>
+                <a:latin typeface="Trebuchet MS" pitchFamily="34" charset="0"/>
+                <a:ea typeface="Trebuchet MS" pitchFamily="34" charset="-122"/>
+                <a:cs typeface="Trebuchet MS" pitchFamily="34" charset="-120"/>
+              </a:rPr>
+              <a:t>Exercice Module 15</a:t>
+            </a:r>
+            <a:endParaRPr lang="en-US" sz="2200" dirty="0"/>
+          </a:p>
+        </p:txBody>
+      </p:sp>
+      <p:sp>
+        <p:nvSpPr>
+          <p:cNvPr id="4" name="Shape 2"/>
+          <p:cNvSpPr/>
+          <p:nvPr/>
+        </p:nvSpPr>
+        <p:spPr>
+          <a:xfrm>
+            <a:off x="457200" y="868680"/>
+            <a:ext cx="8229600" cy="475488"/>
+          </a:xfrm>
+          <a:prstGeom prst="rect">
+            <a:avLst/>
+          </a:prstGeom>
+          <a:solidFill>
+            <a:srgbClr val="FFFFFF"/>
+          </a:solidFill>
+          <a:ln/>
+        </p:spPr>
+      </p:sp>
+      <p:sp>
+        <p:nvSpPr>
+          <p:cNvPr id="5" name="Shape 3"/>
+          <p:cNvSpPr/>
+          <p:nvPr/>
+        </p:nvSpPr>
+        <p:spPr>
+          <a:xfrm>
+            <a:off x="457200" y="868680"/>
+            <a:ext cx="45720" cy="475488"/>
+          </a:xfrm>
+          <a:prstGeom prst="rect">
+            <a:avLst/>
+          </a:prstGeom>
+          <a:solidFill>
+            <a:srgbClr val="1565C0"/>
+          </a:solidFill>
+          <a:ln/>
+        </p:spPr>
+      </p:sp>
+      <p:sp>
+        <p:nvSpPr>
+          <p:cNvPr id="6" name="Text 4"/>
+          <p:cNvSpPr/>
+          <p:nvPr/>
+        </p:nvSpPr>
+        <p:spPr>
+          <a:xfrm>
+            <a:off x="640080" y="868680"/>
+            <a:ext cx="7863840" cy="475488"/>
+          </a:xfrm>
+          <a:prstGeom prst="rect">
+            <a:avLst/>
+          </a:prstGeom>
+          <a:noFill/>
+          <a:ln/>
+        </p:spPr>
+        <p:txBody>
+          <a:bodyPr wrap="square" lIns="0" tIns="0" rIns="0" bIns="0" rtlCol="0" anchor="ctr"/>
+          <a:lstStyle/>
+          <a:p>
+            <a:pPr indent="0" marL="0">
+              <a:buNone/>
+            </a:pPr>
+            <a:r>
+              <a:rPr lang="en-US" sz="1100" dirty="0">
+                <a:solidFill>
+                  <a:srgbClr val="1A1A2E"/>
+                </a:solidFill>
+                <a:latin typeface="Calibri" pitchFamily="34" charset="0"/>
+                <a:ea typeface="Calibri" pitchFamily="34" charset="-122"/>
+                <a:cs typeface="Calibri" pitchFamily="34" charset="-120"/>
+              </a:rPr>
+              <a:t>1. Creer VIEW v_artistes_actifs (actif=TRUE avec genres)</a:t>
+            </a:r>
+            <a:endParaRPr lang="en-US" sz="1100" dirty="0"/>
+          </a:p>
+        </p:txBody>
+      </p:sp>
+      <p:sp>
+        <p:nvSpPr>
+          <p:cNvPr id="7" name="Shape 5"/>
+          <p:cNvSpPr/>
+          <p:nvPr/>
+        </p:nvSpPr>
+        <p:spPr>
+          <a:xfrm>
+            <a:off x="457200" y="1371600"/>
+            <a:ext cx="8229600" cy="475488"/>
+          </a:xfrm>
+          <a:prstGeom prst="rect">
+            <a:avLst/>
+          </a:prstGeom>
+          <a:solidFill>
+            <a:srgbClr val="E3F2FD"/>
+          </a:solidFill>
+          <a:ln/>
+        </p:spPr>
+      </p:sp>
+      <p:sp>
+        <p:nvSpPr>
+          <p:cNvPr id="8" name="Shape 6"/>
+          <p:cNvSpPr/>
+          <p:nvPr/>
+        </p:nvSpPr>
+        <p:spPr>
+          <a:xfrm>
+            <a:off x="457200" y="1371600"/>
+            <a:ext cx="45720" cy="475488"/>
+          </a:xfrm>
+          <a:prstGeom prst="rect">
+            <a:avLst/>
+          </a:prstGeom>
+          <a:solidFill>
+            <a:srgbClr val="1565C0"/>
+          </a:solidFill>
+          <a:ln/>
+        </p:spPr>
+      </p:sp>
+      <p:sp>
+        <p:nvSpPr>
+          <p:cNvPr id="9" name="Text 7"/>
+          <p:cNvSpPr/>
+          <p:nvPr/>
+        </p:nvSpPr>
+        <p:spPr>
+          <a:xfrm>
+            <a:off x="640080" y="1371600"/>
+            <a:ext cx="7863840" cy="475488"/>
+          </a:xfrm>
+          <a:prstGeom prst="rect">
+            <a:avLst/>
+          </a:prstGeom>
+          <a:noFill/>
+          <a:ln/>
+        </p:spPr>
+        <p:txBody>
+          <a:bodyPr wrap="square" lIns="0" tIns="0" rIns="0" bIns="0" rtlCol="0" anchor="ctr"/>
+          <a:lstStyle/>
+          <a:p>
+            <a:pPr indent="0" marL="0">
+              <a:buNone/>
+            </a:pPr>
+            <a:r>
+              <a:rPr lang="en-US" sz="1100" dirty="0">
+                <a:solidFill>
+                  <a:srgbClr val="1A1A2E"/>
+                </a:solidFill>
+                <a:latin typeface="Calibri" pitchFamily="34" charset="0"/>
+                <a:ea typeface="Calibri" pitchFamily="34" charset="-122"/>
+                <a:cs typeface="Calibri" pitchFamily="34" charset="-120"/>
+              </a:rPr>
+              <a:t>2. Creer VIEW v_sessions_mois (sessions du mois en cours)</a:t>
+            </a:r>
+            <a:endParaRPr lang="en-US" sz="1100" dirty="0"/>
+          </a:p>
+        </p:txBody>
+      </p:sp>
+      <p:sp>
+        <p:nvSpPr>
+          <p:cNvPr id="10" name="Shape 8"/>
+          <p:cNvSpPr/>
+          <p:nvPr/>
+        </p:nvSpPr>
+        <p:spPr>
+          <a:xfrm>
+            <a:off x="457200" y="1874520"/>
+            <a:ext cx="8229600" cy="475488"/>
+          </a:xfrm>
+          <a:prstGeom prst="rect">
+            <a:avLst/>
+          </a:prstGeom>
+          <a:solidFill>
+            <a:srgbClr val="FFFFFF"/>
+          </a:solidFill>
+          <a:ln/>
+        </p:spPr>
+      </p:sp>
+      <p:sp>
+        <p:nvSpPr>
+          <p:cNvPr id="11" name="Shape 9"/>
+          <p:cNvSpPr/>
+          <p:nvPr/>
+        </p:nvSpPr>
+        <p:spPr>
+          <a:xfrm>
+            <a:off x="457200" y="1874520"/>
+            <a:ext cx="45720" cy="475488"/>
+          </a:xfrm>
+          <a:prstGeom prst="rect">
+            <a:avLst/>
+          </a:prstGeom>
+          <a:solidFill>
+            <a:srgbClr val="1565C0"/>
+          </a:solidFill>
+          <a:ln/>
+        </p:spPr>
+      </p:sp>
+      <p:sp>
+        <p:nvSpPr>
+          <p:cNvPr id="12" name="Text 10"/>
+          <p:cNvSpPr/>
+          <p:nvPr/>
+        </p:nvSpPr>
+        <p:spPr>
+          <a:xfrm>
+            <a:off x="640080" y="1874520"/>
+            <a:ext cx="7863840" cy="475488"/>
+          </a:xfrm>
+          <a:prstGeom prst="rect">
+            <a:avLst/>
+          </a:prstGeom>
+          <a:noFill/>
+          <a:ln/>
+        </p:spPr>
+        <p:txBody>
+          <a:bodyPr wrap="square" lIns="0" tIns="0" rIns="0" bIns="0" rtlCol="0" anchor="ctr"/>
+          <a:lstStyle/>
+          <a:p>
+            <a:pPr indent="0" marL="0">
+              <a:buNone/>
+            </a:pPr>
+            <a:r>
+              <a:rPr lang="en-US" sz="1100" dirty="0">
+                <a:solidFill>
+                  <a:srgbClr val="1A1A2E"/>
+                </a:solidFill>
+                <a:latin typeface="Calibri" pitchFamily="34" charset="0"/>
+                <a:ea typeface="Calibri" pitchFamily="34" charset="-122"/>
+                <a:cs typeface="Calibri" pitchFamily="34" charset="-120"/>
+              </a:rPr>
+              <a:t>3. Creer VIEW v_dashboard_ca (CA par artiste)</a:t>
+            </a:r>
+            <a:endParaRPr lang="en-US" sz="1100" dirty="0"/>
+          </a:p>
+        </p:txBody>
+      </p:sp>
+      <p:sp>
+        <p:nvSpPr>
+          <p:cNvPr id="13" name="Shape 11"/>
+          <p:cNvSpPr/>
+          <p:nvPr/>
+        </p:nvSpPr>
+        <p:spPr>
+          <a:xfrm>
+            <a:off x="457200" y="2377440"/>
+            <a:ext cx="8229600" cy="475488"/>
+          </a:xfrm>
+          <a:prstGeom prst="rect">
+            <a:avLst/>
+          </a:prstGeom>
+          <a:solidFill>
+            <a:srgbClr val="E3F2FD"/>
+          </a:solidFill>
+          <a:ln/>
+        </p:spPr>
+      </p:sp>
+      <p:sp>
+        <p:nvSpPr>
+          <p:cNvPr id="14" name="Shape 12"/>
+          <p:cNvSpPr/>
+          <p:nvPr/>
+        </p:nvSpPr>
+        <p:spPr>
+          <a:xfrm>
+            <a:off x="457200" y="2377440"/>
+            <a:ext cx="45720" cy="475488"/>
+          </a:xfrm>
+          <a:prstGeom prst="rect">
+            <a:avLst/>
+          </a:prstGeom>
+          <a:solidFill>
+            <a:srgbClr val="1565C0"/>
+          </a:solidFill>
+          <a:ln/>
+        </p:spPr>
+      </p:sp>
+      <p:sp>
+        <p:nvSpPr>
+          <p:cNvPr id="15" name="Text 13"/>
+          <p:cNvSpPr/>
+          <p:nvPr/>
+        </p:nvSpPr>
+        <p:spPr>
+          <a:xfrm>
+            <a:off x="640080" y="2377440"/>
+            <a:ext cx="7863840" cy="475488"/>
+          </a:xfrm>
+          <a:prstGeom prst="rect">
+            <a:avLst/>
+          </a:prstGeom>
+          <a:noFill/>
+          <a:ln/>
+        </p:spPr>
+        <p:txBody>
+          <a:bodyPr wrap="square" lIns="0" tIns="0" rIns="0" bIns="0" rtlCol="0" anchor="ctr"/>
+          <a:lstStyle/>
+          <a:p>
+            <a:pPr indent="0" marL="0">
+              <a:buNone/>
+            </a:pPr>
+            <a:r>
+              <a:rPr lang="en-US" sz="1100" dirty="0">
+                <a:solidFill>
+                  <a:srgbClr val="1A1A2E"/>
+                </a:solidFill>
+                <a:latin typeface="Calibri" pitchFamily="34" charset="0"/>
+                <a:ea typeface="Calibri" pitchFamily="34" charset="-122"/>
+                <a:cs typeface="Calibri" pitchFamily="34" charset="-120"/>
+              </a:rPr>
+              <a:t>4. Creer PROCEDURE sp_ajouter_session avec verification disponibilite</a:t>
+            </a:r>
+            <a:endParaRPr lang="en-US" sz="1100" dirty="0"/>
+          </a:p>
+        </p:txBody>
+      </p:sp>
+      <p:sp>
+        <p:nvSpPr>
+          <p:cNvPr id="16" name="Shape 14"/>
+          <p:cNvSpPr/>
+          <p:nvPr/>
+        </p:nvSpPr>
+        <p:spPr>
+          <a:xfrm>
+            <a:off x="457200" y="2880360"/>
+            <a:ext cx="8229600" cy="475488"/>
+          </a:xfrm>
+          <a:prstGeom prst="rect">
+            <a:avLst/>
+          </a:prstGeom>
+          <a:solidFill>
+            <a:srgbClr val="FFFFFF"/>
+          </a:solidFill>
+          <a:ln/>
+        </p:spPr>
+      </p:sp>
+      <p:sp>
+        <p:nvSpPr>
+          <p:cNvPr id="17" name="Shape 15"/>
+          <p:cNvSpPr/>
+          <p:nvPr/>
+        </p:nvSpPr>
+        <p:spPr>
+          <a:xfrm>
+            <a:off x="457200" y="2880360"/>
+            <a:ext cx="45720" cy="475488"/>
+          </a:xfrm>
+          <a:prstGeom prst="rect">
+            <a:avLst/>
+          </a:prstGeom>
+          <a:solidFill>
+            <a:srgbClr val="1565C0"/>
+          </a:solidFill>
+          <a:ln/>
+        </p:spPr>
+      </p:sp>
+      <p:sp>
+        <p:nvSpPr>
+          <p:cNvPr id="18" name="Text 16"/>
+          <p:cNvSpPr/>
+          <p:nvPr/>
+        </p:nvSpPr>
+        <p:spPr>
+          <a:xfrm>
+            <a:off x="640080" y="2880360"/>
+            <a:ext cx="7863840" cy="475488"/>
+          </a:xfrm>
+          <a:prstGeom prst="rect">
+            <a:avLst/>
+          </a:prstGeom>
+          <a:noFill/>
+          <a:ln/>
+        </p:spPr>
+        <p:txBody>
+          <a:bodyPr wrap="square" lIns="0" tIns="0" rIns="0" bIns="0" rtlCol="0" anchor="ctr"/>
+          <a:lstStyle/>
+          <a:p>
+            <a:pPr indent="0" marL="0">
+              <a:buNone/>
+            </a:pPr>
+            <a:r>
+              <a:rPr lang="en-US" sz="1100" dirty="0">
+                <a:solidFill>
+                  <a:srgbClr val="1A1A2E"/>
+                </a:solidFill>
+                <a:latin typeface="Calibri" pitchFamily="34" charset="0"/>
+                <a:ea typeface="Calibri" pitchFamily="34" charset="-122"/>
+                <a:cs typeface="Calibri" pitchFamily="34" charset="-120"/>
+              </a:rPr>
+              <a:t>5. Creer FUNCTION fn_ca_artiste(id) qui retourne le CA paye</a:t>
+            </a:r>
+            <a:endParaRPr lang="en-US" sz="1100" dirty="0"/>
+          </a:p>
+        </p:txBody>
+      </p:sp>
+      <p:sp>
+        <p:nvSpPr>
+          <p:cNvPr id="19" name="Shape 17"/>
+          <p:cNvSpPr/>
+          <p:nvPr/>
+        </p:nvSpPr>
+        <p:spPr>
+          <a:xfrm>
+            <a:off x="457200" y="3383280"/>
+            <a:ext cx="8229600" cy="475488"/>
+          </a:xfrm>
+          <a:prstGeom prst="rect">
+            <a:avLst/>
+          </a:prstGeom>
+          <a:solidFill>
+            <a:srgbClr val="E3F2FD"/>
+          </a:solidFill>
+          <a:ln/>
+        </p:spPr>
+      </p:sp>
+      <p:sp>
+        <p:nvSpPr>
+          <p:cNvPr id="20" name="Shape 18"/>
+          <p:cNvSpPr/>
+          <p:nvPr/>
+        </p:nvSpPr>
+        <p:spPr>
+          <a:xfrm>
+            <a:off x="457200" y="3383280"/>
+            <a:ext cx="45720" cy="475488"/>
+          </a:xfrm>
+          <a:prstGeom prst="rect">
+            <a:avLst/>
+          </a:prstGeom>
+          <a:solidFill>
+            <a:srgbClr val="1565C0"/>
+          </a:solidFill>
+          <a:ln/>
+        </p:spPr>
+      </p:sp>
+      <p:sp>
+        <p:nvSpPr>
+          <p:cNvPr id="21" name="Text 19"/>
+          <p:cNvSpPr/>
+          <p:nvPr/>
+        </p:nvSpPr>
+        <p:spPr>
+          <a:xfrm>
+            <a:off x="640080" y="3383280"/>
+            <a:ext cx="7863840" cy="475488"/>
+          </a:xfrm>
+          <a:prstGeom prst="rect">
+            <a:avLst/>
+          </a:prstGeom>
+          <a:noFill/>
+          <a:ln/>
+        </p:spPr>
+        <p:txBody>
+          <a:bodyPr wrap="square" lIns="0" tIns="0" rIns="0" bIns="0" rtlCol="0" anchor="ctr"/>
+          <a:lstStyle/>
+          <a:p>
+            <a:pPr indent="0" marL="0">
+              <a:buNone/>
+            </a:pPr>
+            <a:r>
+              <a:rPr lang="en-US" sz="1100" dirty="0">
+                <a:solidFill>
+                  <a:srgbClr val="1A1A2E"/>
+                </a:solidFill>
+                <a:latin typeface="Calibri" pitchFamily="34" charset="0"/>
+                <a:ea typeface="Calibri" pitchFamily="34" charset="-122"/>
+                <a:cs typeface="Calibri" pitchFamily="34" charset="-120"/>
+              </a:rPr>
+              <a:t>6. Creer TRIGGER : mettre a jour statut session quand facture payee</a:t>
+            </a:r>
+            <a:endParaRPr lang="en-US" sz="1100" dirty="0"/>
+          </a:p>
+        </p:txBody>
+      </p:sp>
+      <p:sp>
+        <p:nvSpPr>
+          <p:cNvPr id="22" name="Shape 20"/>
+          <p:cNvSpPr/>
+          <p:nvPr/>
+        </p:nvSpPr>
+        <p:spPr>
+          <a:xfrm>
+            <a:off x="457200" y="3886200"/>
+            <a:ext cx="8229600" cy="475488"/>
+          </a:xfrm>
+          <a:prstGeom prst="rect">
+            <a:avLst/>
+          </a:prstGeom>
+          <a:solidFill>
+            <a:srgbClr val="FFFFFF"/>
+          </a:solidFill>
+          <a:ln/>
+        </p:spPr>
+      </p:sp>
+      <p:sp>
+        <p:nvSpPr>
+          <p:cNvPr id="23" name="Shape 21"/>
+          <p:cNvSpPr/>
+          <p:nvPr/>
+        </p:nvSpPr>
+        <p:spPr>
+          <a:xfrm>
+            <a:off x="457200" y="3886200"/>
+            <a:ext cx="45720" cy="475488"/>
+          </a:xfrm>
+          <a:prstGeom prst="rect">
+            <a:avLst/>
+          </a:prstGeom>
+          <a:solidFill>
+            <a:srgbClr val="1565C0"/>
+          </a:solidFill>
+          <a:ln/>
+        </p:spPr>
+      </p:sp>
+      <p:sp>
+        <p:nvSpPr>
+          <p:cNvPr id="24" name="Text 22"/>
+          <p:cNvSpPr/>
+          <p:nvPr/>
+        </p:nvSpPr>
+        <p:spPr>
+          <a:xfrm>
+            <a:off x="640080" y="3886200"/>
+            <a:ext cx="7863840" cy="475488"/>
+          </a:xfrm>
+          <a:prstGeom prst="rect">
+            <a:avLst/>
+          </a:prstGeom>
+          <a:noFill/>
+          <a:ln/>
+        </p:spPr>
+        <p:txBody>
+          <a:bodyPr wrap="square" lIns="0" tIns="0" rIns="0" bIns="0" rtlCol="0" anchor="ctr"/>
+          <a:lstStyle/>
+          <a:p>
+            <a:pPr indent="0" marL="0">
+              <a:buNone/>
+            </a:pPr>
+            <a:r>
+              <a:rPr lang="en-US" sz="1100" dirty="0">
+                <a:solidFill>
+                  <a:srgbClr val="1A1A2E"/>
+                </a:solidFill>
+                <a:latin typeface="Calibri" pitchFamily="34" charset="0"/>
+                <a:ea typeface="Calibri" pitchFamily="34" charset="-122"/>
+                <a:cs typeface="Calibri" pitchFamily="34" charset="-120"/>
+              </a:rPr>
+              <a:t>DEFI : procedure avec gestion d'erreurs DECLARE HANDLER</a:t>
+            </a:r>
+            <a:endParaRPr lang="en-US" sz="1100" dirty="0"/>
+          </a:p>
+        </p:txBody>
+      </p:sp>
+    </p:spTree>
+  </p:cSld>
+  <p:clrMapOvr>
+    <a:masterClrMapping/>
+  </p:clrMapOvr>
+</p:sld>
+</file>
+
+<file path=ppt/slides/slide7.xml><?xml version="1.0" encoding="utf-8"?>
+<p:sld xmlns:a="http://schemas.openxmlformats.org/drawingml/2006/main" xmlns:r="http://schemas.openxmlformats.org/officeDocument/2006/relationships" xmlns:p="http://schemas.openxmlformats.org/presentationml/2006/main">
+  <p:cSld name="Slide 7">
     <p:bg>
       <p:bgPr>
         <a:solidFill>
@@ -4851,8 +5590,8 @@
         </p:nvSpPr>
         <p:spPr>
           <a:xfrm>
-            <a:off x="3840480" y="457200"/>
-            <a:ext cx="1463040" cy="1097280"/>
+            <a:off x="457200" y="1828800"/>
+            <a:ext cx="8229600" cy="548640"/>
           </a:xfrm>
           <a:prstGeom prst="rect">
             <a:avLst/>
@@ -4868,43 +5607,7 @@
               <a:buNone/>
             </a:pPr>
             <a:r>
-              <a:rPr lang="en-US" sz="6000" dirty="0">
-                <a:solidFill>
-                  <a:srgbClr val="000000"/>
-                </a:solidFill>
-              </a:rPr>
-              <a:t>🎮</a:t>
-            </a:r>
-            <a:endParaRPr lang="en-US" sz="6000" dirty="0"/>
-          </a:p>
-        </p:txBody>
-      </p:sp>
-      <p:sp>
-        <p:nvSpPr>
-          <p:cNvPr id="3" name="Text 1"/>
-          <p:cNvSpPr/>
-          <p:nvPr/>
-        </p:nvSpPr>
-        <p:spPr>
-          <a:xfrm>
-            <a:off x="457200" y="1645920"/>
-            <a:ext cx="8229600" cy="548640"/>
-          </a:xfrm>
-          <a:prstGeom prst="rect">
-            <a:avLst/>
-          </a:prstGeom>
-          <a:noFill/>
-          <a:ln/>
-        </p:spPr>
-        <p:txBody>
-          <a:bodyPr wrap="square" lIns="0" tIns="0" rIns="0" bIns="0" rtlCol="0" anchor="ctr"/>
-          <a:lstStyle/>
-          <a:p>
-            <a:pPr algn="ctr" indent="0" marL="0">
-              <a:buNone/>
-            </a:pPr>
-            <a:r>
-              <a:rPr lang="en-US" sz="2600" b="1" dirty="0">
+              <a:rPr lang="en-US" sz="2400" b="1" dirty="0">
                 <a:solidFill>
                   <a:srgbClr val="FFFFFF"/>
                 </a:solidFill>
@@ -4914,20 +5617,20 @@
               </a:rPr>
               <a:t>Mini-jeu : Le Masque de la Vue</a:t>
             </a:r>
-            <a:endParaRPr lang="en-US" sz="2600" dirty="0"/>
-          </a:p>
-        </p:txBody>
-      </p:sp>
-      <p:sp>
-        <p:nvSpPr>
-          <p:cNvPr id="4" name="Text 2"/>
-          <p:cNvSpPr/>
-          <p:nvPr/>
-        </p:nvSpPr>
-        <p:spPr>
-          <a:xfrm>
-            <a:off x="1371600" y="2286000"/>
-            <a:ext cx="6400800" cy="731520"/>
+            <a:endParaRPr lang="en-US" sz="2400" dirty="0"/>
+          </a:p>
+        </p:txBody>
+      </p:sp>
+      <p:sp>
+        <p:nvSpPr>
+          <p:cNvPr id="3" name="Text 1"/>
+          <p:cNvSpPr/>
+          <p:nvPr/>
+        </p:nvSpPr>
+        <p:spPr>
+          <a:xfrm>
+            <a:off x="1371600" y="2468880"/>
+            <a:ext cx="6400800" cy="640080"/>
           </a:xfrm>
           <a:prstGeom prst="rect">
             <a:avLst/>
@@ -4943,7 +5646,7 @@
               <a:buNone/>
             </a:pPr>
             <a:r>
-              <a:rPr lang="en-US" sz="1400" dirty="0">
+              <a:rPr lang="en-US" sz="1300" dirty="0">
                 <a:solidFill>
                   <a:srgbClr val="CCCCCC"/>
                 </a:solidFill>
@@ -4951,68 +5654,9 @@
                 <a:ea typeface="Calibri" pitchFamily="34" charset="-122"/>
                 <a:cs typeface="Calibri" pitchFamily="34" charset="-120"/>
               </a:rPr>
-              <a:t>Placez les bons masques pour filtrer les données !</a:t>
-            </a:r>
-            <a:endParaRPr lang="en-US" sz="1400" dirty="0"/>
-          </a:p>
-        </p:txBody>
-      </p:sp>
-      <p:sp>
-        <p:nvSpPr>
-          <p:cNvPr id="5" name="Shape 3"/>
-          <p:cNvSpPr/>
-          <p:nvPr/>
-        </p:nvSpPr>
-        <p:spPr>
-          <a:xfrm>
-            <a:off x="2286000" y="3291840"/>
-            <a:ext cx="4572000" cy="548640"/>
-          </a:xfrm>
-          <a:prstGeom prst="rect">
-            <a:avLst/>
-          </a:prstGeom>
-          <a:solidFill>
-            <a:srgbClr val="FF6F00"/>
-          </a:solidFill>
-          <a:ln/>
-        </p:spPr>
-      </p:sp>
-      <p:sp>
-        <p:nvSpPr>
-          <p:cNvPr id="6" name="Text 4"/>
-          <p:cNvSpPr/>
-          <p:nvPr/>
-        </p:nvSpPr>
-        <p:spPr>
-          <a:xfrm>
-            <a:off x="2286000" y="3291840"/>
-            <a:ext cx="4572000" cy="548640"/>
-          </a:xfrm>
-          <a:prstGeom prst="rect">
-            <a:avLst/>
-          </a:prstGeom>
-          <a:noFill/>
-          <a:ln/>
-        </p:spPr>
-        <p:txBody>
-          <a:bodyPr wrap="square" lIns="0" tIns="0" rIns="0" bIns="0" rtlCol="0" anchor="ctr"/>
-          <a:lstStyle/>
-          <a:p>
-            <a:pPr algn="ctr" indent="0" marL="0">
-              <a:buNone/>
-            </a:pPr>
-            <a:r>
-              <a:rPr lang="en-US" sz="1800" b="1" dirty="0">
-                <a:solidFill>
-                  <a:srgbClr val="FFFFFF"/>
-                </a:solidFill>
-                <a:latin typeface="Trebuchet MS" pitchFamily="34" charset="0"/>
-                <a:ea typeface="Trebuchet MS" pitchFamily="34" charset="-122"/>
-                <a:cs typeface="Trebuchet MS" pitchFamily="34" charset="-120"/>
-              </a:rPr>
-              <a:t>▶  Lancer le jeu</a:t>
-            </a:r>
-            <a:endParaRPr lang="en-US" sz="1800" dirty="0"/>
+              <a:t>Creez les bons masques pour filtrer les donnees</a:t>
+            </a:r>
+            <a:endParaRPr lang="en-US" sz="1300" dirty="0"/>
           </a:p>
         </p:txBody>
       </p:sp>
@@ -5024,9 +5668,9 @@
 </p:sld>
 </file>
 
-<file path=ppt/slides/slide7.xml><?xml version="1.0" encoding="utf-8"?>
+<file path=ppt/slides/slide8.xml><?xml version="1.0" encoding="utf-8"?>
 <p:sld xmlns:a="http://schemas.openxmlformats.org/drawingml/2006/main" xmlns:r="http://schemas.openxmlformats.org/officeDocument/2006/relationships" xmlns:p="http://schemas.openxmlformats.org/presentationml/2006/main">
-  <p:cSld name="Slide 7">
+  <p:cSld name="Slide 8">
     <p:bg>
       <p:bgPr>
         <a:solidFill>
@@ -5057,7 +5701,7 @@
         <p:spPr>
           <a:xfrm>
             <a:off x="457200" y="137160"/>
-            <a:ext cx="5486400" cy="411480"/>
+            <a:ext cx="5486400" cy="365760"/>
           </a:xfrm>
           <a:prstGeom prst="rect">
             <a:avLst/>
@@ -5073,7 +5717,7 @@
               <a:buNone/>
             </a:pPr>
             <a:r>
-              <a:rPr lang="en-US" sz="1800" b="1" dirty="0">
+              <a:rPr lang="en-US" sz="1600" b="1" dirty="0">
                 <a:solidFill>
                   <a:srgbClr val="0D47A1"/>
                 </a:solidFill>
@@ -5081,9 +5725,9 @@
                 <a:ea typeface="Trebuchet MS" pitchFamily="34" charset="-122"/>
                 <a:cs typeface="Trebuchet MS" pitchFamily="34" charset="-120"/>
               </a:rPr>
-              <a:t>📋 Mémo Module 15</a:t>
-            </a:r>
-            <a:endParaRPr lang="en-US" sz="1800" dirty="0"/>
+              <a:t>Memo Module 15</a:t>
+            </a:r>
+            <a:endParaRPr lang="en-US" sz="1600" dirty="0"/>
           </a:p>
         </p:txBody>
       </p:sp>
@@ -5095,14 +5739,14 @@
         </p:nvSpPr>
         <p:spPr>
           <a:xfrm>
-            <a:off x="457200" y="548640"/>
-            <a:ext cx="8229600" cy="274320"/>
-          </a:xfrm>
-          <a:prstGeom prst="rect">
-            <a:avLst/>
-          </a:prstGeom>
-          <a:solidFill>
-            <a:srgbClr val="FFF3E0"/>
+            <a:off x="457200" y="640080"/>
+            <a:ext cx="2286000" cy="429768"/>
+          </a:xfrm>
+          <a:prstGeom prst="rect">
+            <a:avLst/>
+          </a:prstGeom>
+          <a:solidFill>
+            <a:srgbClr val="E3F2FD"/>
           </a:solidFill>
           <a:ln/>
         </p:spPr>
@@ -5115,67 +5759,8 @@
         </p:nvSpPr>
         <p:spPr>
           <a:xfrm>
-            <a:off x="640080" y="548640"/>
-            <a:ext cx="7772400" cy="274320"/>
-          </a:xfrm>
-          <a:prstGeom prst="rect">
-            <a:avLst/>
-          </a:prstGeom>
-          <a:noFill/>
-          <a:ln/>
-        </p:spPr>
-        <p:txBody>
-          <a:bodyPr wrap="square" lIns="0" tIns="0" rIns="0" bIns="0" rtlCol="0" anchor="ctr"/>
-          <a:lstStyle/>
-          <a:p>
-            <a:pPr indent="0" marL="0">
-              <a:buNone/>
-            </a:pPr>
-            <a:r>
-              <a:rPr lang="en-US" sz="900" b="1" dirty="0">
-                <a:solidFill>
-                  <a:srgbClr val="E65100"/>
-                </a:solidFill>
-                <a:latin typeface="Calibri" pitchFamily="34" charset="0"/>
-                <a:ea typeface="Calibri" pitchFamily="34" charset="-122"/>
-                <a:cs typeface="Calibri" pitchFamily="34" charset="-120"/>
-              </a:rPr>
-              <a:t>🔒 Déblocable après complétion</a:t>
-            </a:r>
-            <a:endParaRPr lang="en-US" sz="900" dirty="0"/>
-          </a:p>
-        </p:txBody>
-      </p:sp>
-      <p:sp>
-        <p:nvSpPr>
-          <p:cNvPr id="5" name="Shape 3"/>
-          <p:cNvSpPr/>
-          <p:nvPr/>
-        </p:nvSpPr>
-        <p:spPr>
-          <a:xfrm>
-            <a:off x="457200" y="960120"/>
-            <a:ext cx="2286000" cy="475488"/>
-          </a:xfrm>
-          <a:prstGeom prst="rect">
-            <a:avLst/>
-          </a:prstGeom>
-          <a:solidFill>
-            <a:srgbClr val="E3F2FD"/>
-          </a:solidFill>
-          <a:ln/>
-        </p:spPr>
-      </p:sp>
-      <p:sp>
-        <p:nvSpPr>
-          <p:cNvPr id="6" name="Text 4"/>
-          <p:cNvSpPr/>
-          <p:nvPr/>
-        </p:nvSpPr>
-        <p:spPr>
-          <a:xfrm>
-            <a:off x="548640" y="960120"/>
-            <a:ext cx="2103120" cy="475488"/>
+            <a:off x="548640" y="640080"/>
+            <a:ext cx="2103120" cy="429768"/>
           </a:xfrm>
           <a:prstGeom prst="rect">
             <a:avLst/>
@@ -5207,14 +5792,14 @@
       </p:sp>
       <p:sp>
         <p:nvSpPr>
-          <p:cNvPr id="7" name="Shape 5"/>
-          <p:cNvSpPr/>
-          <p:nvPr/>
-        </p:nvSpPr>
-        <p:spPr>
-          <a:xfrm>
-            <a:off x="2743200" y="960120"/>
-            <a:ext cx="5943600" cy="475488"/>
+          <p:cNvPr id="5" name="Shape 3"/>
+          <p:cNvSpPr/>
+          <p:nvPr/>
+        </p:nvSpPr>
+        <p:spPr>
+          <a:xfrm>
+            <a:off x="2743200" y="640080"/>
+            <a:ext cx="5943600" cy="429768"/>
           </a:xfrm>
           <a:prstGeom prst="rect">
             <a:avLst/>
@@ -5227,14 +5812,14 @@
       </p:sp>
       <p:sp>
         <p:nvSpPr>
-          <p:cNvPr id="8" name="Text 6"/>
-          <p:cNvSpPr/>
-          <p:nvPr/>
-        </p:nvSpPr>
-        <p:spPr>
-          <a:xfrm>
-            <a:off x="2834640" y="960120"/>
-            <a:ext cx="5760720" cy="475488"/>
+          <p:cNvPr id="6" name="Text 4"/>
+          <p:cNvSpPr/>
+          <p:nvPr/>
+        </p:nvSpPr>
+        <p:spPr>
+          <a:xfrm>
+            <a:off x="2834640" y="640080"/>
+            <a:ext cx="5760720" cy="429768"/>
           </a:xfrm>
           <a:prstGeom prst="rect">
             <a:avLst/>
@@ -5258,7 +5843,7 @@
                 <a:ea typeface="Calibri" pitchFamily="34" charset="-122"/>
                 <a:cs typeface="Calibri" pitchFamily="34" charset="-120"/>
               </a:rPr>
-              <a:t>Requête sauvegardée = table virtuelle, pas de stockage</a:t>
+              <a:t>Requete sauvegardee, pas de stockage physique</a:t>
             </a:r>
             <a:endParaRPr lang="en-US" sz="900" dirty="0"/>
           </a:p>
@@ -5266,14 +5851,14 @@
       </p:sp>
       <p:sp>
         <p:nvSpPr>
-          <p:cNvPr id="9" name="Shape 7"/>
-          <p:cNvSpPr/>
-          <p:nvPr/>
-        </p:nvSpPr>
-        <p:spPr>
-          <a:xfrm>
-            <a:off x="457200" y="1463040"/>
-            <a:ext cx="2286000" cy="475488"/>
+          <p:cNvPr id="7" name="Shape 5"/>
+          <p:cNvSpPr/>
+          <p:nvPr/>
+        </p:nvSpPr>
+        <p:spPr>
+          <a:xfrm>
+            <a:off x="457200" y="1097280"/>
+            <a:ext cx="2286000" cy="429768"/>
           </a:xfrm>
           <a:prstGeom prst="rect">
             <a:avLst/>
@@ -5286,14 +5871,14 @@
       </p:sp>
       <p:sp>
         <p:nvSpPr>
-          <p:cNvPr id="10" name="Text 8"/>
-          <p:cNvSpPr/>
-          <p:nvPr/>
-        </p:nvSpPr>
-        <p:spPr>
-          <a:xfrm>
-            <a:off x="548640" y="1463040"/>
-            <a:ext cx="2103120" cy="475488"/>
+          <p:cNvPr id="8" name="Text 6"/>
+          <p:cNvSpPr/>
+          <p:nvPr/>
+        </p:nvSpPr>
+        <p:spPr>
+          <a:xfrm>
+            <a:off x="548640" y="1097280"/>
+            <a:ext cx="2103120" cy="429768"/>
           </a:xfrm>
           <a:prstGeom prst="rect">
             <a:avLst/>
@@ -5325,14 +5910,14 @@
       </p:sp>
       <p:sp>
         <p:nvSpPr>
-          <p:cNvPr id="11" name="Shape 9"/>
-          <p:cNvSpPr/>
-          <p:nvPr/>
-        </p:nvSpPr>
-        <p:spPr>
-          <a:xfrm>
-            <a:off x="2743200" y="1463040"/>
-            <a:ext cx="5943600" cy="475488"/>
+          <p:cNvPr id="9" name="Shape 7"/>
+          <p:cNvSpPr/>
+          <p:nvPr/>
+        </p:nvSpPr>
+        <p:spPr>
+          <a:xfrm>
+            <a:off x="2743200" y="1097280"/>
+            <a:ext cx="5943600" cy="429768"/>
           </a:xfrm>
           <a:prstGeom prst="rect">
             <a:avLst/>
@@ -5345,14 +5930,14 @@
       </p:sp>
       <p:sp>
         <p:nvSpPr>
-          <p:cNvPr id="12" name="Text 10"/>
-          <p:cNvSpPr/>
-          <p:nvPr/>
-        </p:nvSpPr>
-        <p:spPr>
-          <a:xfrm>
-            <a:off x="2834640" y="1463040"/>
-            <a:ext cx="5760720" cy="475488"/>
+          <p:cNvPr id="10" name="Text 8"/>
+          <p:cNvSpPr/>
+          <p:nvPr/>
+        </p:nvSpPr>
+        <p:spPr>
+          <a:xfrm>
+            <a:off x="2834640" y="1097280"/>
+            <a:ext cx="5760720" cy="429768"/>
           </a:xfrm>
           <a:prstGeom prst="rect">
             <a:avLst/>
@@ -5376,7 +5961,7 @@
                 <a:ea typeface="Calibri" pitchFamily="34" charset="-122"/>
                 <a:cs typeface="Calibri" pitchFamily="34" charset="-120"/>
               </a:rPr>
-              <a:t>Bloc de code avec paramètres IN/OUT, CALL pour exécuter</a:t>
+              <a:t>CALL, IN/OUT, DELIMITER //</a:t>
             </a:r>
             <a:endParaRPr lang="en-US" sz="900" dirty="0"/>
           </a:p>
@@ -5384,14 +5969,14 @@
       </p:sp>
       <p:sp>
         <p:nvSpPr>
-          <p:cNvPr id="13" name="Shape 11"/>
-          <p:cNvSpPr/>
-          <p:nvPr/>
-        </p:nvSpPr>
-        <p:spPr>
-          <a:xfrm>
-            <a:off x="457200" y="1965960"/>
-            <a:ext cx="2286000" cy="475488"/>
+          <p:cNvPr id="11" name="Shape 9"/>
+          <p:cNvSpPr/>
+          <p:nvPr/>
+        </p:nvSpPr>
+        <p:spPr>
+          <a:xfrm>
+            <a:off x="457200" y="1554480"/>
+            <a:ext cx="2286000" cy="429768"/>
           </a:xfrm>
           <a:prstGeom prst="rect">
             <a:avLst/>
@@ -5404,14 +5989,14 @@
       </p:sp>
       <p:sp>
         <p:nvSpPr>
-          <p:cNvPr id="14" name="Text 12"/>
-          <p:cNvSpPr/>
-          <p:nvPr/>
-        </p:nvSpPr>
-        <p:spPr>
-          <a:xfrm>
-            <a:off x="548640" y="1965960"/>
-            <a:ext cx="2103120" cy="475488"/>
+          <p:cNvPr id="12" name="Text 10"/>
+          <p:cNvSpPr/>
+          <p:nvPr/>
+        </p:nvSpPr>
+        <p:spPr>
+          <a:xfrm>
+            <a:off x="548640" y="1554480"/>
+            <a:ext cx="2103120" cy="429768"/>
           </a:xfrm>
           <a:prstGeom prst="rect">
             <a:avLst/>
@@ -5443,14 +6028,14 @@
       </p:sp>
       <p:sp>
         <p:nvSpPr>
-          <p:cNvPr id="15" name="Shape 13"/>
-          <p:cNvSpPr/>
-          <p:nvPr/>
-        </p:nvSpPr>
-        <p:spPr>
-          <a:xfrm>
-            <a:off x="2743200" y="1965960"/>
-            <a:ext cx="5943600" cy="475488"/>
+          <p:cNvPr id="13" name="Shape 11"/>
+          <p:cNvSpPr/>
+          <p:nvPr/>
+        </p:nvSpPr>
+        <p:spPr>
+          <a:xfrm>
+            <a:off x="2743200" y="1554480"/>
+            <a:ext cx="5943600" cy="429768"/>
           </a:xfrm>
           <a:prstGeom prst="rect">
             <a:avLst/>
@@ -5463,14 +6048,14 @@
       </p:sp>
       <p:sp>
         <p:nvSpPr>
-          <p:cNvPr id="16" name="Text 14"/>
-          <p:cNvSpPr/>
-          <p:nvPr/>
-        </p:nvSpPr>
-        <p:spPr>
-          <a:xfrm>
-            <a:off x="2834640" y="1965960"/>
-            <a:ext cx="5760720" cy="475488"/>
+          <p:cNvPr id="14" name="Text 12"/>
+          <p:cNvSpPr/>
+          <p:nvPr/>
+        </p:nvSpPr>
+        <p:spPr>
+          <a:xfrm>
+            <a:off x="2834640" y="1554480"/>
+            <a:ext cx="5760720" cy="429768"/>
           </a:xfrm>
           <a:prstGeom prst="rect">
             <a:avLst/>
@@ -5494,7 +6079,7 @@
                 <a:ea typeface="Calibri" pitchFamily="34" charset="-122"/>
                 <a:cs typeface="Calibri" pitchFamily="34" charset="-120"/>
               </a:rPr>
-              <a:t>Retourne une valeur, utilisable dans SELECT</a:t>
+              <a:t>RETURNS, utilisable dans SELECT</a:t>
             </a:r>
             <a:endParaRPr lang="en-US" sz="900" dirty="0"/>
           </a:p>
@@ -5502,14 +6087,14 @@
       </p:sp>
       <p:sp>
         <p:nvSpPr>
-          <p:cNvPr id="17" name="Shape 15"/>
-          <p:cNvSpPr/>
-          <p:nvPr/>
-        </p:nvSpPr>
-        <p:spPr>
-          <a:xfrm>
-            <a:off x="457200" y="2468880"/>
-            <a:ext cx="2286000" cy="475488"/>
+          <p:cNvPr id="15" name="Shape 13"/>
+          <p:cNvSpPr/>
+          <p:nvPr/>
+        </p:nvSpPr>
+        <p:spPr>
+          <a:xfrm>
+            <a:off x="457200" y="2011680"/>
+            <a:ext cx="2286000" cy="429768"/>
           </a:xfrm>
           <a:prstGeom prst="rect">
             <a:avLst/>
@@ -5522,14 +6107,14 @@
       </p:sp>
       <p:sp>
         <p:nvSpPr>
-          <p:cNvPr id="18" name="Text 16"/>
-          <p:cNvSpPr/>
-          <p:nvPr/>
-        </p:nvSpPr>
-        <p:spPr>
-          <a:xfrm>
-            <a:off x="548640" y="2468880"/>
-            <a:ext cx="2103120" cy="475488"/>
+          <p:cNvPr id="16" name="Text 14"/>
+          <p:cNvSpPr/>
+          <p:nvPr/>
+        </p:nvSpPr>
+        <p:spPr>
+          <a:xfrm>
+            <a:off x="548640" y="2011680"/>
+            <a:ext cx="2103120" cy="429768"/>
           </a:xfrm>
           <a:prstGeom prst="rect">
             <a:avLst/>
@@ -5561,14 +6146,14 @@
       </p:sp>
       <p:sp>
         <p:nvSpPr>
-          <p:cNvPr id="19" name="Shape 17"/>
-          <p:cNvSpPr/>
-          <p:nvPr/>
-        </p:nvSpPr>
-        <p:spPr>
-          <a:xfrm>
-            <a:off x="2743200" y="2468880"/>
-            <a:ext cx="5943600" cy="475488"/>
+          <p:cNvPr id="17" name="Shape 15"/>
+          <p:cNvSpPr/>
+          <p:nvPr/>
+        </p:nvSpPr>
+        <p:spPr>
+          <a:xfrm>
+            <a:off x="2743200" y="2011680"/>
+            <a:ext cx="5943600" cy="429768"/>
           </a:xfrm>
           <a:prstGeom prst="rect">
             <a:avLst/>
@@ -5581,14 +6166,14 @@
       </p:sp>
       <p:sp>
         <p:nvSpPr>
-          <p:cNvPr id="20" name="Text 18"/>
-          <p:cNvSpPr/>
-          <p:nvPr/>
-        </p:nvSpPr>
-        <p:spPr>
-          <a:xfrm>
-            <a:off x="2834640" y="2468880"/>
-            <a:ext cx="5760720" cy="475488"/>
+          <p:cNvPr id="18" name="Text 16"/>
+          <p:cNvSpPr/>
+          <p:nvPr/>
+        </p:nvSpPr>
+        <p:spPr>
+          <a:xfrm>
+            <a:off x="2834640" y="2011680"/>
+            <a:ext cx="5760720" cy="429768"/>
           </a:xfrm>
           <a:prstGeom prst="rect">
             <a:avLst/>
@@ -5612,7 +6197,7 @@
                 <a:ea typeface="Calibri" pitchFamily="34" charset="-122"/>
                 <a:cs typeface="Calibri" pitchFamily="34" charset="-120"/>
               </a:rPr>
-              <a:t>Automatique : BEFORE/AFTER + INSERT/UPDATE/DELETE</a:t>
+              <a:t>BEFORE/AFTER + INSERT/UPDATE/DELETE, automatique</a:t>
             </a:r>
             <a:endParaRPr lang="en-US" sz="900" dirty="0"/>
           </a:p>
@@ -5620,14 +6205,14 @@
       </p:sp>
       <p:sp>
         <p:nvSpPr>
-          <p:cNvPr id="21" name="Shape 19"/>
-          <p:cNvSpPr/>
-          <p:nvPr/>
-        </p:nvSpPr>
-        <p:spPr>
-          <a:xfrm>
-            <a:off x="457200" y="2971800"/>
-            <a:ext cx="2286000" cy="475488"/>
+          <p:cNvPr id="19" name="Shape 17"/>
+          <p:cNvSpPr/>
+          <p:nvPr/>
+        </p:nvSpPr>
+        <p:spPr>
+          <a:xfrm>
+            <a:off x="457200" y="2468880"/>
+            <a:ext cx="2286000" cy="429768"/>
           </a:xfrm>
           <a:prstGeom prst="rect">
             <a:avLst/>
@@ -5640,14 +6225,14 @@
       </p:sp>
       <p:sp>
         <p:nvSpPr>
-          <p:cNvPr id="22" name="Text 20"/>
-          <p:cNvSpPr/>
-          <p:nvPr/>
-        </p:nvSpPr>
-        <p:spPr>
-          <a:xfrm>
-            <a:off x="548640" y="2971800"/>
-            <a:ext cx="2103120" cy="475488"/>
+          <p:cNvPr id="20" name="Text 18"/>
+          <p:cNvSpPr/>
+          <p:nvPr/>
+        </p:nvSpPr>
+        <p:spPr>
+          <a:xfrm>
+            <a:off x="548640" y="2468880"/>
+            <a:ext cx="2103120" cy="429768"/>
           </a:xfrm>
           <a:prstGeom prst="rect">
             <a:avLst/>
@@ -5679,14 +6264,14 @@
       </p:sp>
       <p:sp>
         <p:nvSpPr>
-          <p:cNvPr id="23" name="Shape 21"/>
-          <p:cNvSpPr/>
-          <p:nvPr/>
-        </p:nvSpPr>
-        <p:spPr>
-          <a:xfrm>
-            <a:off x="2743200" y="2971800"/>
-            <a:ext cx="5943600" cy="475488"/>
+          <p:cNvPr id="21" name="Shape 19"/>
+          <p:cNvSpPr/>
+          <p:nvPr/>
+        </p:nvSpPr>
+        <p:spPr>
+          <a:xfrm>
+            <a:off x="2743200" y="2468880"/>
+            <a:ext cx="5943600" cy="429768"/>
           </a:xfrm>
           <a:prstGeom prst="rect">
             <a:avLst/>
@@ -5699,14 +6284,14 @@
       </p:sp>
       <p:sp>
         <p:nvSpPr>
-          <p:cNvPr id="24" name="Text 22"/>
-          <p:cNvSpPr/>
-          <p:nvPr/>
-        </p:nvSpPr>
-        <p:spPr>
-          <a:xfrm>
-            <a:off x="2834640" y="2971800"/>
-            <a:ext cx="5760720" cy="475488"/>
+          <p:cNvPr id="22" name="Text 20"/>
+          <p:cNvSpPr/>
+          <p:nvPr/>
+        </p:nvSpPr>
+        <p:spPr>
+          <a:xfrm>
+            <a:off x="2834640" y="2468880"/>
+            <a:ext cx="5760720" cy="429768"/>
           </a:xfrm>
           <a:prstGeom prst="rect">
             <a:avLst/>
@@ -5730,125 +6315,7 @@
                 <a:ea typeface="Calibri" pitchFamily="34" charset="-122"/>
                 <a:cs typeface="Calibri" pitchFamily="34" charset="-120"/>
               </a:rPr>
-              <a:t>Changer le séparateur pour écrire des ; dans le code</a:t>
-            </a:r>
-            <a:endParaRPr lang="en-US" sz="900" dirty="0"/>
-          </a:p>
-        </p:txBody>
-      </p:sp>
-      <p:sp>
-        <p:nvSpPr>
-          <p:cNvPr id="25" name="Shape 23"/>
-          <p:cNvSpPr/>
-          <p:nvPr/>
-        </p:nvSpPr>
-        <p:spPr>
-          <a:xfrm>
-            <a:off x="457200" y="3474720"/>
-            <a:ext cx="2286000" cy="475488"/>
-          </a:xfrm>
-          <a:prstGeom prst="rect">
-            <a:avLst/>
-          </a:prstGeom>
-          <a:solidFill>
-            <a:srgbClr val="F0F0F0"/>
-          </a:solidFill>
-          <a:ln/>
-        </p:spPr>
-      </p:sp>
-      <p:sp>
-        <p:nvSpPr>
-          <p:cNvPr id="26" name="Text 24"/>
-          <p:cNvSpPr/>
-          <p:nvPr/>
-        </p:nvSpPr>
-        <p:spPr>
-          <a:xfrm>
-            <a:off x="548640" y="3474720"/>
-            <a:ext cx="2103120" cy="475488"/>
-          </a:xfrm>
-          <a:prstGeom prst="rect">
-            <a:avLst/>
-          </a:prstGeom>
-          <a:noFill/>
-          <a:ln/>
-        </p:spPr>
-        <p:txBody>
-          <a:bodyPr wrap="square" lIns="0" tIns="0" rIns="0" bIns="0" rtlCol="0" anchor="ctr"/>
-          <a:lstStyle/>
-          <a:p>
-            <a:pPr indent="0" marL="0">
-              <a:buNone/>
-            </a:pPr>
-            <a:r>
-              <a:rPr lang="en-US" sz="900" b="1" dirty="0">
-                <a:solidFill>
-                  <a:srgbClr val="0D47A1"/>
-                </a:solidFill>
-                <a:latin typeface="Trebuchet MS" pitchFamily="34" charset="0"/>
-                <a:ea typeface="Trebuchet MS" pitchFamily="34" charset="-122"/>
-                <a:cs typeface="Trebuchet MS" pitchFamily="34" charset="-120"/>
-              </a:rPr>
-              <a:t>Sécurité vue</a:t>
-            </a:r>
-            <a:endParaRPr lang="en-US" sz="900" dirty="0"/>
-          </a:p>
-        </p:txBody>
-      </p:sp>
-      <p:sp>
-        <p:nvSpPr>
-          <p:cNvPr id="27" name="Shape 25"/>
-          <p:cNvSpPr/>
-          <p:nvPr/>
-        </p:nvSpPr>
-        <p:spPr>
-          <a:xfrm>
-            <a:off x="2743200" y="3474720"/>
-            <a:ext cx="5943600" cy="475488"/>
-          </a:xfrm>
-          <a:prstGeom prst="rect">
-            <a:avLst/>
-          </a:prstGeom>
-          <a:solidFill>
-            <a:srgbClr val="F0F0F0"/>
-          </a:solidFill>
-          <a:ln/>
-        </p:spPr>
-      </p:sp>
-      <p:sp>
-        <p:nvSpPr>
-          <p:cNvPr id="28" name="Text 26"/>
-          <p:cNvSpPr/>
-          <p:nvPr/>
-        </p:nvSpPr>
-        <p:spPr>
-          <a:xfrm>
-            <a:off x="2834640" y="3474720"/>
-            <a:ext cx="5760720" cy="475488"/>
-          </a:xfrm>
-          <a:prstGeom prst="rect">
-            <a:avLst/>
-          </a:prstGeom>
-          <a:noFill/>
-          <a:ln/>
-        </p:spPr>
-        <p:txBody>
-          <a:bodyPr wrap="square" lIns="0" tIns="0" rIns="0" bIns="0" rtlCol="0" anchor="ctr"/>
-          <a:lstStyle/>
-          <a:p>
-            <a:pPr indent="0" marL="0">
-              <a:buNone/>
-            </a:pPr>
-            <a:r>
-              <a:rPr lang="en-US" sz="900" dirty="0">
-                <a:solidFill>
-                  <a:srgbClr val="333333"/>
-                </a:solidFill>
-                <a:latin typeface="Calibri" pitchFamily="34" charset="0"/>
-                <a:ea typeface="Calibri" pitchFamily="34" charset="-122"/>
-                <a:cs typeface="Calibri" pitchFamily="34" charset="-120"/>
-              </a:rPr>
-              <a:t>Donner accès à la vue, pas à la table source</a:t>
+              <a:t>Changer separateur pour ecrire des ; dans le code</a:t>
             </a:r>
             <a:endParaRPr lang="en-US" sz="900" dirty="0"/>
           </a:p>

</xml_diff>